<commit_message>
Make AI reflection slide specific to reviewed defect
</commit_message>
<xml_diff>
--- a/docs/midterm-presentation-draft.pptx
+++ b/docs/midterm-presentation-draft.pptx
@@ -2,23 +2,23 @@
 <file path=ppt/presentation.xml><?xml version="1.0" encoding="utf-8"?>
 <p:presentation xmlns:p="http://schemas.openxmlformats.org/presentationml/2006/main">
   <p:sldMasterIdLst>
-    <p:sldMasterId xmlns:r="http://schemas.openxmlformats.org/officeDocument/2006/relationships" id="2147483648" r:id="R430b2dae4ad144ad"/>
+    <p:sldMasterId xmlns:r="http://schemas.openxmlformats.org/officeDocument/2006/relationships" id="2147483648" r:id="Rebe9b505012f408f"/>
   </p:sldMasterIdLst>
   <p:notesMasterIdLst>
-    <p:notesMasterId xmlns:r="http://schemas.openxmlformats.org/officeDocument/2006/relationships" r:id="R6e80883725eb454b"/>
+    <p:notesMasterId xmlns:r="http://schemas.openxmlformats.org/officeDocument/2006/relationships" r:id="Rd59f1620b447403e"/>
   </p:notesMasterIdLst>
   <p:sldIdLst>
-    <p:sldId xmlns:r="http://schemas.openxmlformats.org/officeDocument/2006/relationships" id="256" r:id="R6ddfe8a48d0b430e"/>
-    <p:sldId xmlns:r="http://schemas.openxmlformats.org/officeDocument/2006/relationships" id="257" r:id="R48556247b01f4438"/>
-    <p:sldId xmlns:r="http://schemas.openxmlformats.org/officeDocument/2006/relationships" id="258" r:id="R81ce3c2af85146f3"/>
-    <p:sldId xmlns:r="http://schemas.openxmlformats.org/officeDocument/2006/relationships" id="259" r:id="R88473d462dc44f66"/>
-    <p:sldId xmlns:r="http://schemas.openxmlformats.org/officeDocument/2006/relationships" id="260" r:id="R818a594ab1d542cb"/>
-    <p:sldId xmlns:r="http://schemas.openxmlformats.org/officeDocument/2006/relationships" id="261" r:id="R3f76a947ddb6498b"/>
-    <p:sldId xmlns:r="http://schemas.openxmlformats.org/officeDocument/2006/relationships" id="262" r:id="R54b47e2b89eb4d33"/>
-    <p:sldId xmlns:r="http://schemas.openxmlformats.org/officeDocument/2006/relationships" id="263" r:id="R515d2c6726ab49bb"/>
-    <p:sldId xmlns:r="http://schemas.openxmlformats.org/officeDocument/2006/relationships" id="264" r:id="R939a1cc6ae7f4ee2"/>
-    <p:sldId xmlns:r="http://schemas.openxmlformats.org/officeDocument/2006/relationships" id="265" r:id="Rebb5a7c17d894ce6"/>
-    <p:sldId xmlns:r="http://schemas.openxmlformats.org/officeDocument/2006/relationships" id="266" r:id="R3435d986020e4edd"/>
+    <p:sldId xmlns:r="http://schemas.openxmlformats.org/officeDocument/2006/relationships" id="256" r:id="R414b7378254e4740"/>
+    <p:sldId xmlns:r="http://schemas.openxmlformats.org/officeDocument/2006/relationships" id="257" r:id="R5918ff4c9bfb4ed1"/>
+    <p:sldId xmlns:r="http://schemas.openxmlformats.org/officeDocument/2006/relationships" id="258" r:id="R4b5642c318ac4e6e"/>
+    <p:sldId xmlns:r="http://schemas.openxmlformats.org/officeDocument/2006/relationships" id="259" r:id="R84bbeb480f8d4ee7"/>
+    <p:sldId xmlns:r="http://schemas.openxmlformats.org/officeDocument/2006/relationships" id="260" r:id="R1e583557cc194695"/>
+    <p:sldId xmlns:r="http://schemas.openxmlformats.org/officeDocument/2006/relationships" id="261" r:id="Rbeb4243bdce24fdb"/>
+    <p:sldId xmlns:r="http://schemas.openxmlformats.org/officeDocument/2006/relationships" id="262" r:id="R21f08db855a54e51"/>
+    <p:sldId xmlns:r="http://schemas.openxmlformats.org/officeDocument/2006/relationships" id="263" r:id="R0857fd5b975e4f98"/>
+    <p:sldId xmlns:r="http://schemas.openxmlformats.org/officeDocument/2006/relationships" id="264" r:id="Rfdbe10d4f5e4466d"/>
+    <p:sldId xmlns:r="http://schemas.openxmlformats.org/officeDocument/2006/relationships" id="265" r:id="R732495b6307e436b"/>
+    <p:sldId xmlns:r="http://schemas.openxmlformats.org/officeDocument/2006/relationships" id="266" r:id="R5935297e89514f6b"/>
   </p:sldIdLst>
   <p:sldSz cx="12192000" cy="6858000"/>
   <p:notesSz cx="6858000" cy="9144000"/>
@@ -642,7 +642,7 @@
           </a:p>
           <a:p xmlns:a="http://schemas.openxmlformats.org/drawingml/2006/main">
             <a:r>
-              <a:t>In this integration, AI assisted with adapter and test drafting. We reviewed the contract and added checks for article ownership, quote provenance, and failure states. A passing fixture test does not prove that Gemini’s interpretation is fair. This is an account of the current integration work; ask each teammate for a real AI-use example before speaking for the whole team.</a:t>
+              <a:t>In this integration, AI assisted with adapter and test drafting. Final review found that a claim relation could be withheld in the comparison card but asserted in the I1 card. We fixed both to show a withheld judgment and added regression tests. A passing fixture test does not prove that Gemini’s interpretation is fair. This is an account of the current integration work; ask each teammate for a real AI-use example before speaking for the whole team.</a:t>
             </a:r>
           </a:p>
           <a:p xmlns:a="http://schemas.openxmlformats.org/drawingml/2006/main">
@@ -1469,7 +1469,7 @@
           <p:cNvPr id="3" name="Title">
             <a:extLst xmlns:a="http://schemas.openxmlformats.org/drawingml/2006/main">
               <a:ext uri="{FF2B5EF4-FFF2-40B4-BE49-F238E27FC236}">
-                <a16:creationId xmlns:a16="http://schemas.microsoft.com/office/drawing/2014/main" id="{11B91FCA-EEB8-42C2-A701-5D00068DD9AD}"/>
+                <a16:creationId xmlns:a16="http://schemas.microsoft.com/office/drawing/2014/main" id="{54AEB853-5435-485A-A9A7-F1659F352B33}"/>
               </a:ext>
             </a:extLst>
           </p:cNvPr>
@@ -1626,7 +1626,7 @@
           <p:cNvPr id="2" name="Subtitle">
             <a:extLst xmlns:a="http://schemas.openxmlformats.org/drawingml/2006/main">
               <a:ext uri="{FF2B5EF4-FFF2-40B4-BE49-F238E27FC236}">
-                <a16:creationId xmlns:a16="http://schemas.microsoft.com/office/drawing/2014/main" id="{2D743681-A5E1-48C4-815F-E7CCA5C245D1}"/>
+                <a16:creationId xmlns:a16="http://schemas.microsoft.com/office/drawing/2014/main" id="{DBCF4C02-98C9-4FC5-B776-C748D66BFB42}"/>
               </a:ext>
             </a:extLst>
           </p:cNvPr>
@@ -1800,7 +1800,7 @@
           <p:cNvPr id="2" name="Section title">
             <a:extLst xmlns:a="http://schemas.openxmlformats.org/drawingml/2006/main">
               <a:ext uri="{FF2B5EF4-FFF2-40B4-BE49-F238E27FC236}">
-                <a16:creationId xmlns:a16="http://schemas.microsoft.com/office/drawing/2014/main" id="{1A896B74-D5E5-482E-91DF-F26E22789324}"/>
+                <a16:creationId xmlns:a16="http://schemas.microsoft.com/office/drawing/2014/main" id="{F39D2054-4855-4DAC-8D20-D834367D00E9}"/>
               </a:ext>
             </a:extLst>
           </p:cNvPr>
@@ -1974,7 +1974,7 @@
           <p:cNvPr id="3" name="Title">
             <a:extLst xmlns:a="http://schemas.openxmlformats.org/drawingml/2006/main">
               <a:ext uri="{FF2B5EF4-FFF2-40B4-BE49-F238E27FC236}">
-                <a16:creationId xmlns:a16="http://schemas.microsoft.com/office/drawing/2014/main" id="{F89A77D3-89B8-448F-9C9D-A0A3253A7491}"/>
+                <a16:creationId xmlns:a16="http://schemas.microsoft.com/office/drawing/2014/main" id="{ACAB96AE-685E-4A9B-BD99-DD05D3EEF00C}"/>
               </a:ext>
             </a:extLst>
           </p:cNvPr>
@@ -2131,7 +2131,7 @@
           <p:cNvPr id="2" name="Body">
             <a:extLst xmlns:a="http://schemas.openxmlformats.org/drawingml/2006/main">
               <a:ext uri="{FF2B5EF4-FFF2-40B4-BE49-F238E27FC236}">
-                <a16:creationId xmlns:a16="http://schemas.microsoft.com/office/drawing/2014/main" id="{6B1D806E-0471-4E0F-8950-BF0FE118093D}"/>
+                <a16:creationId xmlns:a16="http://schemas.microsoft.com/office/drawing/2014/main" id="{68B8457B-87D5-44CC-8D07-6251D8307224}"/>
               </a:ext>
             </a:extLst>
           </p:cNvPr>
@@ -2305,7 +2305,7 @@
           <p:cNvPr id="4" name="Title">
             <a:extLst xmlns:a="http://schemas.openxmlformats.org/drawingml/2006/main">
               <a:ext uri="{FF2B5EF4-FFF2-40B4-BE49-F238E27FC236}">
-                <a16:creationId xmlns:a16="http://schemas.microsoft.com/office/drawing/2014/main" id="{F0D32609-3130-4434-9366-3CCB6F1F8350}"/>
+                <a16:creationId xmlns:a16="http://schemas.microsoft.com/office/drawing/2014/main" id="{22AE893B-2B9C-4292-9827-04B9B0AABD15}"/>
               </a:ext>
             </a:extLst>
           </p:cNvPr>
@@ -2462,7 +2462,7 @@
           <p:cNvPr id="2" name="Left column">
             <a:extLst xmlns:a="http://schemas.openxmlformats.org/drawingml/2006/main">
               <a:ext uri="{FF2B5EF4-FFF2-40B4-BE49-F238E27FC236}">
-                <a16:creationId xmlns:a16="http://schemas.microsoft.com/office/drawing/2014/main" id="{47C8A539-57A6-4382-8017-BD4CF8CC17A1}"/>
+                <a16:creationId xmlns:a16="http://schemas.microsoft.com/office/drawing/2014/main" id="{3095202D-FE32-41DD-B24D-7B078C97B5CC}"/>
               </a:ext>
             </a:extLst>
           </p:cNvPr>
@@ -2619,7 +2619,7 @@
           <p:cNvPr id="3" name="Right column">
             <a:extLst xmlns:a="http://schemas.openxmlformats.org/drawingml/2006/main">
               <a:ext uri="{FF2B5EF4-FFF2-40B4-BE49-F238E27FC236}">
-                <a16:creationId xmlns:a16="http://schemas.microsoft.com/office/drawing/2014/main" id="{ED028B7F-134A-4ABC-8D22-DF8E74179440}"/>
+                <a16:creationId xmlns:a16="http://schemas.microsoft.com/office/drawing/2014/main" id="{38CD379C-443D-409E-BD5E-46D32270194F}"/>
               </a:ext>
             </a:extLst>
           </p:cNvPr>
@@ -2793,7 +2793,7 @@
           <p:cNvPr id="3" name="Title">
             <a:extLst xmlns:a="http://schemas.openxmlformats.org/drawingml/2006/main">
               <a:ext uri="{FF2B5EF4-FFF2-40B4-BE49-F238E27FC236}">
-                <a16:creationId xmlns:a16="http://schemas.microsoft.com/office/drawing/2014/main" id="{92A933F7-AA58-4690-9BAA-7CEFC8C5985E}"/>
+                <a16:creationId xmlns:a16="http://schemas.microsoft.com/office/drawing/2014/main" id="{7FCD7E26-041A-4BF7-9CDA-4C77158D6556}"/>
               </a:ext>
             </a:extLst>
           </p:cNvPr>
@@ -2950,7 +2950,7 @@
           <p:cNvPr id="2" name="Left column">
             <a:extLst xmlns:a="http://schemas.openxmlformats.org/drawingml/2006/main">
               <a:ext uri="{FF2B5EF4-FFF2-40B4-BE49-F238E27FC236}">
-                <a16:creationId xmlns:a16="http://schemas.microsoft.com/office/drawing/2014/main" id="{4757782B-D732-4411-94EE-1B51DA767F2E}"/>
+                <a16:creationId xmlns:a16="http://schemas.microsoft.com/office/drawing/2014/main" id="{3946DDF1-0A20-446D-A7BA-9A87CA9C7814}"/>
               </a:ext>
             </a:extLst>
           </p:cNvPr>
@@ -3145,12 +3145,12 @@
   </p:cSld>
   <p:clrMap bg1="lt1" tx1="dk1" bg2="lt2" tx2="dk2" accent1="accent1" accent2="accent2" accent3="accent3" accent4="accent4" accent5="accent5" accent6="accent6" hlink="hlink" folHlink="folHlink"/>
   <p:sldLayoutIdLst>
-    <p:sldLayoutId xmlns:r="http://schemas.openxmlformats.org/officeDocument/2006/relationships" id="2147483649" r:id="R319354321597488e"/>
-    <p:sldLayoutId xmlns:r="http://schemas.openxmlformats.org/officeDocument/2006/relationships" id="2147483650" r:id="R01eaf198a5ce459c"/>
-    <p:sldLayoutId xmlns:r="http://schemas.openxmlformats.org/officeDocument/2006/relationships" id="2147483651" r:id="R46044ff6ad164f78"/>
-    <p:sldLayoutId xmlns:r="http://schemas.openxmlformats.org/officeDocument/2006/relationships" id="2147483652" r:id="Rac0b23e813d44cf9"/>
-    <p:sldLayoutId xmlns:r="http://schemas.openxmlformats.org/officeDocument/2006/relationships" id="2147483653" r:id="R133ead92e95642f7"/>
-    <p:sldLayoutId xmlns:r="http://schemas.openxmlformats.org/officeDocument/2006/relationships" id="2147483654" r:id="R06eb3c62181f4e8d"/>
+    <p:sldLayoutId xmlns:r="http://schemas.openxmlformats.org/officeDocument/2006/relationships" id="2147483649" r:id="Rd6a61e108d704406"/>
+    <p:sldLayoutId xmlns:r="http://schemas.openxmlformats.org/officeDocument/2006/relationships" id="2147483650" r:id="R81b499ef56084b8d"/>
+    <p:sldLayoutId xmlns:r="http://schemas.openxmlformats.org/officeDocument/2006/relationships" id="2147483651" r:id="R69da57f68dd14600"/>
+    <p:sldLayoutId xmlns:r="http://schemas.openxmlformats.org/officeDocument/2006/relationships" id="2147483652" r:id="Re59ddda97378471b"/>
+    <p:sldLayoutId xmlns:r="http://schemas.openxmlformats.org/officeDocument/2006/relationships" id="2147483653" r:id="R691d55b6876641e1"/>
+    <p:sldLayoutId xmlns:r="http://schemas.openxmlformats.org/officeDocument/2006/relationships" id="2147483654" r:id="Rec2000f7a5b84d88"/>
   </p:sldLayoutIdLst>
   <p:txStyles>
     <p:titleStyle>
@@ -3701,7 +3701,7 @@
           <p:cNvPr id="8" name="">
             <a:extLst xmlns:a="http://schemas.openxmlformats.org/drawingml/2006/main">
               <a:ext uri="{FF2B5EF4-FFF2-40B4-BE49-F238E27FC236}">
-                <a16:creationId xmlns:a16="http://schemas.microsoft.com/office/drawing/2014/main" id="{99189393-BDF2-4A9D-BADF-7102D090A7D9}"/>
+                <a16:creationId xmlns:a16="http://schemas.microsoft.com/office/drawing/2014/main" id="{9A828000-11F2-44AF-B680-F83E5E14DF8F}"/>
               </a:ext>
             </a:extLst>
           </p:cNvPr>
@@ -3770,7 +3770,7 @@
           <p:cNvPr id="2" name="">
             <a:extLst xmlns:a="http://schemas.openxmlformats.org/drawingml/2006/main">
               <a:ext uri="{FF2B5EF4-FFF2-40B4-BE49-F238E27FC236}">
-                <a16:creationId xmlns:a16="http://schemas.microsoft.com/office/drawing/2014/main" id="{2D29C079-5656-4187-8FFD-E5A9B070BAC0}"/>
+                <a16:creationId xmlns:a16="http://schemas.microsoft.com/office/drawing/2014/main" id="{6DA418BE-4E34-48F5-BB2F-B107C69B409B}"/>
               </a:ext>
             </a:extLst>
           </p:cNvPr>
@@ -3801,7 +3801,7 @@
           <p:cNvPr id="3" name="">
             <a:extLst xmlns:a="http://schemas.openxmlformats.org/drawingml/2006/main">
               <a:ext uri="{FF2B5EF4-FFF2-40B4-BE49-F238E27FC236}">
-                <a16:creationId xmlns:a16="http://schemas.microsoft.com/office/drawing/2014/main" id="{58F1D56C-4C00-4CA7-BEC1-8D3218B08425}"/>
+                <a16:creationId xmlns:a16="http://schemas.microsoft.com/office/drawing/2014/main" id="{94A1870F-0C95-4EB5-AA12-1E27A42D4282}"/>
               </a:ext>
             </a:extLst>
           </p:cNvPr>
@@ -3870,7 +3870,7 @@
           <p:cNvPr id="4" name="">
             <a:extLst xmlns:a="http://schemas.openxmlformats.org/drawingml/2006/main">
               <a:ext uri="{FF2B5EF4-FFF2-40B4-BE49-F238E27FC236}">
-                <a16:creationId xmlns:a16="http://schemas.microsoft.com/office/drawing/2014/main" id="{B0901BB0-2DDB-4375-9E18-CC8D3F730D8C}"/>
+                <a16:creationId xmlns:a16="http://schemas.microsoft.com/office/drawing/2014/main" id="{308AB2FA-004E-401D-A43D-19376ABB9DEA}"/>
               </a:ext>
             </a:extLst>
           </p:cNvPr>
@@ -3939,7 +3939,7 @@
           <p:cNvPr id="5" name="">
             <a:extLst xmlns:a="http://schemas.openxmlformats.org/drawingml/2006/main">
               <a:ext uri="{FF2B5EF4-FFF2-40B4-BE49-F238E27FC236}">
-                <a16:creationId xmlns:a16="http://schemas.microsoft.com/office/drawing/2014/main" id="{0659BF45-49E3-4E12-92ED-B924A7AEF3A2}"/>
+                <a16:creationId xmlns:a16="http://schemas.microsoft.com/office/drawing/2014/main" id="{610A81AC-86D9-45AD-8A38-A8CA41C4659E}"/>
               </a:ext>
             </a:extLst>
           </p:cNvPr>
@@ -4008,7 +4008,7 @@
           <p:cNvPr id="6" name="">
             <a:extLst xmlns:a="http://schemas.openxmlformats.org/drawingml/2006/main">
               <a:ext uri="{FF2B5EF4-FFF2-40B4-BE49-F238E27FC236}">
-                <a16:creationId xmlns:a16="http://schemas.microsoft.com/office/drawing/2014/main" id="{95052505-278E-4A3A-9063-85DC926C14F9}"/>
+                <a16:creationId xmlns:a16="http://schemas.microsoft.com/office/drawing/2014/main" id="{ED6ADB34-41A3-4361-9930-AB68CABDF7DE}"/>
               </a:ext>
             </a:extLst>
           </p:cNvPr>
@@ -4039,7 +4039,7 @@
           <p:cNvPr id="7" name="">
             <a:extLst xmlns:a="http://schemas.openxmlformats.org/drawingml/2006/main">
               <a:ext uri="{FF2B5EF4-FFF2-40B4-BE49-F238E27FC236}">
-                <a16:creationId xmlns:a16="http://schemas.microsoft.com/office/drawing/2014/main" id="{1893BFF1-E78B-4B9B-BC80-F93BFA9683E6}"/>
+                <a16:creationId xmlns:a16="http://schemas.microsoft.com/office/drawing/2014/main" id="{317FB412-8E0B-40FD-BC19-7882E0BB6142}"/>
               </a:ext>
             </a:extLst>
           </p:cNvPr>
@@ -4106,7 +4106,7 @@
     </p:spTree>
     <p:extLst>
       <p:ext uri="{BB962C8B-B14F-4D97-AF65-F5344CB8AC3E}">
-        <p14:creationId xmlns:p14="http://schemas.microsoft.com/office/powerpoint/2010/main" val="510115334"/>
+        <p14:creationId xmlns:p14="http://schemas.microsoft.com/office/powerpoint/2010/main" val="143147074"/>
       </p:ext>
     </p:extLst>
   </p:cSld>
@@ -4137,7 +4137,7 @@
           <p:cNvPr id="15" name="">
             <a:extLst xmlns:a="http://schemas.openxmlformats.org/drawingml/2006/main">
               <a:ext uri="{FF2B5EF4-FFF2-40B4-BE49-F238E27FC236}">
-                <a16:creationId xmlns:a16="http://schemas.microsoft.com/office/drawing/2014/main" id="{E08B3B5B-BCB0-4EC3-85E9-0C43C750B6D5}"/>
+                <a16:creationId xmlns:a16="http://schemas.microsoft.com/office/drawing/2014/main" id="{93060B0F-DA74-4D51-8E96-AF8EF25C06B1}"/>
               </a:ext>
             </a:extLst>
           </p:cNvPr>
@@ -4206,7 +4206,7 @@
           <p:cNvPr id="2" name="">
             <a:extLst xmlns:a="http://schemas.openxmlformats.org/drawingml/2006/main">
               <a:ext uri="{FF2B5EF4-FFF2-40B4-BE49-F238E27FC236}">
-                <a16:creationId xmlns:a16="http://schemas.microsoft.com/office/drawing/2014/main" id="{9C3C5CF2-51D0-4FCF-9392-1DFE29F41763}"/>
+                <a16:creationId xmlns:a16="http://schemas.microsoft.com/office/drawing/2014/main" id="{62C90395-4D74-47AA-82DC-42EA1A8A38CD}"/>
               </a:ext>
             </a:extLst>
           </p:cNvPr>
@@ -4237,7 +4237,7 @@
           <p:cNvPr id="3" name="">
             <a:extLst xmlns:a="http://schemas.openxmlformats.org/drawingml/2006/main">
               <a:ext uri="{FF2B5EF4-FFF2-40B4-BE49-F238E27FC236}">
-                <a16:creationId xmlns:a16="http://schemas.microsoft.com/office/drawing/2014/main" id="{C5E4417C-8DA4-430F-8471-9CAD07A8E615}"/>
+                <a16:creationId xmlns:a16="http://schemas.microsoft.com/office/drawing/2014/main" id="{F13F1B9F-4506-46BF-8830-613B07EC4E26}"/>
               </a:ext>
             </a:extLst>
           </p:cNvPr>
@@ -4306,7 +4306,7 @@
           <p:cNvPr id="4" name="">
             <a:extLst xmlns:a="http://schemas.openxmlformats.org/drawingml/2006/main">
               <a:ext uri="{FF2B5EF4-FFF2-40B4-BE49-F238E27FC236}">
-                <a16:creationId xmlns:a16="http://schemas.microsoft.com/office/drawing/2014/main" id="{8122439A-4EED-427F-867F-5820053E4F45}"/>
+                <a16:creationId xmlns:a16="http://schemas.microsoft.com/office/drawing/2014/main" id="{D4C8C888-7708-4EAD-8B09-E2AF9C7317B2}"/>
               </a:ext>
             </a:extLst>
           </p:cNvPr>
@@ -4375,7 +4375,7 @@
           <p:cNvPr id="5" name="">
             <a:extLst xmlns:a="http://schemas.openxmlformats.org/drawingml/2006/main">
               <a:ext uri="{FF2B5EF4-FFF2-40B4-BE49-F238E27FC236}">
-                <a16:creationId xmlns:a16="http://schemas.microsoft.com/office/drawing/2014/main" id="{6AA83F60-1338-4C75-B785-91AC9E8F7DF3}"/>
+                <a16:creationId xmlns:a16="http://schemas.microsoft.com/office/drawing/2014/main" id="{D3661B15-5B5A-4013-982D-B0DB05E57CA0}"/>
               </a:ext>
             </a:extLst>
           </p:cNvPr>
@@ -4444,7 +4444,7 @@
           <p:cNvPr id="6" name="">
             <a:extLst xmlns:a="http://schemas.openxmlformats.org/drawingml/2006/main">
               <a:ext uri="{FF2B5EF4-FFF2-40B4-BE49-F238E27FC236}">
-                <a16:creationId xmlns:a16="http://schemas.microsoft.com/office/drawing/2014/main" id="{1DEE66D3-D566-43A7-9B09-472AE879406B}"/>
+                <a16:creationId xmlns:a16="http://schemas.microsoft.com/office/drawing/2014/main" id="{206EEC04-97BA-44A5-818B-AFB3A650EC43}"/>
               </a:ext>
             </a:extLst>
           </p:cNvPr>
@@ -4513,7 +4513,7 @@
           <p:cNvPr id="7" name="">
             <a:extLst xmlns:a="http://schemas.openxmlformats.org/drawingml/2006/main">
               <a:ext uri="{FF2B5EF4-FFF2-40B4-BE49-F238E27FC236}">
-                <a16:creationId xmlns:a16="http://schemas.microsoft.com/office/drawing/2014/main" id="{EDDEE052-EFD4-4A3A-9DEF-C49BA4E70C2A}"/>
+                <a16:creationId xmlns:a16="http://schemas.microsoft.com/office/drawing/2014/main" id="{4466E6A7-D65A-4798-8363-B2AD40F1FE4A}"/>
               </a:ext>
             </a:extLst>
           </p:cNvPr>
@@ -4544,7 +4544,7 @@
           <p:cNvPr id="8" name="">
             <a:extLst xmlns:a="http://schemas.openxmlformats.org/drawingml/2006/main">
               <a:ext uri="{FF2B5EF4-FFF2-40B4-BE49-F238E27FC236}">
-                <a16:creationId xmlns:a16="http://schemas.microsoft.com/office/drawing/2014/main" id="{FFD57B6E-6AB1-4085-8DFA-ED35E12AE6C3}"/>
+                <a16:creationId xmlns:a16="http://schemas.microsoft.com/office/drawing/2014/main" id="{9D7FEB54-3D0D-48BB-9D5B-D1DE170746E0}"/>
               </a:ext>
             </a:extLst>
           </p:cNvPr>
@@ -4613,7 +4613,7 @@
           <p:cNvPr id="9" name="">
             <a:extLst xmlns:a="http://schemas.openxmlformats.org/drawingml/2006/main">
               <a:ext uri="{FF2B5EF4-FFF2-40B4-BE49-F238E27FC236}">
-                <a16:creationId xmlns:a16="http://schemas.microsoft.com/office/drawing/2014/main" id="{CCFC782F-98C7-42D0-9554-AF39DBE8E4AC}"/>
+                <a16:creationId xmlns:a16="http://schemas.microsoft.com/office/drawing/2014/main" id="{A335263F-02B5-433B-B5A0-5CD758CF91B0}"/>
               </a:ext>
             </a:extLst>
           </p:cNvPr>
@@ -4682,7 +4682,7 @@
           <p:cNvPr id="10" name="">
             <a:extLst xmlns:a="http://schemas.openxmlformats.org/drawingml/2006/main">
               <a:ext uri="{FF2B5EF4-FFF2-40B4-BE49-F238E27FC236}">
-                <a16:creationId xmlns:a16="http://schemas.microsoft.com/office/drawing/2014/main" id="{03E169C5-5F4D-401E-A67A-0172BD297DAB}"/>
+                <a16:creationId xmlns:a16="http://schemas.microsoft.com/office/drawing/2014/main" id="{2425F00E-B335-45F1-9C04-E6FE23269194}"/>
               </a:ext>
             </a:extLst>
           </p:cNvPr>
@@ -4751,7 +4751,7 @@
           <p:cNvPr id="11" name="">
             <a:extLst xmlns:a="http://schemas.openxmlformats.org/drawingml/2006/main">
               <a:ext uri="{FF2B5EF4-FFF2-40B4-BE49-F238E27FC236}">
-                <a16:creationId xmlns:a16="http://schemas.microsoft.com/office/drawing/2014/main" id="{BAB3DE4A-D4D3-4FA1-ADD5-1217035D2C12}"/>
+                <a16:creationId xmlns:a16="http://schemas.microsoft.com/office/drawing/2014/main" id="{3D424012-74FA-45BD-9169-69FD3A6D584F}"/>
               </a:ext>
             </a:extLst>
           </p:cNvPr>
@@ -4782,7 +4782,7 @@
           <p:cNvPr id="12" name="">
             <a:extLst xmlns:a="http://schemas.openxmlformats.org/drawingml/2006/main">
               <a:ext uri="{FF2B5EF4-FFF2-40B4-BE49-F238E27FC236}">
-                <a16:creationId xmlns:a16="http://schemas.microsoft.com/office/drawing/2014/main" id="{46188C71-C313-4CE0-9557-6D37ED6D6C79}"/>
+                <a16:creationId xmlns:a16="http://schemas.microsoft.com/office/drawing/2014/main" id="{5ACF0AE0-D94D-491A-AC61-E3E339805D51}"/>
               </a:ext>
             </a:extLst>
           </p:cNvPr>
@@ -4851,7 +4851,7 @@
           <p:cNvPr id="13" name="">
             <a:extLst xmlns:a="http://schemas.openxmlformats.org/drawingml/2006/main">
               <a:ext uri="{FF2B5EF4-FFF2-40B4-BE49-F238E27FC236}">
-                <a16:creationId xmlns:a16="http://schemas.microsoft.com/office/drawing/2014/main" id="{4ADA4822-ADC5-4E12-9C6E-8EFBBE962166}"/>
+                <a16:creationId xmlns:a16="http://schemas.microsoft.com/office/drawing/2014/main" id="{349641CD-77E7-4B52-882A-22ABB720F001}"/>
               </a:ext>
             </a:extLst>
           </p:cNvPr>
@@ -4920,7 +4920,7 @@
           <p:cNvPr id="14" name="">
             <a:extLst xmlns:a="http://schemas.openxmlformats.org/drawingml/2006/main">
               <a:ext uri="{FF2B5EF4-FFF2-40B4-BE49-F238E27FC236}">
-                <a16:creationId xmlns:a16="http://schemas.microsoft.com/office/drawing/2014/main" id="{0BA69CF0-7016-40C5-8B11-90ED7982F80C}"/>
+                <a16:creationId xmlns:a16="http://schemas.microsoft.com/office/drawing/2014/main" id="{3C7B8548-F033-4FC6-A35A-4344FF4BCF8C}"/>
               </a:ext>
             </a:extLst>
           </p:cNvPr>
@@ -4987,7 +4987,7 @@
     </p:spTree>
     <p:extLst>
       <p:ext uri="{BB962C8B-B14F-4D97-AF65-F5344CB8AC3E}">
-        <p14:creationId xmlns:p14="http://schemas.microsoft.com/office/powerpoint/2010/main" val="2029842150"/>
+        <p14:creationId xmlns:p14="http://schemas.microsoft.com/office/powerpoint/2010/main" val="1302224683"/>
       </p:ext>
     </p:extLst>
   </p:cSld>
@@ -5018,7 +5018,7 @@
           <p:cNvPr id="10" name="">
             <a:extLst xmlns:a="http://schemas.openxmlformats.org/drawingml/2006/main">
               <a:ext uri="{FF2B5EF4-FFF2-40B4-BE49-F238E27FC236}">
-                <a16:creationId xmlns:a16="http://schemas.microsoft.com/office/drawing/2014/main" id="{8202AF04-B8AD-4608-86C2-EDE722A820B9}"/>
+                <a16:creationId xmlns:a16="http://schemas.microsoft.com/office/drawing/2014/main" id="{42FCCC7C-7BC6-406C-8BCB-B382BC044883}"/>
               </a:ext>
             </a:extLst>
           </p:cNvPr>
@@ -5087,7 +5087,7 @@
           <p:cNvPr id="2" name="">
             <a:extLst xmlns:a="http://schemas.openxmlformats.org/drawingml/2006/main">
               <a:ext uri="{FF2B5EF4-FFF2-40B4-BE49-F238E27FC236}">
-                <a16:creationId xmlns:a16="http://schemas.microsoft.com/office/drawing/2014/main" id="{6E6D78F2-48AE-4FAB-BB54-346EF1DCF9C0}"/>
+                <a16:creationId xmlns:a16="http://schemas.microsoft.com/office/drawing/2014/main" id="{8D756D50-B045-4D36-BEB2-345F5B1E8983}"/>
               </a:ext>
             </a:extLst>
           </p:cNvPr>
@@ -5118,7 +5118,7 @@
           <p:cNvPr id="3" name="">
             <a:extLst xmlns:a="http://schemas.openxmlformats.org/drawingml/2006/main">
               <a:ext uri="{FF2B5EF4-FFF2-40B4-BE49-F238E27FC236}">
-                <a16:creationId xmlns:a16="http://schemas.microsoft.com/office/drawing/2014/main" id="{EAE9BB07-D313-4580-9ADF-7B1963F41338}"/>
+                <a16:creationId xmlns:a16="http://schemas.microsoft.com/office/drawing/2014/main" id="{DFEC4383-A086-4850-B6EB-0DB9A276DBA2}"/>
               </a:ext>
             </a:extLst>
           </p:cNvPr>
@@ -5187,7 +5187,7 @@
           <p:cNvPr id="4" name="">
             <a:extLst xmlns:a="http://schemas.openxmlformats.org/drawingml/2006/main">
               <a:ext uri="{FF2B5EF4-FFF2-40B4-BE49-F238E27FC236}">
-                <a16:creationId xmlns:a16="http://schemas.microsoft.com/office/drawing/2014/main" id="{1F75BFF2-E04A-41FE-A18C-D9FD82FA7740}"/>
+                <a16:creationId xmlns:a16="http://schemas.microsoft.com/office/drawing/2014/main" id="{313FE0A2-BD2F-42B6-864D-7D3B9E061F82}"/>
               </a:ext>
             </a:extLst>
           </p:cNvPr>
@@ -5246,7 +5246,7 @@
                 <a:ea typeface="Georgia"/>
                 <a:cs typeface="Georgia"/>
               </a:rPr>
-              <a:t>AI helped draft the integration.</a:t>
+              <a:t>AI drafted a first pass.</a:t>
             </a:r>
           </a:p>
           <a:p xmlns:a="http://schemas.openxmlformats.org/drawingml/2006/main">
@@ -5269,7 +5269,7 @@
                 <a:ea typeface="Georgia"/>
                 <a:cs typeface="Georgia"/>
               </a:rPr>
-              <a:t>Tests made its assumptions visible.</a:t>
+              <a:t>Review caught a relation mismatch.</a:t>
             </a:r>
           </a:p>
         </p:txBody>
@@ -5279,7 +5279,7 @@
           <p:cNvPr id="5" name="">
             <a:extLst xmlns:a="http://schemas.openxmlformats.org/drawingml/2006/main">
               <a:ext uri="{FF2B5EF4-FFF2-40B4-BE49-F238E27FC236}">
-                <a16:creationId xmlns:a16="http://schemas.microsoft.com/office/drawing/2014/main" id="{7BE6FC40-21B6-4F70-A663-325815ACB9BA}"/>
+                <a16:creationId xmlns:a16="http://schemas.microsoft.com/office/drawing/2014/main" id="{90ACEDB9-0BF4-4660-9FC8-4D9D7ABDA815}"/>
               </a:ext>
             </a:extLst>
           </p:cNvPr>
@@ -5310,7 +5310,7 @@
           <p:cNvPr id="6" name="">
             <a:extLst xmlns:a="http://schemas.openxmlformats.org/drawingml/2006/main">
               <a:ext uri="{FF2B5EF4-FFF2-40B4-BE49-F238E27FC236}">
-                <a16:creationId xmlns:a16="http://schemas.microsoft.com/office/drawing/2014/main" id="{01B25A7E-FF8B-4206-BA2B-4756713D955A}"/>
+                <a16:creationId xmlns:a16="http://schemas.microsoft.com/office/drawing/2014/main" id="{BB770AA4-52F7-45F4-89DA-D83C02B27349}"/>
               </a:ext>
             </a:extLst>
           </p:cNvPr>
@@ -5379,7 +5379,7 @@
           <p:cNvPr id="7" name="">
             <a:extLst xmlns:a="http://schemas.openxmlformats.org/drawingml/2006/main">
               <a:ext uri="{FF2B5EF4-FFF2-40B4-BE49-F238E27FC236}">
-                <a16:creationId xmlns:a16="http://schemas.microsoft.com/office/drawing/2014/main" id="{501EE7FF-7D02-4356-884A-1883F7047C62}"/>
+                <a16:creationId xmlns:a16="http://schemas.microsoft.com/office/drawing/2014/main" id="{39D62575-6306-4B76-9E1D-A6D867418B18}"/>
               </a:ext>
             </a:extLst>
           </p:cNvPr>
@@ -5448,7 +5448,7 @@
           <p:cNvPr id="8" name="">
             <a:extLst xmlns:a="http://schemas.openxmlformats.org/drawingml/2006/main">
               <a:ext uri="{FF2B5EF4-FFF2-40B4-BE49-F238E27FC236}">
-                <a16:creationId xmlns:a16="http://schemas.microsoft.com/office/drawing/2014/main" id="{5268CFE5-648E-492A-B57F-8DAF35EA7747}"/>
+                <a16:creationId xmlns:a16="http://schemas.microsoft.com/office/drawing/2014/main" id="{DF79302B-8D77-4B3D-91DE-3D1B1E58E601}"/>
               </a:ext>
             </a:extLst>
           </p:cNvPr>
@@ -5517,7 +5517,7 @@
           <p:cNvPr id="9" name="">
             <a:extLst xmlns:a="http://schemas.openxmlformats.org/drawingml/2006/main">
               <a:ext uri="{FF2B5EF4-FFF2-40B4-BE49-F238E27FC236}">
-                <a16:creationId xmlns:a16="http://schemas.microsoft.com/office/drawing/2014/main" id="{791BFD10-59F7-48F0-9E1C-FBB41F4268AB}"/>
+                <a16:creationId xmlns:a16="http://schemas.microsoft.com/office/drawing/2014/main" id="{B1FD0644-C7C4-4474-A26B-977F9FE6B0D7}"/>
               </a:ext>
             </a:extLst>
           </p:cNvPr>
@@ -5584,7 +5584,7 @@
     </p:spTree>
     <p:extLst>
       <p:ext uri="{BB962C8B-B14F-4D97-AF65-F5344CB8AC3E}">
-        <p14:creationId xmlns:p14="http://schemas.microsoft.com/office/powerpoint/2010/main" val="2079969769"/>
+        <p14:creationId xmlns:p14="http://schemas.microsoft.com/office/powerpoint/2010/main" val="190850223"/>
       </p:ext>
     </p:extLst>
   </p:cSld>
@@ -5615,7 +5615,7 @@
           <p:cNvPr id="12" name="">
             <a:extLst xmlns:a="http://schemas.openxmlformats.org/drawingml/2006/main">
               <a:ext uri="{FF2B5EF4-FFF2-40B4-BE49-F238E27FC236}">
-                <a16:creationId xmlns:a16="http://schemas.microsoft.com/office/drawing/2014/main" id="{9869812E-9F68-4E67-988F-166FDE0C68C0}"/>
+                <a16:creationId xmlns:a16="http://schemas.microsoft.com/office/drawing/2014/main" id="{96400A45-3E58-4F98-861C-7098DFE91DEF}"/>
               </a:ext>
             </a:extLst>
           </p:cNvPr>
@@ -5684,7 +5684,7 @@
           <p:cNvPr id="2" name="">
             <a:extLst xmlns:a="http://schemas.openxmlformats.org/drawingml/2006/main">
               <a:ext uri="{FF2B5EF4-FFF2-40B4-BE49-F238E27FC236}">
-                <a16:creationId xmlns:a16="http://schemas.microsoft.com/office/drawing/2014/main" id="{828FBDE5-7B62-40FC-B95D-7EA3B47CD9FD}"/>
+                <a16:creationId xmlns:a16="http://schemas.microsoft.com/office/drawing/2014/main" id="{FC810F4A-DBB1-43DF-AC3B-440AB14B1FE4}"/>
               </a:ext>
             </a:extLst>
           </p:cNvPr>
@@ -5715,7 +5715,7 @@
           <p:cNvPr id="3" name="">
             <a:extLst xmlns:a="http://schemas.openxmlformats.org/drawingml/2006/main">
               <a:ext uri="{FF2B5EF4-FFF2-40B4-BE49-F238E27FC236}">
-                <a16:creationId xmlns:a16="http://schemas.microsoft.com/office/drawing/2014/main" id="{26EF9AE0-7228-4965-B71A-66B57E4690AE}"/>
+                <a16:creationId xmlns:a16="http://schemas.microsoft.com/office/drawing/2014/main" id="{0BFAC7EC-FCB5-4AD4-B4ED-5CF9CD64BB01}"/>
               </a:ext>
             </a:extLst>
           </p:cNvPr>
@@ -5784,7 +5784,7 @@
           <p:cNvPr id="4" name="">
             <a:extLst xmlns:a="http://schemas.openxmlformats.org/drawingml/2006/main">
               <a:ext uri="{FF2B5EF4-FFF2-40B4-BE49-F238E27FC236}">
-                <a16:creationId xmlns:a16="http://schemas.microsoft.com/office/drawing/2014/main" id="{D2B8EEB8-C856-4AE3-BD95-E42056FAC645}"/>
+                <a16:creationId xmlns:a16="http://schemas.microsoft.com/office/drawing/2014/main" id="{C366F713-F977-4BE1-A932-763AB9C192A2}"/>
               </a:ext>
             </a:extLst>
           </p:cNvPr>
@@ -5876,7 +5876,7 @@
           <p:cNvPr id="5" name="">
             <a:extLst xmlns:a="http://schemas.openxmlformats.org/drawingml/2006/main">
               <a:ext uri="{FF2B5EF4-FFF2-40B4-BE49-F238E27FC236}">
-                <a16:creationId xmlns:a16="http://schemas.microsoft.com/office/drawing/2014/main" id="{F4CECAB8-44ED-4680-99CB-194FADE91CD0}"/>
+                <a16:creationId xmlns:a16="http://schemas.microsoft.com/office/drawing/2014/main" id="{A8AE2B65-2574-4296-B6F6-8A581C24E7BE}"/>
               </a:ext>
             </a:extLst>
           </p:cNvPr>
@@ -5907,7 +5907,7 @@
           <p:cNvPr id="6" name="">
             <a:extLst xmlns:a="http://schemas.openxmlformats.org/drawingml/2006/main">
               <a:ext uri="{FF2B5EF4-FFF2-40B4-BE49-F238E27FC236}">
-                <a16:creationId xmlns:a16="http://schemas.microsoft.com/office/drawing/2014/main" id="{50F8A17C-51BA-4A71-A4DA-5C368BAA1E23}"/>
+                <a16:creationId xmlns:a16="http://schemas.microsoft.com/office/drawing/2014/main" id="{804C0613-B081-49A3-A661-FD595327423C}"/>
               </a:ext>
             </a:extLst>
           </p:cNvPr>
@@ -5976,7 +5976,7 @@
           <p:cNvPr id="7" name="">
             <a:extLst xmlns:a="http://schemas.openxmlformats.org/drawingml/2006/main">
               <a:ext uri="{FF2B5EF4-FFF2-40B4-BE49-F238E27FC236}">
-                <a16:creationId xmlns:a16="http://schemas.microsoft.com/office/drawing/2014/main" id="{5BA8785A-ABB0-4ADB-86B9-B96BAE0E534F}"/>
+                <a16:creationId xmlns:a16="http://schemas.microsoft.com/office/drawing/2014/main" id="{06488C27-651F-4176-BB53-3261404EB9EF}"/>
               </a:ext>
             </a:extLst>
           </p:cNvPr>
@@ -6045,7 +6045,7 @@
           <p:cNvPr id="8" name="">
             <a:extLst xmlns:a="http://schemas.openxmlformats.org/drawingml/2006/main">
               <a:ext uri="{FF2B5EF4-FFF2-40B4-BE49-F238E27FC236}">
-                <a16:creationId xmlns:a16="http://schemas.microsoft.com/office/drawing/2014/main" id="{F540B750-61E3-49BF-9B29-1C8CC10BBD6B}"/>
+                <a16:creationId xmlns:a16="http://schemas.microsoft.com/office/drawing/2014/main" id="{FCB1A60B-D5EE-4A28-A3C9-BD229A249692}"/>
               </a:ext>
             </a:extLst>
           </p:cNvPr>
@@ -6114,7 +6114,7 @@
           <p:cNvPr id="9" name="">
             <a:extLst xmlns:a="http://schemas.openxmlformats.org/drawingml/2006/main">
               <a:ext uri="{FF2B5EF4-FFF2-40B4-BE49-F238E27FC236}">
-                <a16:creationId xmlns:a16="http://schemas.microsoft.com/office/drawing/2014/main" id="{C4672A0E-1469-4C68-8E4A-2097D5F3B114}"/>
+                <a16:creationId xmlns:a16="http://schemas.microsoft.com/office/drawing/2014/main" id="{94E80108-503B-4A7D-AE92-897B4F31092A}"/>
               </a:ext>
             </a:extLst>
           </p:cNvPr>
@@ -6183,7 +6183,7 @@
           <p:cNvPr id="10" name="">
             <a:extLst xmlns:a="http://schemas.openxmlformats.org/drawingml/2006/main">
               <a:ext uri="{FF2B5EF4-FFF2-40B4-BE49-F238E27FC236}">
-                <a16:creationId xmlns:a16="http://schemas.microsoft.com/office/drawing/2014/main" id="{721A9F8D-A193-4F50-B905-6915ED070A4E}"/>
+                <a16:creationId xmlns:a16="http://schemas.microsoft.com/office/drawing/2014/main" id="{B0D4BCD1-873A-47A8-89D3-97504EA945B9}"/>
               </a:ext>
             </a:extLst>
           </p:cNvPr>
@@ -6252,7 +6252,7 @@
           <p:cNvPr id="11" name="">
             <a:extLst xmlns:a="http://schemas.openxmlformats.org/drawingml/2006/main">
               <a:ext uri="{FF2B5EF4-FFF2-40B4-BE49-F238E27FC236}">
-                <a16:creationId xmlns:a16="http://schemas.microsoft.com/office/drawing/2014/main" id="{B1FE8A34-DF60-4F42-B6CE-9F62FDBF88C2}"/>
+                <a16:creationId xmlns:a16="http://schemas.microsoft.com/office/drawing/2014/main" id="{BA5D6C51-4295-4DAF-9F13-F9B6091C53CA}"/>
               </a:ext>
             </a:extLst>
           </p:cNvPr>
@@ -6319,7 +6319,7 @@
     </p:spTree>
     <p:extLst>
       <p:ext uri="{BB962C8B-B14F-4D97-AF65-F5344CB8AC3E}">
-        <p14:creationId xmlns:p14="http://schemas.microsoft.com/office/powerpoint/2010/main" val="277365531"/>
+        <p14:creationId xmlns:p14="http://schemas.microsoft.com/office/powerpoint/2010/main" val="1073557832"/>
       </p:ext>
     </p:extLst>
   </p:cSld>
@@ -6350,7 +6350,7 @@
           <p:cNvPr id="19" name="">
             <a:extLst xmlns:a="http://schemas.openxmlformats.org/drawingml/2006/main">
               <a:ext uri="{FF2B5EF4-FFF2-40B4-BE49-F238E27FC236}">
-                <a16:creationId xmlns:a16="http://schemas.microsoft.com/office/drawing/2014/main" id="{525A87FB-1075-4858-AAA3-5193F40C378E}"/>
+                <a16:creationId xmlns:a16="http://schemas.microsoft.com/office/drawing/2014/main" id="{5A70B6FA-10D9-4EE6-A4CB-9FDDD50B20E4}"/>
               </a:ext>
             </a:extLst>
           </p:cNvPr>
@@ -6419,7 +6419,7 @@
           <p:cNvPr id="2" name="">
             <a:extLst xmlns:a="http://schemas.openxmlformats.org/drawingml/2006/main">
               <a:ext uri="{FF2B5EF4-FFF2-40B4-BE49-F238E27FC236}">
-                <a16:creationId xmlns:a16="http://schemas.microsoft.com/office/drawing/2014/main" id="{FD33C7CF-2B18-4409-BAAB-6794CEC9C210}"/>
+                <a16:creationId xmlns:a16="http://schemas.microsoft.com/office/drawing/2014/main" id="{6840B659-846C-4621-8998-F65FE29E58AC}"/>
               </a:ext>
             </a:extLst>
           </p:cNvPr>
@@ -6450,7 +6450,7 @@
           <p:cNvPr id="3" name="">
             <a:extLst xmlns:a="http://schemas.openxmlformats.org/drawingml/2006/main">
               <a:ext uri="{FF2B5EF4-FFF2-40B4-BE49-F238E27FC236}">
-                <a16:creationId xmlns:a16="http://schemas.microsoft.com/office/drawing/2014/main" id="{60757FDB-2FF2-40BD-99F2-1F9433ABD0F8}"/>
+                <a16:creationId xmlns:a16="http://schemas.microsoft.com/office/drawing/2014/main" id="{929B7A99-5B2E-4452-8C44-470DEED7AC11}"/>
               </a:ext>
             </a:extLst>
           </p:cNvPr>
@@ -6519,7 +6519,7 @@
           <p:cNvPr id="4" name="">
             <a:extLst xmlns:a="http://schemas.openxmlformats.org/drawingml/2006/main">
               <a:ext uri="{FF2B5EF4-FFF2-40B4-BE49-F238E27FC236}">
-                <a16:creationId xmlns:a16="http://schemas.microsoft.com/office/drawing/2014/main" id="{0377F8E9-5EC3-4701-ABBA-0720FDCA8F95}"/>
+                <a16:creationId xmlns:a16="http://schemas.microsoft.com/office/drawing/2014/main" id="{CF85703D-C98C-489B-9577-EE897B99B6E2}"/>
               </a:ext>
             </a:extLst>
           </p:cNvPr>
@@ -6588,7 +6588,7 @@
           <p:cNvPr id="5" name="">
             <a:extLst xmlns:a="http://schemas.openxmlformats.org/drawingml/2006/main">
               <a:ext uri="{FF2B5EF4-FFF2-40B4-BE49-F238E27FC236}">
-                <a16:creationId xmlns:a16="http://schemas.microsoft.com/office/drawing/2014/main" id="{908AF2E9-2EB9-4B07-8498-D57F747C6C16}"/>
+                <a16:creationId xmlns:a16="http://schemas.microsoft.com/office/drawing/2014/main" id="{DE136DA4-5792-4529-8413-745398F1D04C}"/>
               </a:ext>
             </a:extLst>
           </p:cNvPr>
@@ -6657,7 +6657,7 @@
           <p:cNvPr id="6" name="">
             <a:extLst xmlns:a="http://schemas.openxmlformats.org/drawingml/2006/main">
               <a:ext uri="{FF2B5EF4-FFF2-40B4-BE49-F238E27FC236}">
-                <a16:creationId xmlns:a16="http://schemas.microsoft.com/office/drawing/2014/main" id="{BE9C78F8-6731-4C14-84AA-640558B20A9D}"/>
+                <a16:creationId xmlns:a16="http://schemas.microsoft.com/office/drawing/2014/main" id="{1306CDFD-B66D-45EB-9FF3-80FF2B3B8763}"/>
               </a:ext>
             </a:extLst>
           </p:cNvPr>
@@ -6726,7 +6726,7 @@
           <p:cNvPr id="7" name="">
             <a:extLst xmlns:a="http://schemas.openxmlformats.org/drawingml/2006/main">
               <a:ext uri="{FF2B5EF4-FFF2-40B4-BE49-F238E27FC236}">
-                <a16:creationId xmlns:a16="http://schemas.microsoft.com/office/drawing/2014/main" id="{149224C8-ED83-418E-892F-8F066D3E7076}"/>
+                <a16:creationId xmlns:a16="http://schemas.microsoft.com/office/drawing/2014/main" id="{CB69336D-E651-43AD-9B9D-A5273514BCFF}"/>
               </a:ext>
             </a:extLst>
           </p:cNvPr>
@@ -6757,7 +6757,7 @@
           <p:cNvPr id="8" name="">
             <a:extLst xmlns:a="http://schemas.openxmlformats.org/drawingml/2006/main">
               <a:ext uri="{FF2B5EF4-FFF2-40B4-BE49-F238E27FC236}">
-                <a16:creationId xmlns:a16="http://schemas.microsoft.com/office/drawing/2014/main" id="{BF7F4977-E521-4F11-8DAD-B9F50544D631}"/>
+                <a16:creationId xmlns:a16="http://schemas.microsoft.com/office/drawing/2014/main" id="{1CBCC2E7-9388-4244-A8C1-FE219E6BC1BC}"/>
               </a:ext>
             </a:extLst>
           </p:cNvPr>
@@ -6826,7 +6826,7 @@
           <p:cNvPr id="9" name="">
             <a:extLst xmlns:a="http://schemas.openxmlformats.org/drawingml/2006/main">
               <a:ext uri="{FF2B5EF4-FFF2-40B4-BE49-F238E27FC236}">
-                <a16:creationId xmlns:a16="http://schemas.microsoft.com/office/drawing/2014/main" id="{96928EAE-C1C6-432F-98D8-9C43B9C201E1}"/>
+                <a16:creationId xmlns:a16="http://schemas.microsoft.com/office/drawing/2014/main" id="{F9CA9326-689A-4182-87A9-49CC7C3E8757}"/>
               </a:ext>
             </a:extLst>
           </p:cNvPr>
@@ -6895,7 +6895,7 @@
           <p:cNvPr id="10" name="">
             <a:extLst xmlns:a="http://schemas.openxmlformats.org/drawingml/2006/main">
               <a:ext uri="{FF2B5EF4-FFF2-40B4-BE49-F238E27FC236}">
-                <a16:creationId xmlns:a16="http://schemas.microsoft.com/office/drawing/2014/main" id="{C55D37EE-1DEC-41AA-9DEA-CBD8F913FF68}"/>
+                <a16:creationId xmlns:a16="http://schemas.microsoft.com/office/drawing/2014/main" id="{271ABCF5-8221-4653-8C01-A953179DE429}"/>
               </a:ext>
             </a:extLst>
           </p:cNvPr>
@@ -6964,7 +6964,7 @@
           <p:cNvPr id="11" name="">
             <a:extLst xmlns:a="http://schemas.openxmlformats.org/drawingml/2006/main">
               <a:ext uri="{FF2B5EF4-FFF2-40B4-BE49-F238E27FC236}">
-                <a16:creationId xmlns:a16="http://schemas.microsoft.com/office/drawing/2014/main" id="{B1402C7F-EF13-4956-B1B9-F752C54BC552}"/>
+                <a16:creationId xmlns:a16="http://schemas.microsoft.com/office/drawing/2014/main" id="{B4B6C307-84D8-4EC2-80C2-EE80BE178C3F}"/>
               </a:ext>
             </a:extLst>
           </p:cNvPr>
@@ -6995,7 +6995,7 @@
           <p:cNvPr id="12" name="">
             <a:extLst xmlns:a="http://schemas.openxmlformats.org/drawingml/2006/main">
               <a:ext uri="{FF2B5EF4-FFF2-40B4-BE49-F238E27FC236}">
-                <a16:creationId xmlns:a16="http://schemas.microsoft.com/office/drawing/2014/main" id="{904E91E2-7ED8-4827-BD00-8A19296E6AB2}"/>
+                <a16:creationId xmlns:a16="http://schemas.microsoft.com/office/drawing/2014/main" id="{B3E8F5A6-8D5C-4A3F-A7E4-CE4DDE42F145}"/>
               </a:ext>
             </a:extLst>
           </p:cNvPr>
@@ -7064,7 +7064,7 @@
           <p:cNvPr id="13" name="">
             <a:extLst xmlns:a="http://schemas.openxmlformats.org/drawingml/2006/main">
               <a:ext uri="{FF2B5EF4-FFF2-40B4-BE49-F238E27FC236}">
-                <a16:creationId xmlns:a16="http://schemas.microsoft.com/office/drawing/2014/main" id="{7FD19B77-06BE-4E14-A7A2-8FDD121B1FFD}"/>
+                <a16:creationId xmlns:a16="http://schemas.microsoft.com/office/drawing/2014/main" id="{637485D2-7C38-4F05-85C9-9A611902994E}"/>
               </a:ext>
             </a:extLst>
           </p:cNvPr>
@@ -7133,7 +7133,7 @@
           <p:cNvPr id="14" name="">
             <a:extLst xmlns:a="http://schemas.openxmlformats.org/drawingml/2006/main">
               <a:ext uri="{FF2B5EF4-FFF2-40B4-BE49-F238E27FC236}">
-                <a16:creationId xmlns:a16="http://schemas.microsoft.com/office/drawing/2014/main" id="{DC176DBD-EA52-4B6B-974C-829B5A502A22}"/>
+                <a16:creationId xmlns:a16="http://schemas.microsoft.com/office/drawing/2014/main" id="{32F25CD5-3C36-4115-8530-025D397240FD}"/>
               </a:ext>
             </a:extLst>
           </p:cNvPr>
@@ -7202,7 +7202,7 @@
           <p:cNvPr id="15" name="">
             <a:extLst xmlns:a="http://schemas.openxmlformats.org/drawingml/2006/main">
               <a:ext uri="{FF2B5EF4-FFF2-40B4-BE49-F238E27FC236}">
-                <a16:creationId xmlns:a16="http://schemas.microsoft.com/office/drawing/2014/main" id="{2E6EC311-51F6-49FB-8707-437769C618FC}"/>
+                <a16:creationId xmlns:a16="http://schemas.microsoft.com/office/drawing/2014/main" id="{3B2FC34F-4657-4C15-8623-78CD0AB93B82}"/>
               </a:ext>
             </a:extLst>
           </p:cNvPr>
@@ -7233,7 +7233,7 @@
           <p:cNvPr id="16" name="">
             <a:extLst xmlns:a="http://schemas.openxmlformats.org/drawingml/2006/main">
               <a:ext uri="{FF2B5EF4-FFF2-40B4-BE49-F238E27FC236}">
-                <a16:creationId xmlns:a16="http://schemas.microsoft.com/office/drawing/2014/main" id="{E81037CD-565B-4C6C-9119-5EE9F953361B}"/>
+                <a16:creationId xmlns:a16="http://schemas.microsoft.com/office/drawing/2014/main" id="{80B18990-F7C7-49F8-AFF9-463A08FCAB49}"/>
               </a:ext>
             </a:extLst>
           </p:cNvPr>
@@ -7302,7 +7302,7 @@
           <p:cNvPr id="17" name="">
             <a:extLst xmlns:a="http://schemas.openxmlformats.org/drawingml/2006/main">
               <a:ext uri="{FF2B5EF4-FFF2-40B4-BE49-F238E27FC236}">
-                <a16:creationId xmlns:a16="http://schemas.microsoft.com/office/drawing/2014/main" id="{93D389ED-542A-49D4-9F5F-9C5714BD55CE}"/>
+                <a16:creationId xmlns:a16="http://schemas.microsoft.com/office/drawing/2014/main" id="{F66598CB-8044-4521-B512-C9910908BB29}"/>
               </a:ext>
             </a:extLst>
           </p:cNvPr>
@@ -7371,7 +7371,7 @@
           <p:cNvPr id="18" name="">
             <a:extLst xmlns:a="http://schemas.openxmlformats.org/drawingml/2006/main">
               <a:ext uri="{FF2B5EF4-FFF2-40B4-BE49-F238E27FC236}">
-                <a16:creationId xmlns:a16="http://schemas.microsoft.com/office/drawing/2014/main" id="{66E832FF-54D5-482A-B77A-BAA5DF4A9CF4}"/>
+                <a16:creationId xmlns:a16="http://schemas.microsoft.com/office/drawing/2014/main" id="{2E50E5AA-C281-43B5-BD6E-4CD21B7E30EB}"/>
               </a:ext>
             </a:extLst>
           </p:cNvPr>
@@ -7438,7 +7438,7 @@
     </p:spTree>
     <p:extLst>
       <p:ext uri="{BB962C8B-B14F-4D97-AF65-F5344CB8AC3E}">
-        <p14:creationId xmlns:p14="http://schemas.microsoft.com/office/powerpoint/2010/main" val="1418757300"/>
+        <p14:creationId xmlns:p14="http://schemas.microsoft.com/office/powerpoint/2010/main" val="1366648011"/>
       </p:ext>
     </p:extLst>
   </p:cSld>
@@ -7469,7 +7469,7 @@
           <p:cNvPr id="10" name="">
             <a:extLst xmlns:a="http://schemas.openxmlformats.org/drawingml/2006/main">
               <a:ext uri="{FF2B5EF4-FFF2-40B4-BE49-F238E27FC236}">
-                <a16:creationId xmlns:a16="http://schemas.microsoft.com/office/drawing/2014/main" id="{F0AE2B08-E4C8-479A-A219-D4308A60E378}"/>
+                <a16:creationId xmlns:a16="http://schemas.microsoft.com/office/drawing/2014/main" id="{3FEFA2F0-206D-419D-85E0-12258D4BED31}"/>
               </a:ext>
             </a:extLst>
           </p:cNvPr>
@@ -7538,7 +7538,7 @@
           <p:cNvPr id="2" name="">
             <a:extLst xmlns:a="http://schemas.openxmlformats.org/drawingml/2006/main">
               <a:ext uri="{FF2B5EF4-FFF2-40B4-BE49-F238E27FC236}">
-                <a16:creationId xmlns:a16="http://schemas.microsoft.com/office/drawing/2014/main" id="{8261446C-387E-4135-B1F0-0C7AF38C9A1C}"/>
+                <a16:creationId xmlns:a16="http://schemas.microsoft.com/office/drawing/2014/main" id="{964AA127-1FDF-4A8B-A326-CBDA832E2B15}"/>
               </a:ext>
             </a:extLst>
           </p:cNvPr>
@@ -7569,7 +7569,7 @@
           <p:cNvPr id="3" name="">
             <a:extLst xmlns:a="http://schemas.openxmlformats.org/drawingml/2006/main">
               <a:ext uri="{FF2B5EF4-FFF2-40B4-BE49-F238E27FC236}">
-                <a16:creationId xmlns:a16="http://schemas.microsoft.com/office/drawing/2014/main" id="{DE68B658-A2E3-4875-A118-07151B745150}"/>
+                <a16:creationId xmlns:a16="http://schemas.microsoft.com/office/drawing/2014/main" id="{5E5C9A25-8D1E-4181-A4DF-8491AD6E3F12}"/>
               </a:ext>
             </a:extLst>
           </p:cNvPr>
@@ -7638,7 +7638,7 @@
           <p:cNvPr id="4" name="">
             <a:extLst xmlns:a="http://schemas.openxmlformats.org/drawingml/2006/main">
               <a:ext uri="{FF2B5EF4-FFF2-40B4-BE49-F238E27FC236}">
-                <a16:creationId xmlns:a16="http://schemas.microsoft.com/office/drawing/2014/main" id="{1C723F0F-1E29-4CEF-BDF3-03B4F25D8861}"/>
+                <a16:creationId xmlns:a16="http://schemas.microsoft.com/office/drawing/2014/main" id="{4AE929D6-CCFC-435C-8A85-804DAAFCAF7F}"/>
               </a:ext>
             </a:extLst>
           </p:cNvPr>
@@ -7707,7 +7707,7 @@
           <p:cNvPr id="5" name="">
             <a:extLst xmlns:a="http://schemas.openxmlformats.org/drawingml/2006/main">
               <a:ext uri="{FF2B5EF4-FFF2-40B4-BE49-F238E27FC236}">
-                <a16:creationId xmlns:a16="http://schemas.microsoft.com/office/drawing/2014/main" id="{2D93DCA3-9106-4AA8-801E-0C385C3B3D22}"/>
+                <a16:creationId xmlns:a16="http://schemas.microsoft.com/office/drawing/2014/main" id="{638231AD-3E8C-4E37-877B-DDD0A47744E7}"/>
               </a:ext>
             </a:extLst>
           </p:cNvPr>
@@ -7845,7 +7845,7 @@
           <p:cNvPr id="6" name="">
             <a:extLst xmlns:a="http://schemas.openxmlformats.org/drawingml/2006/main">
               <a:ext uri="{FF2B5EF4-FFF2-40B4-BE49-F238E27FC236}">
-                <a16:creationId xmlns:a16="http://schemas.microsoft.com/office/drawing/2014/main" id="{3EB5CE9E-FE65-4B65-81CA-23FE8A8B2CD6}"/>
+                <a16:creationId xmlns:a16="http://schemas.microsoft.com/office/drawing/2014/main" id="{0CA5F178-5C75-4754-A83B-685505E9B06C}"/>
               </a:ext>
             </a:extLst>
           </p:cNvPr>
@@ -7876,7 +7876,7 @@
           <p:cNvPr id="7" name="">
             <a:extLst xmlns:a="http://schemas.openxmlformats.org/drawingml/2006/main">
               <a:ext uri="{FF2B5EF4-FFF2-40B4-BE49-F238E27FC236}">
-                <a16:creationId xmlns:a16="http://schemas.microsoft.com/office/drawing/2014/main" id="{EACAA089-0D1A-442E-A34E-906C35D60C5E}"/>
+                <a16:creationId xmlns:a16="http://schemas.microsoft.com/office/drawing/2014/main" id="{56E39CD3-08B3-4AA3-9C23-93302E9915BD}"/>
               </a:ext>
             </a:extLst>
           </p:cNvPr>
@@ -7945,7 +7945,7 @@
           <p:cNvPr id="8" name="">
             <a:extLst xmlns:a="http://schemas.openxmlformats.org/drawingml/2006/main">
               <a:ext uri="{FF2B5EF4-FFF2-40B4-BE49-F238E27FC236}">
-                <a16:creationId xmlns:a16="http://schemas.microsoft.com/office/drawing/2014/main" id="{A9071B7C-6F6D-4C0F-962C-12E7B55EDD79}"/>
+                <a16:creationId xmlns:a16="http://schemas.microsoft.com/office/drawing/2014/main" id="{D8EE7607-3E97-419F-BD30-8C7FF1B4EB90}"/>
               </a:ext>
             </a:extLst>
           </p:cNvPr>
@@ -8060,7 +8060,7 @@
           <p:cNvPr id="9" name="">
             <a:extLst xmlns:a="http://schemas.openxmlformats.org/drawingml/2006/main">
               <a:ext uri="{FF2B5EF4-FFF2-40B4-BE49-F238E27FC236}">
-                <a16:creationId xmlns:a16="http://schemas.microsoft.com/office/drawing/2014/main" id="{E0C4AEA0-E875-43F6-AA72-D6330F9083E8}"/>
+                <a16:creationId xmlns:a16="http://schemas.microsoft.com/office/drawing/2014/main" id="{7626A133-A975-4339-A7D0-D07FCAB9FA11}"/>
               </a:ext>
             </a:extLst>
           </p:cNvPr>
@@ -8127,7 +8127,7 @@
     </p:spTree>
     <p:extLst>
       <p:ext uri="{BB962C8B-B14F-4D97-AF65-F5344CB8AC3E}">
-        <p14:creationId xmlns:p14="http://schemas.microsoft.com/office/powerpoint/2010/main" val="1714285379"/>
+        <p14:creationId xmlns:p14="http://schemas.microsoft.com/office/powerpoint/2010/main" val="987148200"/>
       </p:ext>
     </p:extLst>
   </p:cSld>
@@ -8158,7 +8158,7 @@
           <p:cNvPr id="13" name="">
             <a:extLst xmlns:a="http://schemas.openxmlformats.org/drawingml/2006/main">
               <a:ext uri="{FF2B5EF4-FFF2-40B4-BE49-F238E27FC236}">
-                <a16:creationId xmlns:a16="http://schemas.microsoft.com/office/drawing/2014/main" id="{54CAAE50-37C4-4F5E-9F97-1FF2DAB207D0}"/>
+                <a16:creationId xmlns:a16="http://schemas.microsoft.com/office/drawing/2014/main" id="{7754B748-BE29-472D-B040-E6AE8A498F85}"/>
               </a:ext>
             </a:extLst>
           </p:cNvPr>
@@ -8227,7 +8227,7 @@
           <p:cNvPr id="2" name="">
             <a:extLst xmlns:a="http://schemas.openxmlformats.org/drawingml/2006/main">
               <a:ext uri="{FF2B5EF4-FFF2-40B4-BE49-F238E27FC236}">
-                <a16:creationId xmlns:a16="http://schemas.microsoft.com/office/drawing/2014/main" id="{A5CE6381-3546-4885-A430-20D9F2ECFA51}"/>
+                <a16:creationId xmlns:a16="http://schemas.microsoft.com/office/drawing/2014/main" id="{79FC0DD3-A3B8-4706-9374-D1174E82D553}"/>
               </a:ext>
             </a:extLst>
           </p:cNvPr>
@@ -8258,7 +8258,7 @@
           <p:cNvPr id="3" name="">
             <a:extLst xmlns:a="http://schemas.openxmlformats.org/drawingml/2006/main">
               <a:ext uri="{FF2B5EF4-FFF2-40B4-BE49-F238E27FC236}">
-                <a16:creationId xmlns:a16="http://schemas.microsoft.com/office/drawing/2014/main" id="{481D0C49-0E0E-4935-81D7-51BA749144EC}"/>
+                <a16:creationId xmlns:a16="http://schemas.microsoft.com/office/drawing/2014/main" id="{117ACC05-4ACD-4389-B38E-85E57246DB36}"/>
               </a:ext>
             </a:extLst>
           </p:cNvPr>
@@ -8327,7 +8327,7 @@
           <p:cNvPr id="4" name="">
             <a:extLst xmlns:a="http://schemas.openxmlformats.org/drawingml/2006/main">
               <a:ext uri="{FF2B5EF4-FFF2-40B4-BE49-F238E27FC236}">
-                <a16:creationId xmlns:a16="http://schemas.microsoft.com/office/drawing/2014/main" id="{9B374215-4986-44FE-9BE6-ADFE96928D99}"/>
+                <a16:creationId xmlns:a16="http://schemas.microsoft.com/office/drawing/2014/main" id="{BE55C568-87FA-4B1D-939F-5581FFE0EE01}"/>
               </a:ext>
             </a:extLst>
           </p:cNvPr>
@@ -8396,7 +8396,7 @@
           <p:cNvPr id="5" name="">
             <a:extLst xmlns:a="http://schemas.openxmlformats.org/drawingml/2006/main">
               <a:ext uri="{FF2B5EF4-FFF2-40B4-BE49-F238E27FC236}">
-                <a16:creationId xmlns:a16="http://schemas.microsoft.com/office/drawing/2014/main" id="{C47BFD2C-0C15-4DF3-B18B-EA66F65049EE}"/>
+                <a16:creationId xmlns:a16="http://schemas.microsoft.com/office/drawing/2014/main" id="{D5E2E1A5-D918-4CF5-A46E-816D8A1370CD}"/>
               </a:ext>
             </a:extLst>
           </p:cNvPr>
@@ -8465,7 +8465,7 @@
           <p:cNvPr id="6" name="">
             <a:extLst xmlns:a="http://schemas.openxmlformats.org/drawingml/2006/main">
               <a:ext uri="{FF2B5EF4-FFF2-40B4-BE49-F238E27FC236}">
-                <a16:creationId xmlns:a16="http://schemas.microsoft.com/office/drawing/2014/main" id="{5226445C-EFDA-4A05-A5E7-19DE328FD08F}"/>
+                <a16:creationId xmlns:a16="http://schemas.microsoft.com/office/drawing/2014/main" id="{F96A53F4-F344-48E8-AF6B-12930615E5CC}"/>
               </a:ext>
             </a:extLst>
           </p:cNvPr>
@@ -8534,7 +8534,7 @@
           <p:cNvPr id="7" name="">
             <a:extLst xmlns:a="http://schemas.openxmlformats.org/drawingml/2006/main">
               <a:ext uri="{FF2B5EF4-FFF2-40B4-BE49-F238E27FC236}">
-                <a16:creationId xmlns:a16="http://schemas.microsoft.com/office/drawing/2014/main" id="{F001C7E5-FDCA-4436-8596-7E01B9D053C7}"/>
+                <a16:creationId xmlns:a16="http://schemas.microsoft.com/office/drawing/2014/main" id="{10A79FC2-7CCC-45EF-AD6E-9C9C46174D99}"/>
               </a:ext>
             </a:extLst>
           </p:cNvPr>
@@ -8565,7 +8565,7 @@
           <p:cNvPr id="8" name="">
             <a:extLst xmlns:a="http://schemas.openxmlformats.org/drawingml/2006/main">
               <a:ext uri="{FF2B5EF4-FFF2-40B4-BE49-F238E27FC236}">
-                <a16:creationId xmlns:a16="http://schemas.microsoft.com/office/drawing/2014/main" id="{D49B14BF-6F17-4BE2-BF64-357A5ECAB9C7}"/>
+                <a16:creationId xmlns:a16="http://schemas.microsoft.com/office/drawing/2014/main" id="{C96903B6-E38D-4756-9401-9A331B6AD28C}"/>
               </a:ext>
             </a:extLst>
           </p:cNvPr>
@@ -8634,7 +8634,7 @@
           <p:cNvPr id="9" name="">
             <a:extLst xmlns:a="http://schemas.openxmlformats.org/drawingml/2006/main">
               <a:ext uri="{FF2B5EF4-FFF2-40B4-BE49-F238E27FC236}">
-                <a16:creationId xmlns:a16="http://schemas.microsoft.com/office/drawing/2014/main" id="{03F9970F-6EAB-4447-907F-0DA4CAFA9CFB}"/>
+                <a16:creationId xmlns:a16="http://schemas.microsoft.com/office/drawing/2014/main" id="{6D893B35-88D8-4818-9D8F-067089B8EDB5}"/>
               </a:ext>
             </a:extLst>
           </p:cNvPr>
@@ -8703,7 +8703,7 @@
           <p:cNvPr id="10" name="">
             <a:extLst xmlns:a="http://schemas.openxmlformats.org/drawingml/2006/main">
               <a:ext uri="{FF2B5EF4-FFF2-40B4-BE49-F238E27FC236}">
-                <a16:creationId xmlns:a16="http://schemas.microsoft.com/office/drawing/2014/main" id="{FC3FFEA4-C179-4D82-8804-D040F48D386F}"/>
+                <a16:creationId xmlns:a16="http://schemas.microsoft.com/office/drawing/2014/main" id="{8EF564F2-63F5-45E6-9288-C40C5FB45EF9}"/>
               </a:ext>
             </a:extLst>
           </p:cNvPr>
@@ -8772,7 +8772,7 @@
           <p:cNvPr id="11" name="">
             <a:extLst xmlns:a="http://schemas.openxmlformats.org/drawingml/2006/main">
               <a:ext uri="{FF2B5EF4-FFF2-40B4-BE49-F238E27FC236}">
-                <a16:creationId xmlns:a16="http://schemas.microsoft.com/office/drawing/2014/main" id="{D9974CE3-EE16-4CC5-A26A-82C5CCAF76B4}"/>
+                <a16:creationId xmlns:a16="http://schemas.microsoft.com/office/drawing/2014/main" id="{0B4E55FF-33A7-4A26-87C4-2F520172054F}"/>
               </a:ext>
             </a:extLst>
           </p:cNvPr>
@@ -8803,7 +8803,7 @@
           <p:cNvPr id="12" name="">
             <a:extLst xmlns:a="http://schemas.openxmlformats.org/drawingml/2006/main">
               <a:ext uri="{FF2B5EF4-FFF2-40B4-BE49-F238E27FC236}">
-                <a16:creationId xmlns:a16="http://schemas.microsoft.com/office/drawing/2014/main" id="{E0B27978-0C78-4E62-8B11-72265D8C4E5E}"/>
+                <a16:creationId xmlns:a16="http://schemas.microsoft.com/office/drawing/2014/main" id="{68DC8ADE-9924-4D30-8A0C-00AB905651DB}"/>
               </a:ext>
             </a:extLst>
           </p:cNvPr>
@@ -8870,7 +8870,7 @@
     </p:spTree>
     <p:extLst>
       <p:ext uri="{BB962C8B-B14F-4D97-AF65-F5344CB8AC3E}">
-        <p14:creationId xmlns:p14="http://schemas.microsoft.com/office/powerpoint/2010/main" val="1034565149"/>
+        <p14:creationId xmlns:p14="http://schemas.microsoft.com/office/powerpoint/2010/main" val="902039228"/>
       </p:ext>
     </p:extLst>
   </p:cSld>
@@ -8901,7 +8901,7 @@
           <p:cNvPr id="21" name="">
             <a:extLst xmlns:a="http://schemas.openxmlformats.org/drawingml/2006/main">
               <a:ext uri="{FF2B5EF4-FFF2-40B4-BE49-F238E27FC236}">
-                <a16:creationId xmlns:a16="http://schemas.microsoft.com/office/drawing/2014/main" id="{A24A0720-AE17-46C9-8600-17D3389B0815}"/>
+                <a16:creationId xmlns:a16="http://schemas.microsoft.com/office/drawing/2014/main" id="{E63A53B3-5EA7-4553-8615-8107E2765C28}"/>
               </a:ext>
             </a:extLst>
           </p:cNvPr>
@@ -8970,7 +8970,7 @@
           <p:cNvPr id="2" name="">
             <a:extLst xmlns:a="http://schemas.openxmlformats.org/drawingml/2006/main">
               <a:ext uri="{FF2B5EF4-FFF2-40B4-BE49-F238E27FC236}">
-                <a16:creationId xmlns:a16="http://schemas.microsoft.com/office/drawing/2014/main" id="{75315B4B-0263-4F33-8EC1-0C6D861AAE9E}"/>
+                <a16:creationId xmlns:a16="http://schemas.microsoft.com/office/drawing/2014/main" id="{94AAB6B4-F97D-4E22-B83C-74A25ECE0A0A}"/>
               </a:ext>
             </a:extLst>
           </p:cNvPr>
@@ -9001,7 +9001,7 @@
           <p:cNvPr id="3" name="">
             <a:extLst xmlns:a="http://schemas.openxmlformats.org/drawingml/2006/main">
               <a:ext uri="{FF2B5EF4-FFF2-40B4-BE49-F238E27FC236}">
-                <a16:creationId xmlns:a16="http://schemas.microsoft.com/office/drawing/2014/main" id="{D5045141-697D-433A-8E6D-CEE85983A108}"/>
+                <a16:creationId xmlns:a16="http://schemas.microsoft.com/office/drawing/2014/main" id="{F4463F14-27F5-4740-9987-585743684AA5}"/>
               </a:ext>
             </a:extLst>
           </p:cNvPr>
@@ -9070,7 +9070,7 @@
           <p:cNvPr id="4" name="">
             <a:extLst xmlns:a="http://schemas.openxmlformats.org/drawingml/2006/main">
               <a:ext uri="{FF2B5EF4-FFF2-40B4-BE49-F238E27FC236}">
-                <a16:creationId xmlns:a16="http://schemas.microsoft.com/office/drawing/2014/main" id="{1B552298-9D8B-408E-860D-CEDBCC14768A}"/>
+                <a16:creationId xmlns:a16="http://schemas.microsoft.com/office/drawing/2014/main" id="{C561485E-D2C5-44CA-99BB-21CCB86387DA}"/>
               </a:ext>
             </a:extLst>
           </p:cNvPr>
@@ -9139,7 +9139,7 @@
           <p:cNvPr id="5" name="">
             <a:extLst xmlns:a="http://schemas.openxmlformats.org/drawingml/2006/main">
               <a:ext uri="{FF2B5EF4-FFF2-40B4-BE49-F238E27FC236}">
-                <a16:creationId xmlns:a16="http://schemas.microsoft.com/office/drawing/2014/main" id="{8207391F-3D68-47EA-8560-0D3D12837B75}"/>
+                <a16:creationId xmlns:a16="http://schemas.microsoft.com/office/drawing/2014/main" id="{09688C1F-0F2C-4762-A86E-6B2752CEF360}"/>
               </a:ext>
             </a:extLst>
           </p:cNvPr>
@@ -9208,7 +9208,7 @@
           <p:cNvPr id="6" name="">
             <a:extLst xmlns:a="http://schemas.openxmlformats.org/drawingml/2006/main">
               <a:ext uri="{FF2B5EF4-FFF2-40B4-BE49-F238E27FC236}">
-                <a16:creationId xmlns:a16="http://schemas.microsoft.com/office/drawing/2014/main" id="{D212ABD9-7DB5-44BD-938B-AA5D626AAE31}"/>
+                <a16:creationId xmlns:a16="http://schemas.microsoft.com/office/drawing/2014/main" id="{36617875-E343-4552-85B3-3AA3F09243E9}"/>
               </a:ext>
             </a:extLst>
           </p:cNvPr>
@@ -9277,7 +9277,7 @@
           <p:cNvPr id="7" name="">
             <a:extLst xmlns:a="http://schemas.openxmlformats.org/drawingml/2006/main">
               <a:ext uri="{FF2B5EF4-FFF2-40B4-BE49-F238E27FC236}">
-                <a16:creationId xmlns:a16="http://schemas.microsoft.com/office/drawing/2014/main" id="{ABC253D0-3CEF-4FD4-9D5A-350B83F657E3}"/>
+                <a16:creationId xmlns:a16="http://schemas.microsoft.com/office/drawing/2014/main" id="{906D4F16-E6E0-4E4C-9EF2-903E395BA1A2}"/>
               </a:ext>
             </a:extLst>
           </p:cNvPr>
@@ -9308,7 +9308,7 @@
           <p:cNvPr id="8" name="">
             <a:extLst xmlns:a="http://schemas.openxmlformats.org/drawingml/2006/main">
               <a:ext uri="{FF2B5EF4-FFF2-40B4-BE49-F238E27FC236}">
-                <a16:creationId xmlns:a16="http://schemas.microsoft.com/office/drawing/2014/main" id="{AA395EEC-39CE-4482-B709-119E9BC6BBEE}"/>
+                <a16:creationId xmlns:a16="http://schemas.microsoft.com/office/drawing/2014/main" id="{026788F8-7502-4F1E-A618-4D1F06E0C622}"/>
               </a:ext>
             </a:extLst>
           </p:cNvPr>
@@ -9377,7 +9377,7 @@
           <p:cNvPr id="9" name="">
             <a:extLst xmlns:a="http://schemas.openxmlformats.org/drawingml/2006/main">
               <a:ext uri="{FF2B5EF4-FFF2-40B4-BE49-F238E27FC236}">
-                <a16:creationId xmlns:a16="http://schemas.microsoft.com/office/drawing/2014/main" id="{26264DCB-FEB8-4E99-96CB-6B002CCBCB76}"/>
+                <a16:creationId xmlns:a16="http://schemas.microsoft.com/office/drawing/2014/main" id="{B933C0A5-6FCA-470F-A211-53DD17A52FD6}"/>
               </a:ext>
             </a:extLst>
           </p:cNvPr>
@@ -9446,7 +9446,7 @@
           <p:cNvPr id="10" name="">
             <a:extLst xmlns:a="http://schemas.openxmlformats.org/drawingml/2006/main">
               <a:ext uri="{FF2B5EF4-FFF2-40B4-BE49-F238E27FC236}">
-                <a16:creationId xmlns:a16="http://schemas.microsoft.com/office/drawing/2014/main" id="{653BEE4F-EB0F-4F67-938A-A7FEA4F10BA8}"/>
+                <a16:creationId xmlns:a16="http://schemas.microsoft.com/office/drawing/2014/main" id="{B469045B-5568-4F72-9C4B-2916F0DE4A73}"/>
               </a:ext>
             </a:extLst>
           </p:cNvPr>
@@ -9515,7 +9515,7 @@
           <p:cNvPr id="11" name="">
             <a:extLst xmlns:a="http://schemas.openxmlformats.org/drawingml/2006/main">
               <a:ext uri="{FF2B5EF4-FFF2-40B4-BE49-F238E27FC236}">
-                <a16:creationId xmlns:a16="http://schemas.microsoft.com/office/drawing/2014/main" id="{805CE3B8-F65B-4E49-9880-DAEE280D18E2}"/>
+                <a16:creationId xmlns:a16="http://schemas.microsoft.com/office/drawing/2014/main" id="{3FCE0553-1846-4DAE-B2B9-CC52489CBC20}"/>
               </a:ext>
             </a:extLst>
           </p:cNvPr>
@@ -9546,7 +9546,7 @@
           <p:cNvPr id="12" name="">
             <a:extLst xmlns:a="http://schemas.openxmlformats.org/drawingml/2006/main">
               <a:ext uri="{FF2B5EF4-FFF2-40B4-BE49-F238E27FC236}">
-                <a16:creationId xmlns:a16="http://schemas.microsoft.com/office/drawing/2014/main" id="{61C41FC3-A394-4E72-998D-A31CB39AFBF6}"/>
+                <a16:creationId xmlns:a16="http://schemas.microsoft.com/office/drawing/2014/main" id="{60889100-EB10-45B6-91F4-E41FE22EEA8C}"/>
               </a:ext>
             </a:extLst>
           </p:cNvPr>
@@ -9615,7 +9615,7 @@
           <p:cNvPr id="13" name="">
             <a:extLst xmlns:a="http://schemas.openxmlformats.org/drawingml/2006/main">
               <a:ext uri="{FF2B5EF4-FFF2-40B4-BE49-F238E27FC236}">
-                <a16:creationId xmlns:a16="http://schemas.microsoft.com/office/drawing/2014/main" id="{8E55BC31-AEF8-43D5-9F0E-098BF3E1C2D4}"/>
+                <a16:creationId xmlns:a16="http://schemas.microsoft.com/office/drawing/2014/main" id="{84A29974-445F-4CA3-9F3B-85869CBA81D0}"/>
               </a:ext>
             </a:extLst>
           </p:cNvPr>
@@ -9684,7 +9684,7 @@
           <p:cNvPr id="14" name="">
             <a:extLst xmlns:a="http://schemas.openxmlformats.org/drawingml/2006/main">
               <a:ext uri="{FF2B5EF4-FFF2-40B4-BE49-F238E27FC236}">
-                <a16:creationId xmlns:a16="http://schemas.microsoft.com/office/drawing/2014/main" id="{B100124C-EDCF-4574-87A5-376F6148282A}"/>
+                <a16:creationId xmlns:a16="http://schemas.microsoft.com/office/drawing/2014/main" id="{A235753F-A6C0-479E-B53F-026E1947A547}"/>
               </a:ext>
             </a:extLst>
           </p:cNvPr>
@@ -9753,7 +9753,7 @@
           <p:cNvPr id="15" name="">
             <a:extLst xmlns:a="http://schemas.openxmlformats.org/drawingml/2006/main">
               <a:ext uri="{FF2B5EF4-FFF2-40B4-BE49-F238E27FC236}">
-                <a16:creationId xmlns:a16="http://schemas.microsoft.com/office/drawing/2014/main" id="{FDD16E56-4D15-47AA-B4C5-01F6A779DDD2}"/>
+                <a16:creationId xmlns:a16="http://schemas.microsoft.com/office/drawing/2014/main" id="{5F2A19F6-7184-43AA-9CFA-BBAE1A690007}"/>
               </a:ext>
             </a:extLst>
           </p:cNvPr>
@@ -9784,7 +9784,7 @@
           <p:cNvPr id="16" name="">
             <a:extLst xmlns:a="http://schemas.openxmlformats.org/drawingml/2006/main">
               <a:ext uri="{FF2B5EF4-FFF2-40B4-BE49-F238E27FC236}">
-                <a16:creationId xmlns:a16="http://schemas.microsoft.com/office/drawing/2014/main" id="{BE0410F4-0595-4D50-8EDD-0503716AC1FD}"/>
+                <a16:creationId xmlns:a16="http://schemas.microsoft.com/office/drawing/2014/main" id="{E3DAE044-7457-4637-9962-BB3A063CF529}"/>
               </a:ext>
             </a:extLst>
           </p:cNvPr>
@@ -9853,7 +9853,7 @@
           <p:cNvPr id="17" name="">
             <a:extLst xmlns:a="http://schemas.openxmlformats.org/drawingml/2006/main">
               <a:ext uri="{FF2B5EF4-FFF2-40B4-BE49-F238E27FC236}">
-                <a16:creationId xmlns:a16="http://schemas.microsoft.com/office/drawing/2014/main" id="{3E1E0838-0490-4614-8E2E-E0FD2077A265}"/>
+                <a16:creationId xmlns:a16="http://schemas.microsoft.com/office/drawing/2014/main" id="{38DAACBE-3867-4148-A290-BE7F4F0B8B31}"/>
               </a:ext>
             </a:extLst>
           </p:cNvPr>
@@ -9922,7 +9922,7 @@
           <p:cNvPr id="18" name="">
             <a:extLst xmlns:a="http://schemas.openxmlformats.org/drawingml/2006/main">
               <a:ext uri="{FF2B5EF4-FFF2-40B4-BE49-F238E27FC236}">
-                <a16:creationId xmlns:a16="http://schemas.microsoft.com/office/drawing/2014/main" id="{1B39C709-7A9E-4F7F-A65F-BA290FF2AD94}"/>
+                <a16:creationId xmlns:a16="http://schemas.microsoft.com/office/drawing/2014/main" id="{4286AB90-5FFF-4AF2-8C01-2899BD5FA76F}"/>
               </a:ext>
             </a:extLst>
           </p:cNvPr>
@@ -9991,7 +9991,7 @@
           <p:cNvPr id="19" name="">
             <a:extLst xmlns:a="http://schemas.openxmlformats.org/drawingml/2006/main">
               <a:ext uri="{FF2B5EF4-FFF2-40B4-BE49-F238E27FC236}">
-                <a16:creationId xmlns:a16="http://schemas.microsoft.com/office/drawing/2014/main" id="{5C497C36-6BE5-42FA-9D19-6A4FADC598D3}"/>
+                <a16:creationId xmlns:a16="http://schemas.microsoft.com/office/drawing/2014/main" id="{7F0886E4-6776-451C-A353-BD3B8DD86ABC}"/>
               </a:ext>
             </a:extLst>
           </p:cNvPr>
@@ -10022,7 +10022,7 @@
           <p:cNvPr id="20" name="">
             <a:extLst xmlns:a="http://schemas.openxmlformats.org/drawingml/2006/main">
               <a:ext uri="{FF2B5EF4-FFF2-40B4-BE49-F238E27FC236}">
-                <a16:creationId xmlns:a16="http://schemas.microsoft.com/office/drawing/2014/main" id="{62286DC7-E20C-438E-B081-C1DDF777BBA2}"/>
+                <a16:creationId xmlns:a16="http://schemas.microsoft.com/office/drawing/2014/main" id="{D53FEDF3-4263-43F7-AC41-B9B2F823CC2D}"/>
               </a:ext>
             </a:extLst>
           </p:cNvPr>
@@ -10089,7 +10089,7 @@
     </p:spTree>
     <p:extLst>
       <p:ext uri="{BB962C8B-B14F-4D97-AF65-F5344CB8AC3E}">
-        <p14:creationId xmlns:p14="http://schemas.microsoft.com/office/powerpoint/2010/main" val="108436923"/>
+        <p14:creationId xmlns:p14="http://schemas.microsoft.com/office/powerpoint/2010/main" val="468582185"/>
       </p:ext>
     </p:extLst>
   </p:cSld>
@@ -10120,7 +10120,7 @@
           <p:cNvPr id="13" name="">
             <a:extLst xmlns:a="http://schemas.openxmlformats.org/drawingml/2006/main">
               <a:ext uri="{FF2B5EF4-FFF2-40B4-BE49-F238E27FC236}">
-                <a16:creationId xmlns:a16="http://schemas.microsoft.com/office/drawing/2014/main" id="{9E4BEAB4-5B0A-4D70-A086-0BDCE9FD3B1D}"/>
+                <a16:creationId xmlns:a16="http://schemas.microsoft.com/office/drawing/2014/main" id="{7C68277A-550C-45E9-92A1-0029477D67E0}"/>
               </a:ext>
             </a:extLst>
           </p:cNvPr>
@@ -10189,7 +10189,7 @@
           <p:cNvPr id="2" name="">
             <a:extLst xmlns:a="http://schemas.openxmlformats.org/drawingml/2006/main">
               <a:ext uri="{FF2B5EF4-FFF2-40B4-BE49-F238E27FC236}">
-                <a16:creationId xmlns:a16="http://schemas.microsoft.com/office/drawing/2014/main" id="{8AC32E7F-32D0-4EBC-8C84-61BF6A3DEAFB}"/>
+                <a16:creationId xmlns:a16="http://schemas.microsoft.com/office/drawing/2014/main" id="{B23859C7-A976-45B4-BE05-D605A0D0ECBC}"/>
               </a:ext>
             </a:extLst>
           </p:cNvPr>
@@ -10220,7 +10220,7 @@
           <p:cNvPr id="3" name="">
             <a:extLst xmlns:a="http://schemas.openxmlformats.org/drawingml/2006/main">
               <a:ext uri="{FF2B5EF4-FFF2-40B4-BE49-F238E27FC236}">
-                <a16:creationId xmlns:a16="http://schemas.microsoft.com/office/drawing/2014/main" id="{3F676346-7814-4B3F-9E15-AEFD40C30781}"/>
+                <a16:creationId xmlns:a16="http://schemas.microsoft.com/office/drawing/2014/main" id="{6B87DA26-218A-4396-8595-3AA971FC42E2}"/>
               </a:ext>
             </a:extLst>
           </p:cNvPr>
@@ -10289,7 +10289,7 @@
           <p:cNvPr id="4" name="">
             <a:extLst xmlns:a="http://schemas.openxmlformats.org/drawingml/2006/main">
               <a:ext uri="{FF2B5EF4-FFF2-40B4-BE49-F238E27FC236}">
-                <a16:creationId xmlns:a16="http://schemas.microsoft.com/office/drawing/2014/main" id="{A8681F8F-078C-4F2D-9BBE-38299AF23793}"/>
+                <a16:creationId xmlns:a16="http://schemas.microsoft.com/office/drawing/2014/main" id="{F66193A1-7521-4DAC-A70E-61D7C8F78B21}"/>
               </a:ext>
             </a:extLst>
           </p:cNvPr>
@@ -10358,7 +10358,7 @@
           <p:cNvPr id="5" name="">
             <a:extLst xmlns:a="http://schemas.openxmlformats.org/drawingml/2006/main">
               <a:ext uri="{FF2B5EF4-FFF2-40B4-BE49-F238E27FC236}">
-                <a16:creationId xmlns:a16="http://schemas.microsoft.com/office/drawing/2014/main" id="{EE359BA6-4BB8-48E7-8FF7-B4A153C66124}"/>
+                <a16:creationId xmlns:a16="http://schemas.microsoft.com/office/drawing/2014/main" id="{BA85CD8F-1B93-4D80-BC60-DAEE0CD50E0A}"/>
               </a:ext>
             </a:extLst>
           </p:cNvPr>
@@ -10427,7 +10427,7 @@
           <p:cNvPr id="6" name="">
             <a:extLst xmlns:a="http://schemas.openxmlformats.org/drawingml/2006/main">
               <a:ext uri="{FF2B5EF4-FFF2-40B4-BE49-F238E27FC236}">
-                <a16:creationId xmlns:a16="http://schemas.microsoft.com/office/drawing/2014/main" id="{8BD9ABF8-92AE-4ACF-9D21-9B84111FCB4B}"/>
+                <a16:creationId xmlns:a16="http://schemas.microsoft.com/office/drawing/2014/main" id="{55877A65-E144-4C35-9E20-6FCC035F82CD}"/>
               </a:ext>
             </a:extLst>
           </p:cNvPr>
@@ -10458,7 +10458,7 @@
           <p:cNvPr id="7" name="">
             <a:extLst xmlns:a="http://schemas.openxmlformats.org/drawingml/2006/main">
               <a:ext uri="{FF2B5EF4-FFF2-40B4-BE49-F238E27FC236}">
-                <a16:creationId xmlns:a16="http://schemas.microsoft.com/office/drawing/2014/main" id="{3151D2C7-47C1-4543-A91B-9B215BE8F62C}"/>
+                <a16:creationId xmlns:a16="http://schemas.microsoft.com/office/drawing/2014/main" id="{60C65489-5319-4E83-A267-B6F2EF14F07F}"/>
               </a:ext>
             </a:extLst>
           </p:cNvPr>
@@ -10527,7 +10527,7 @@
           <p:cNvPr id="8" name="">
             <a:extLst xmlns:a="http://schemas.openxmlformats.org/drawingml/2006/main">
               <a:ext uri="{FF2B5EF4-FFF2-40B4-BE49-F238E27FC236}">
-                <a16:creationId xmlns:a16="http://schemas.microsoft.com/office/drawing/2014/main" id="{CA2E8383-C13B-474F-A364-D82117CD9C7B}"/>
+                <a16:creationId xmlns:a16="http://schemas.microsoft.com/office/drawing/2014/main" id="{68DC36C0-A762-4E17-8DA0-3694B4793097}"/>
               </a:ext>
             </a:extLst>
           </p:cNvPr>
@@ -10596,7 +10596,7 @@
           <p:cNvPr id="9" name="">
             <a:extLst xmlns:a="http://schemas.openxmlformats.org/drawingml/2006/main">
               <a:ext uri="{FF2B5EF4-FFF2-40B4-BE49-F238E27FC236}">
-                <a16:creationId xmlns:a16="http://schemas.microsoft.com/office/drawing/2014/main" id="{5B296F1B-1E23-4F57-B538-6C15323A7053}"/>
+                <a16:creationId xmlns:a16="http://schemas.microsoft.com/office/drawing/2014/main" id="{48FC9A1E-ABAD-4A76-A324-80C558CE0F0D}"/>
               </a:ext>
             </a:extLst>
           </p:cNvPr>
@@ -10665,7 +10665,7 @@
           <p:cNvPr id="10" name="">
             <a:extLst xmlns:a="http://schemas.openxmlformats.org/drawingml/2006/main">
               <a:ext uri="{FF2B5EF4-FFF2-40B4-BE49-F238E27FC236}">
-                <a16:creationId xmlns:a16="http://schemas.microsoft.com/office/drawing/2014/main" id="{95A6AAEF-EEC1-4C70-AB6F-33613D940CB9}"/>
+                <a16:creationId xmlns:a16="http://schemas.microsoft.com/office/drawing/2014/main" id="{592E4E1B-29F8-4E92-8D1A-482529B38A7F}"/>
               </a:ext>
             </a:extLst>
           </p:cNvPr>
@@ -10734,7 +10734,7 @@
           <p:cNvPr id="11" name="">
             <a:extLst xmlns:a="http://schemas.openxmlformats.org/drawingml/2006/main">
               <a:ext uri="{FF2B5EF4-FFF2-40B4-BE49-F238E27FC236}">
-                <a16:creationId xmlns:a16="http://schemas.microsoft.com/office/drawing/2014/main" id="{1F57D96A-4660-4885-B765-EFB64DEFDC8C}"/>
+                <a16:creationId xmlns:a16="http://schemas.microsoft.com/office/drawing/2014/main" id="{6A660C15-99DE-4EAA-A9FB-2A0BF1C7EF5A}"/>
               </a:ext>
             </a:extLst>
           </p:cNvPr>
@@ -10803,7 +10803,7 @@
           <p:cNvPr id="12" name="">
             <a:extLst xmlns:a="http://schemas.openxmlformats.org/drawingml/2006/main">
               <a:ext uri="{FF2B5EF4-FFF2-40B4-BE49-F238E27FC236}">
-                <a16:creationId xmlns:a16="http://schemas.microsoft.com/office/drawing/2014/main" id="{12E2857B-627C-491A-86F7-05C7AF6E39A1}"/>
+                <a16:creationId xmlns:a16="http://schemas.microsoft.com/office/drawing/2014/main" id="{06DFB763-D584-4F2E-83F3-15A736F93854}"/>
               </a:ext>
             </a:extLst>
           </p:cNvPr>
@@ -10870,7 +10870,7 @@
     </p:spTree>
     <p:extLst>
       <p:ext uri="{BB962C8B-B14F-4D97-AF65-F5344CB8AC3E}">
-        <p14:creationId xmlns:p14="http://schemas.microsoft.com/office/powerpoint/2010/main" val="1180941050"/>
+        <p14:creationId xmlns:p14="http://schemas.microsoft.com/office/powerpoint/2010/main" val="667703571"/>
       </p:ext>
     </p:extLst>
   </p:cSld>
@@ -10901,7 +10901,7 @@
           <p:cNvPr id="9" name="">
             <a:extLst xmlns:a="http://schemas.openxmlformats.org/drawingml/2006/main">
               <a:ext uri="{FF2B5EF4-FFF2-40B4-BE49-F238E27FC236}">
-                <a16:creationId xmlns:a16="http://schemas.microsoft.com/office/drawing/2014/main" id="{2A8F9DE9-871D-48B2-8571-D90DFC8A4118}"/>
+                <a16:creationId xmlns:a16="http://schemas.microsoft.com/office/drawing/2014/main" id="{DE6E6F9F-B898-4A6B-B6AD-EE910A6DC118}"/>
               </a:ext>
             </a:extLst>
           </p:cNvPr>
@@ -10970,7 +10970,7 @@
           <p:cNvPr id="2" name="">
             <a:extLst xmlns:a="http://schemas.openxmlformats.org/drawingml/2006/main">
               <a:ext uri="{FF2B5EF4-FFF2-40B4-BE49-F238E27FC236}">
-                <a16:creationId xmlns:a16="http://schemas.microsoft.com/office/drawing/2014/main" id="{3EF6214A-C314-4BAD-93E9-6689A5804CDE}"/>
+                <a16:creationId xmlns:a16="http://schemas.microsoft.com/office/drawing/2014/main" id="{D76AD93D-6804-407F-92FA-41EB954C464B}"/>
               </a:ext>
             </a:extLst>
           </p:cNvPr>
@@ -11001,7 +11001,7 @@
           <p:cNvPr id="3" name="">
             <a:extLst xmlns:a="http://schemas.openxmlformats.org/drawingml/2006/main">
               <a:ext uri="{FF2B5EF4-FFF2-40B4-BE49-F238E27FC236}">
-                <a16:creationId xmlns:a16="http://schemas.microsoft.com/office/drawing/2014/main" id="{798B23E4-D8DB-4E68-BA76-0D2C838F714B}"/>
+                <a16:creationId xmlns:a16="http://schemas.microsoft.com/office/drawing/2014/main" id="{BC28FCBF-EF74-45DC-B1F4-B51D85EB251D}"/>
               </a:ext>
             </a:extLst>
           </p:cNvPr>
@@ -11070,7 +11070,7 @@
           <p:cNvPr id="4" name="">
             <a:extLst xmlns:a="http://schemas.openxmlformats.org/drawingml/2006/main">
               <a:ext uri="{FF2B5EF4-FFF2-40B4-BE49-F238E27FC236}">
-                <a16:creationId xmlns:a16="http://schemas.microsoft.com/office/drawing/2014/main" id="{6FDF6929-7543-40F1-A433-63B7ECBEE35D}"/>
+                <a16:creationId xmlns:a16="http://schemas.microsoft.com/office/drawing/2014/main" id="{E331E034-7E88-4989-A998-A5FE7B18C0D4}"/>
               </a:ext>
             </a:extLst>
           </p:cNvPr>
@@ -11080,7 +11080,7 @@
           <p:nvPr/>
         </p:nvPicPr>
         <p:blipFill>
-          <a:blip xmlns:r="http://schemas.openxmlformats.org/officeDocument/2006/relationships" xmlns:a="http://schemas.openxmlformats.org/drawingml/2006/main" r:embed="Rd56ab71321044e48"/>
+          <a:blip xmlns:r="http://schemas.openxmlformats.org/officeDocument/2006/relationships" xmlns:a="http://schemas.openxmlformats.org/drawingml/2006/main" r:embed="Ra8dd7dd67d1e4b8e"/>
           <a:srcRect xmlns:a="http://schemas.openxmlformats.org/drawingml/2006/main" l="3000" t="27000" r="3000" b="32000"/>
           <a:stretch xmlns:a="http://schemas.openxmlformats.org/drawingml/2006/main"/>
         </p:blipFill>
@@ -11099,7 +11099,7 @@
           <p:cNvPr id="5" name="">
             <a:extLst xmlns:a="http://schemas.openxmlformats.org/drawingml/2006/main">
               <a:ext uri="{FF2B5EF4-FFF2-40B4-BE49-F238E27FC236}">
-                <a16:creationId xmlns:a16="http://schemas.microsoft.com/office/drawing/2014/main" id="{2367C213-F750-4A0C-AE49-67E9D939DBBF}"/>
+                <a16:creationId xmlns:a16="http://schemas.microsoft.com/office/drawing/2014/main" id="{7692FFC9-3DFE-481F-96C9-870BDD9933B3}"/>
               </a:ext>
             </a:extLst>
           </p:cNvPr>
@@ -11168,7 +11168,7 @@
           <p:cNvPr id="6" name="">
             <a:extLst xmlns:a="http://schemas.openxmlformats.org/drawingml/2006/main">
               <a:ext uri="{FF2B5EF4-FFF2-40B4-BE49-F238E27FC236}">
-                <a16:creationId xmlns:a16="http://schemas.microsoft.com/office/drawing/2014/main" id="{35319E5C-56A2-4878-93C4-43213B8B9B65}"/>
+                <a16:creationId xmlns:a16="http://schemas.microsoft.com/office/drawing/2014/main" id="{F45B7274-05AD-4BE8-98E7-716913C93AA2}"/>
               </a:ext>
             </a:extLst>
           </p:cNvPr>
@@ -11237,7 +11237,7 @@
           <p:cNvPr id="7" name="">
             <a:extLst xmlns:a="http://schemas.openxmlformats.org/drawingml/2006/main">
               <a:ext uri="{FF2B5EF4-FFF2-40B4-BE49-F238E27FC236}">
-                <a16:creationId xmlns:a16="http://schemas.microsoft.com/office/drawing/2014/main" id="{4AC064F9-C58D-4EFC-B5A3-7CFD1DEBF8EE}"/>
+                <a16:creationId xmlns:a16="http://schemas.microsoft.com/office/drawing/2014/main" id="{7AD79EF5-44F2-4041-BEFA-B2BD4B02DA64}"/>
               </a:ext>
             </a:extLst>
           </p:cNvPr>
@@ -11268,7 +11268,7 @@
           <p:cNvPr id="8" name="">
             <a:extLst xmlns:a="http://schemas.openxmlformats.org/drawingml/2006/main">
               <a:ext uri="{FF2B5EF4-FFF2-40B4-BE49-F238E27FC236}">
-                <a16:creationId xmlns:a16="http://schemas.microsoft.com/office/drawing/2014/main" id="{EA65D890-2090-4ECF-9C50-D3AA7BFAC10D}"/>
+                <a16:creationId xmlns:a16="http://schemas.microsoft.com/office/drawing/2014/main" id="{C6E18DE9-F389-4615-8A65-DE4C836DDC6A}"/>
               </a:ext>
             </a:extLst>
           </p:cNvPr>
@@ -11335,7 +11335,7 @@
     </p:spTree>
     <p:extLst>
       <p:ext uri="{BB962C8B-B14F-4D97-AF65-F5344CB8AC3E}">
-        <p14:creationId xmlns:p14="http://schemas.microsoft.com/office/powerpoint/2010/main" val="2091976568"/>
+        <p14:creationId xmlns:p14="http://schemas.microsoft.com/office/powerpoint/2010/main" val="1231511017"/>
       </p:ext>
     </p:extLst>
   </p:cSld>
@@ -11366,7 +11366,7 @@
           <p:cNvPr id="17" name="">
             <a:extLst xmlns:a="http://schemas.openxmlformats.org/drawingml/2006/main">
               <a:ext uri="{FF2B5EF4-FFF2-40B4-BE49-F238E27FC236}">
-                <a16:creationId xmlns:a16="http://schemas.microsoft.com/office/drawing/2014/main" id="{E52ED5DE-6456-4DD1-973D-D957E814BE05}"/>
+                <a16:creationId xmlns:a16="http://schemas.microsoft.com/office/drawing/2014/main" id="{CCB5A756-453F-4BE2-88E9-D51D82229235}"/>
               </a:ext>
             </a:extLst>
           </p:cNvPr>
@@ -11435,7 +11435,7 @@
           <p:cNvPr id="2" name="">
             <a:extLst xmlns:a="http://schemas.openxmlformats.org/drawingml/2006/main">
               <a:ext uri="{FF2B5EF4-FFF2-40B4-BE49-F238E27FC236}">
-                <a16:creationId xmlns:a16="http://schemas.microsoft.com/office/drawing/2014/main" id="{0C980D25-DF84-4E2F-B924-3A590375E162}"/>
+                <a16:creationId xmlns:a16="http://schemas.microsoft.com/office/drawing/2014/main" id="{4A36A003-3B47-4E1C-AF27-B32FF8C72615}"/>
               </a:ext>
             </a:extLst>
           </p:cNvPr>
@@ -11466,7 +11466,7 @@
           <p:cNvPr id="3" name="">
             <a:extLst xmlns:a="http://schemas.openxmlformats.org/drawingml/2006/main">
               <a:ext uri="{FF2B5EF4-FFF2-40B4-BE49-F238E27FC236}">
-                <a16:creationId xmlns:a16="http://schemas.microsoft.com/office/drawing/2014/main" id="{8E7DA2DE-F83D-48E5-83C9-B9FABCDC537F}"/>
+                <a16:creationId xmlns:a16="http://schemas.microsoft.com/office/drawing/2014/main" id="{411C3D24-D614-4B13-A96A-80C10A7944F4}"/>
               </a:ext>
             </a:extLst>
           </p:cNvPr>
@@ -11535,7 +11535,7 @@
           <p:cNvPr id="4" name="">
             <a:extLst xmlns:a="http://schemas.openxmlformats.org/drawingml/2006/main">
               <a:ext uri="{FF2B5EF4-FFF2-40B4-BE49-F238E27FC236}">
-                <a16:creationId xmlns:a16="http://schemas.microsoft.com/office/drawing/2014/main" id="{B819C659-B898-4BD0-8BF8-D423A7AAF689}"/>
+                <a16:creationId xmlns:a16="http://schemas.microsoft.com/office/drawing/2014/main" id="{8145BB15-A2E6-4218-B3B5-D9F888E1591F}"/>
               </a:ext>
             </a:extLst>
           </p:cNvPr>
@@ -11604,7 +11604,7 @@
           <p:cNvPr id="5" name="">
             <a:extLst xmlns:a="http://schemas.openxmlformats.org/drawingml/2006/main">
               <a:ext uri="{FF2B5EF4-FFF2-40B4-BE49-F238E27FC236}">
-                <a16:creationId xmlns:a16="http://schemas.microsoft.com/office/drawing/2014/main" id="{6751714C-2FD8-48B6-9F28-DA3BA89FC106}"/>
+                <a16:creationId xmlns:a16="http://schemas.microsoft.com/office/drawing/2014/main" id="{82BB9C79-E34F-4F83-942B-297F0F475EE7}"/>
               </a:ext>
             </a:extLst>
           </p:cNvPr>
@@ -11673,7 +11673,7 @@
           <p:cNvPr id="6" name="">
             <a:extLst xmlns:a="http://schemas.openxmlformats.org/drawingml/2006/main">
               <a:ext uri="{FF2B5EF4-FFF2-40B4-BE49-F238E27FC236}">
-                <a16:creationId xmlns:a16="http://schemas.microsoft.com/office/drawing/2014/main" id="{45053991-F186-4341-BD29-184CA767B57E}"/>
+                <a16:creationId xmlns:a16="http://schemas.microsoft.com/office/drawing/2014/main" id="{E6F5662C-ADDD-4BCF-A9C0-F5F85F86ED10}"/>
               </a:ext>
             </a:extLst>
           </p:cNvPr>
@@ -11704,7 +11704,7 @@
           <p:cNvPr id="7" name="">
             <a:extLst xmlns:a="http://schemas.openxmlformats.org/drawingml/2006/main">
               <a:ext uri="{FF2B5EF4-FFF2-40B4-BE49-F238E27FC236}">
-                <a16:creationId xmlns:a16="http://schemas.microsoft.com/office/drawing/2014/main" id="{1B15C0B6-D174-4C7A-9692-93B9BB07C259}"/>
+                <a16:creationId xmlns:a16="http://schemas.microsoft.com/office/drawing/2014/main" id="{544C6D19-A55D-4DBD-BC22-6A1264DA38EC}"/>
               </a:ext>
             </a:extLst>
           </p:cNvPr>
@@ -11773,7 +11773,7 @@
           <p:cNvPr id="8" name="">
             <a:extLst xmlns:a="http://schemas.openxmlformats.org/drawingml/2006/main">
               <a:ext uri="{FF2B5EF4-FFF2-40B4-BE49-F238E27FC236}">
-                <a16:creationId xmlns:a16="http://schemas.microsoft.com/office/drawing/2014/main" id="{C02A75E3-BE8C-4060-8C25-E312B826FA61}"/>
+                <a16:creationId xmlns:a16="http://schemas.microsoft.com/office/drawing/2014/main" id="{C1927047-5817-4FEB-843B-042E66F9AB71}"/>
               </a:ext>
             </a:extLst>
           </p:cNvPr>
@@ -11842,7 +11842,7 @@
           <p:cNvPr id="9" name="">
             <a:extLst xmlns:a="http://schemas.openxmlformats.org/drawingml/2006/main">
               <a:ext uri="{FF2B5EF4-FFF2-40B4-BE49-F238E27FC236}">
-                <a16:creationId xmlns:a16="http://schemas.microsoft.com/office/drawing/2014/main" id="{A6E3564F-5A52-4425-AB9F-FA1DA7469C06}"/>
+                <a16:creationId xmlns:a16="http://schemas.microsoft.com/office/drawing/2014/main" id="{4EAFCB14-DBA9-400F-9CE1-5E4E6FF693A1}"/>
               </a:ext>
             </a:extLst>
           </p:cNvPr>
@@ -11873,7 +11873,7 @@
           <p:cNvPr id="10" name="">
             <a:extLst xmlns:a="http://schemas.openxmlformats.org/drawingml/2006/main">
               <a:ext uri="{FF2B5EF4-FFF2-40B4-BE49-F238E27FC236}">
-                <a16:creationId xmlns:a16="http://schemas.microsoft.com/office/drawing/2014/main" id="{8E590BEF-BE7B-4936-942C-61A164AA497C}"/>
+                <a16:creationId xmlns:a16="http://schemas.microsoft.com/office/drawing/2014/main" id="{DBB8F2F9-B895-44EB-A119-B25474AD2342}"/>
               </a:ext>
             </a:extLst>
           </p:cNvPr>
@@ -11942,7 +11942,7 @@
           <p:cNvPr id="11" name="">
             <a:extLst xmlns:a="http://schemas.openxmlformats.org/drawingml/2006/main">
               <a:ext uri="{FF2B5EF4-FFF2-40B4-BE49-F238E27FC236}">
-                <a16:creationId xmlns:a16="http://schemas.microsoft.com/office/drawing/2014/main" id="{4411A4E6-8E52-414E-8D6F-3BDF9EAF234F}"/>
+                <a16:creationId xmlns:a16="http://schemas.microsoft.com/office/drawing/2014/main" id="{6E82F6C3-793C-40DA-B7B7-F83D0ECDBF32}"/>
               </a:ext>
             </a:extLst>
           </p:cNvPr>
@@ -12011,7 +12011,7 @@
           <p:cNvPr id="12" name="">
             <a:extLst xmlns:a="http://schemas.openxmlformats.org/drawingml/2006/main">
               <a:ext uri="{FF2B5EF4-FFF2-40B4-BE49-F238E27FC236}">
-                <a16:creationId xmlns:a16="http://schemas.microsoft.com/office/drawing/2014/main" id="{16957957-E370-4329-BB3A-86F7D9C1B2DF}"/>
+                <a16:creationId xmlns:a16="http://schemas.microsoft.com/office/drawing/2014/main" id="{5A67D72C-2E58-45EB-A7AE-BE4B5724772D}"/>
               </a:ext>
             </a:extLst>
           </p:cNvPr>
@@ -12042,7 +12042,7 @@
           <p:cNvPr id="13" name="">
             <a:extLst xmlns:a="http://schemas.openxmlformats.org/drawingml/2006/main">
               <a:ext uri="{FF2B5EF4-FFF2-40B4-BE49-F238E27FC236}">
-                <a16:creationId xmlns:a16="http://schemas.microsoft.com/office/drawing/2014/main" id="{02A715A7-CF1A-4183-A244-19675C150197}"/>
+                <a16:creationId xmlns:a16="http://schemas.microsoft.com/office/drawing/2014/main" id="{97D9D1F2-8E54-40FE-BAFC-E4C2A1103F71}"/>
               </a:ext>
             </a:extLst>
           </p:cNvPr>
@@ -12111,7 +12111,7 @@
           <p:cNvPr id="14" name="">
             <a:extLst xmlns:a="http://schemas.openxmlformats.org/drawingml/2006/main">
               <a:ext uri="{FF2B5EF4-FFF2-40B4-BE49-F238E27FC236}">
-                <a16:creationId xmlns:a16="http://schemas.microsoft.com/office/drawing/2014/main" id="{2254D513-BBC0-4CD5-AE6D-289B4901C762}"/>
+                <a16:creationId xmlns:a16="http://schemas.microsoft.com/office/drawing/2014/main" id="{BB23699A-75B5-4FA6-8E90-18A488A0CC82}"/>
               </a:ext>
             </a:extLst>
           </p:cNvPr>
@@ -12180,7 +12180,7 @@
           <p:cNvPr id="15" name="">
             <a:extLst xmlns:a="http://schemas.openxmlformats.org/drawingml/2006/main">
               <a:ext uri="{FF2B5EF4-FFF2-40B4-BE49-F238E27FC236}">
-                <a16:creationId xmlns:a16="http://schemas.microsoft.com/office/drawing/2014/main" id="{FCB6E231-0D19-402D-86C7-42541BF059E0}"/>
+                <a16:creationId xmlns:a16="http://schemas.microsoft.com/office/drawing/2014/main" id="{A22C0C8A-EF89-4684-9459-59671FE96E24}"/>
               </a:ext>
             </a:extLst>
           </p:cNvPr>
@@ -12211,7 +12211,7 @@
           <p:cNvPr id="16" name="">
             <a:extLst xmlns:a="http://schemas.openxmlformats.org/drawingml/2006/main">
               <a:ext uri="{FF2B5EF4-FFF2-40B4-BE49-F238E27FC236}">
-                <a16:creationId xmlns:a16="http://schemas.microsoft.com/office/drawing/2014/main" id="{6AD35BB3-3F12-473A-AF5A-2748D284727B}"/>
+                <a16:creationId xmlns:a16="http://schemas.microsoft.com/office/drawing/2014/main" id="{670175A6-70D0-458F-900D-A67F16E118F6}"/>
               </a:ext>
             </a:extLst>
           </p:cNvPr>
@@ -12278,7 +12278,7 @@
     </p:spTree>
     <p:extLst>
       <p:ext uri="{BB962C8B-B14F-4D97-AF65-F5344CB8AC3E}">
-        <p14:creationId xmlns:p14="http://schemas.microsoft.com/office/powerpoint/2010/main" val="2012926361"/>
+        <p14:creationId xmlns:p14="http://schemas.microsoft.com/office/powerpoint/2010/main" val="287679998"/>
       </p:ext>
     </p:extLst>
   </p:cSld>

</xml_diff>

<commit_message>
Preserve verified rubric results on partial article failure
</commit_message>
<xml_diff>
--- a/docs/midterm-presentation-draft.pptx
+++ b/docs/midterm-presentation-draft.pptx
@@ -2,23 +2,23 @@
 <file path=ppt/presentation.xml><?xml version="1.0" encoding="utf-8"?>
 <p:presentation xmlns:p="http://schemas.openxmlformats.org/presentationml/2006/main">
   <p:sldMasterIdLst>
-    <p:sldMasterId xmlns:r="http://schemas.openxmlformats.org/officeDocument/2006/relationships" id="2147483648" r:id="Rebe9b505012f408f"/>
+    <p:sldMasterId xmlns:r="http://schemas.openxmlformats.org/officeDocument/2006/relationships" id="2147483648" r:id="Rb24d1d1ac0a34e9f"/>
   </p:sldMasterIdLst>
   <p:notesMasterIdLst>
-    <p:notesMasterId xmlns:r="http://schemas.openxmlformats.org/officeDocument/2006/relationships" r:id="Rd59f1620b447403e"/>
+    <p:notesMasterId xmlns:r="http://schemas.openxmlformats.org/officeDocument/2006/relationships" r:id="R712b780ac9ed4329"/>
   </p:notesMasterIdLst>
   <p:sldIdLst>
-    <p:sldId xmlns:r="http://schemas.openxmlformats.org/officeDocument/2006/relationships" id="256" r:id="R414b7378254e4740"/>
-    <p:sldId xmlns:r="http://schemas.openxmlformats.org/officeDocument/2006/relationships" id="257" r:id="R5918ff4c9bfb4ed1"/>
-    <p:sldId xmlns:r="http://schemas.openxmlformats.org/officeDocument/2006/relationships" id="258" r:id="R4b5642c318ac4e6e"/>
-    <p:sldId xmlns:r="http://schemas.openxmlformats.org/officeDocument/2006/relationships" id="259" r:id="R84bbeb480f8d4ee7"/>
-    <p:sldId xmlns:r="http://schemas.openxmlformats.org/officeDocument/2006/relationships" id="260" r:id="R1e583557cc194695"/>
-    <p:sldId xmlns:r="http://schemas.openxmlformats.org/officeDocument/2006/relationships" id="261" r:id="Rbeb4243bdce24fdb"/>
-    <p:sldId xmlns:r="http://schemas.openxmlformats.org/officeDocument/2006/relationships" id="262" r:id="R21f08db855a54e51"/>
-    <p:sldId xmlns:r="http://schemas.openxmlformats.org/officeDocument/2006/relationships" id="263" r:id="R0857fd5b975e4f98"/>
-    <p:sldId xmlns:r="http://schemas.openxmlformats.org/officeDocument/2006/relationships" id="264" r:id="Rfdbe10d4f5e4466d"/>
-    <p:sldId xmlns:r="http://schemas.openxmlformats.org/officeDocument/2006/relationships" id="265" r:id="R732495b6307e436b"/>
-    <p:sldId xmlns:r="http://schemas.openxmlformats.org/officeDocument/2006/relationships" id="266" r:id="R5935297e89514f6b"/>
+    <p:sldId xmlns:r="http://schemas.openxmlformats.org/officeDocument/2006/relationships" id="256" r:id="Re0e300d56b8f485a"/>
+    <p:sldId xmlns:r="http://schemas.openxmlformats.org/officeDocument/2006/relationships" id="257" r:id="R7b940e16eeef42fd"/>
+    <p:sldId xmlns:r="http://schemas.openxmlformats.org/officeDocument/2006/relationships" id="258" r:id="Rae8b5828683e4f11"/>
+    <p:sldId xmlns:r="http://schemas.openxmlformats.org/officeDocument/2006/relationships" id="259" r:id="Rc1ef24438f3341e5"/>
+    <p:sldId xmlns:r="http://schemas.openxmlformats.org/officeDocument/2006/relationships" id="260" r:id="Rcb1e51dcf0324d1d"/>
+    <p:sldId xmlns:r="http://schemas.openxmlformats.org/officeDocument/2006/relationships" id="261" r:id="R0803bf3b46044a68"/>
+    <p:sldId xmlns:r="http://schemas.openxmlformats.org/officeDocument/2006/relationships" id="262" r:id="R2e9328ba75484b51"/>
+    <p:sldId xmlns:r="http://schemas.openxmlformats.org/officeDocument/2006/relationships" id="263" r:id="R092765fc8f584c66"/>
+    <p:sldId xmlns:r="http://schemas.openxmlformats.org/officeDocument/2006/relationships" id="264" r:id="R0534f5efe5144aef"/>
+    <p:sldId xmlns:r="http://schemas.openxmlformats.org/officeDocument/2006/relationships" id="265" r:id="Rf1771004b1094389"/>
+    <p:sldId xmlns:r="http://schemas.openxmlformats.org/officeDocument/2006/relationships" id="266" r:id="R41a0d56426844da6"/>
   </p:sldIdLst>
   <p:sldSz cx="12192000" cy="6858000"/>
   <p:notesSz cx="6858000" cy="9144000"/>
@@ -547,7 +547,7 @@
           </a:p>
           <a:p xmlns:a="http://schemas.openxmlformats.org/drawingml/2006/main">
             <a:r>
-              <a:t>These are the three remaining gates. A health endpoint only checks that credential values exist, not that the services respond. The real run needs source review, timing, and a device recording. The demo branch and Iteration 2 package follow those checks.</a:t>
+              <a:t>The first deployed API request reached comparison in 46.3 seconds but rubric validation failed. Fix and rerun that stage, check source passages and model relations against the articles, then repeat the Android walkthrough after a local emulator HTTPS certificate trust error. The demo branch and Iteration 2 package follow those checks.</a:t>
             </a:r>
           </a:p>
           <a:p xmlns:a="http://schemas.openxmlformats.org/drawingml/2006/main">
@@ -852,7 +852,7 @@
           </a:p>
           <a:p xmlns:a="http://schemas.openxmlformats.org/drawingml/2006/main">
             <a:r>
-              <a:t>Integrated client and API are in draft PR #10; live v2 is not yet verified.</a:t>
+              <a:t>PR #10 merged into main at 6b75cb9 and v2 was deployed on 18 October. The first live API call reached comparison but rubric validation failed. Android remains unverified after a local emulator HTTPS certificate trust error.</a:t>
             </a:r>
           </a:p>
         </p:txBody>
@@ -1117,7 +1117,7 @@
           </a:p>
           <a:p xmlns:a="http://schemas.openxmlformats.org/drawingml/2006/main">
             <a:r>
-              <a:t>The Android client sends an article URL to Django. The server fetches article text, searches through NAVER API HUB, calls Gemini, and returns source-linked JSON. The existing Vercel production deployment is from October 5 and does not demonstrate the integrated v2 path.</a:t>
+              <a:t>The Android client sends an article URL to Django. The server fetches article text, searches through NAVER API HUB, calls Gemini, and returns source-linked JSON. The integrated v2 server was deployed to the existing Vercel URL on 18 October. Its first live request returned HTTP 200 in 46.3 seconds with comparison available; rubric validation failed and the overall status was partial. Source accuracy and the Android path remain unverified. API keys remain server-side.</a:t>
             </a:r>
           </a:p>
           <a:p xmlns:a="http://schemas.openxmlformats.org/drawingml/2006/main">
@@ -1212,7 +1212,7 @@
           </a:p>
           <a:p xmlns:a="http://schemas.openxmlformats.org/drawingml/2006/main">
             <a:r>
-              <a:t>The adapter preserves stable article and claim IDs, a literal source passage and URL, relation and speaker attribution, and partial or unavailable states. Offline tests and a synthetic-response emulator run check the contract and screen path. These checks do not establish the semantic quality or availability of a real model run. Consult the testing draft for revision-specific results.</a:t>
+              <a:t>The adapter preserves stable article and claim IDs, a literal source passage and URL, relation and speaker attribution, and partial or unavailable states. Offline tests and a synthetic-response emulator run check the contract and screen path. A first live API call reached comparison, but rubric validation failed. None of these checks establishes the semantic quality of a model judgment. Consult the testing draft for revision-specific results.</a:t>
             </a:r>
           </a:p>
           <a:p xmlns:a="http://schemas.openxmlformats.org/drawingml/2006/main">
@@ -1307,7 +1307,7 @@
           </a:p>
           <a:p xmlns:a="http://schemas.openxmlformats.org/drawingml/2006/main">
             <a:r>
-              <a:t>The screenshot came from an emulator using a mocked HTTP response. It demonstrates screen navigation and rendering, not a live Gemini or NAVER result. Replace or supplement this slide with a recorded run of the exact configured backend and APK. If live v2 is not ready, show the historical Iteration 1 clip as such.</a:t>
+              <a:t>The screenshot came from an emulator using a mocked HTTP response. It demonstrates screen navigation and rendering, not a live Gemini or NAVER result. Separately, the first production API request returned HTTP 200 in 46.3 seconds with three input claims, three related articles, and comparison available. Rubric validation failed, giving an overall partial status. Android remains unverified after a local emulator HTTPS certificate trust error. Replace or supplement this slide only after a complete recorded run of the exact backend and APK. If unavailable, label the historical Iteration 1 clip as such.</a:t>
             </a:r>
           </a:p>
           <a:p xmlns:a="http://schemas.openxmlformats.org/drawingml/2006/main">
@@ -1402,7 +1402,7 @@
           </a:p>
           <a:p xmlns:a="http://schemas.openxmlformats.org/drawingml/2006/main">
             <a:r>
-              <a:t>The team assignment came from Slack. Jinsol’s UI and Junseo’s pipeline are connected through Django in draft PR #10; it is not merged into main. Update this slide with final PR status, revision, and live outcome before presenting.</a:t>
+              <a:t>The team assignment came from Slack. Jinsol’s UI and Junseo’s pipeline are connected through Django in PR #10, merged into main at 6b75cb9. The server was deployed to the existing Vercel URL on 18 October. One real API request reached comparison; rubric validation failed. Android remains unverified after a local emulator HTTPS certificate trust error. A complete demo is not yet signed off.</a:t>
             </a:r>
           </a:p>
           <a:p xmlns:a="http://schemas.openxmlformats.org/drawingml/2006/main">
@@ -1469,7 +1469,7 @@
           <p:cNvPr id="3" name="Title">
             <a:extLst xmlns:a="http://schemas.openxmlformats.org/drawingml/2006/main">
               <a:ext uri="{FF2B5EF4-FFF2-40B4-BE49-F238E27FC236}">
-                <a16:creationId xmlns:a16="http://schemas.microsoft.com/office/drawing/2014/main" id="{54AEB853-5435-485A-A9A7-F1659F352B33}"/>
+                <a16:creationId xmlns:a16="http://schemas.microsoft.com/office/drawing/2014/main" id="{8162E4EE-3DCD-4E02-B91C-9B36C12728C8}"/>
               </a:ext>
             </a:extLst>
           </p:cNvPr>
@@ -1626,7 +1626,7 @@
           <p:cNvPr id="2" name="Subtitle">
             <a:extLst xmlns:a="http://schemas.openxmlformats.org/drawingml/2006/main">
               <a:ext uri="{FF2B5EF4-FFF2-40B4-BE49-F238E27FC236}">
-                <a16:creationId xmlns:a16="http://schemas.microsoft.com/office/drawing/2014/main" id="{DBCF4C02-98C9-4FC5-B776-C748D66BFB42}"/>
+                <a16:creationId xmlns:a16="http://schemas.microsoft.com/office/drawing/2014/main" id="{9AF4BC07-468E-42B1-9996-C061018E70BF}"/>
               </a:ext>
             </a:extLst>
           </p:cNvPr>
@@ -1800,7 +1800,7 @@
           <p:cNvPr id="2" name="Section title">
             <a:extLst xmlns:a="http://schemas.openxmlformats.org/drawingml/2006/main">
               <a:ext uri="{FF2B5EF4-FFF2-40B4-BE49-F238E27FC236}">
-                <a16:creationId xmlns:a16="http://schemas.microsoft.com/office/drawing/2014/main" id="{F39D2054-4855-4DAC-8D20-D834367D00E9}"/>
+                <a16:creationId xmlns:a16="http://schemas.microsoft.com/office/drawing/2014/main" id="{04250860-455D-47E4-B5D3-6ABFBA12B73C}"/>
               </a:ext>
             </a:extLst>
           </p:cNvPr>
@@ -1974,7 +1974,7 @@
           <p:cNvPr id="3" name="Title">
             <a:extLst xmlns:a="http://schemas.openxmlformats.org/drawingml/2006/main">
               <a:ext uri="{FF2B5EF4-FFF2-40B4-BE49-F238E27FC236}">
-                <a16:creationId xmlns:a16="http://schemas.microsoft.com/office/drawing/2014/main" id="{ACAB96AE-685E-4A9B-BD99-DD05D3EEF00C}"/>
+                <a16:creationId xmlns:a16="http://schemas.microsoft.com/office/drawing/2014/main" id="{6BFE4B69-42EF-4227-AC79-F37DD543F1D7}"/>
               </a:ext>
             </a:extLst>
           </p:cNvPr>
@@ -2131,7 +2131,7 @@
           <p:cNvPr id="2" name="Body">
             <a:extLst xmlns:a="http://schemas.openxmlformats.org/drawingml/2006/main">
               <a:ext uri="{FF2B5EF4-FFF2-40B4-BE49-F238E27FC236}">
-                <a16:creationId xmlns:a16="http://schemas.microsoft.com/office/drawing/2014/main" id="{68B8457B-87D5-44CC-8D07-6251D8307224}"/>
+                <a16:creationId xmlns:a16="http://schemas.microsoft.com/office/drawing/2014/main" id="{7B537218-D708-4EB2-91CA-5D5D5A130457}"/>
               </a:ext>
             </a:extLst>
           </p:cNvPr>
@@ -2305,7 +2305,7 @@
           <p:cNvPr id="4" name="Title">
             <a:extLst xmlns:a="http://schemas.openxmlformats.org/drawingml/2006/main">
               <a:ext uri="{FF2B5EF4-FFF2-40B4-BE49-F238E27FC236}">
-                <a16:creationId xmlns:a16="http://schemas.microsoft.com/office/drawing/2014/main" id="{22AE893B-2B9C-4292-9827-04B9B0AABD15}"/>
+                <a16:creationId xmlns:a16="http://schemas.microsoft.com/office/drawing/2014/main" id="{119767CF-B557-48FC-8559-3AEAF615B72D}"/>
               </a:ext>
             </a:extLst>
           </p:cNvPr>
@@ -2462,7 +2462,7 @@
           <p:cNvPr id="2" name="Left column">
             <a:extLst xmlns:a="http://schemas.openxmlformats.org/drawingml/2006/main">
               <a:ext uri="{FF2B5EF4-FFF2-40B4-BE49-F238E27FC236}">
-                <a16:creationId xmlns:a16="http://schemas.microsoft.com/office/drawing/2014/main" id="{3095202D-FE32-41DD-B24D-7B078C97B5CC}"/>
+                <a16:creationId xmlns:a16="http://schemas.microsoft.com/office/drawing/2014/main" id="{ABD64AF1-30E4-4E1F-9918-65CB568ADE0B}"/>
               </a:ext>
             </a:extLst>
           </p:cNvPr>
@@ -2619,7 +2619,7 @@
           <p:cNvPr id="3" name="Right column">
             <a:extLst xmlns:a="http://schemas.openxmlformats.org/drawingml/2006/main">
               <a:ext uri="{FF2B5EF4-FFF2-40B4-BE49-F238E27FC236}">
-                <a16:creationId xmlns:a16="http://schemas.microsoft.com/office/drawing/2014/main" id="{38CD379C-443D-409E-BD5E-46D32270194F}"/>
+                <a16:creationId xmlns:a16="http://schemas.microsoft.com/office/drawing/2014/main" id="{1969FBAA-1ECD-4D90-91D4-234654D1104C}"/>
               </a:ext>
             </a:extLst>
           </p:cNvPr>
@@ -2793,7 +2793,7 @@
           <p:cNvPr id="3" name="Title">
             <a:extLst xmlns:a="http://schemas.openxmlformats.org/drawingml/2006/main">
               <a:ext uri="{FF2B5EF4-FFF2-40B4-BE49-F238E27FC236}">
-                <a16:creationId xmlns:a16="http://schemas.microsoft.com/office/drawing/2014/main" id="{7FCD7E26-041A-4BF7-9CDA-4C77158D6556}"/>
+                <a16:creationId xmlns:a16="http://schemas.microsoft.com/office/drawing/2014/main" id="{76FC2F74-0978-4F7D-8D83-A0605404BE0C}"/>
               </a:ext>
             </a:extLst>
           </p:cNvPr>
@@ -2950,7 +2950,7 @@
           <p:cNvPr id="2" name="Left column">
             <a:extLst xmlns:a="http://schemas.openxmlformats.org/drawingml/2006/main">
               <a:ext uri="{FF2B5EF4-FFF2-40B4-BE49-F238E27FC236}">
-                <a16:creationId xmlns:a16="http://schemas.microsoft.com/office/drawing/2014/main" id="{3946DDF1-0A20-446D-A7BA-9A87CA9C7814}"/>
+                <a16:creationId xmlns:a16="http://schemas.microsoft.com/office/drawing/2014/main" id="{D2F29500-4A40-4EA5-A313-0518201A70D3}"/>
               </a:ext>
             </a:extLst>
           </p:cNvPr>
@@ -3145,12 +3145,12 @@
   </p:cSld>
   <p:clrMap bg1="lt1" tx1="dk1" bg2="lt2" tx2="dk2" accent1="accent1" accent2="accent2" accent3="accent3" accent4="accent4" accent5="accent5" accent6="accent6" hlink="hlink" folHlink="folHlink"/>
   <p:sldLayoutIdLst>
-    <p:sldLayoutId xmlns:r="http://schemas.openxmlformats.org/officeDocument/2006/relationships" id="2147483649" r:id="Rd6a61e108d704406"/>
-    <p:sldLayoutId xmlns:r="http://schemas.openxmlformats.org/officeDocument/2006/relationships" id="2147483650" r:id="R81b499ef56084b8d"/>
-    <p:sldLayoutId xmlns:r="http://schemas.openxmlformats.org/officeDocument/2006/relationships" id="2147483651" r:id="R69da57f68dd14600"/>
-    <p:sldLayoutId xmlns:r="http://schemas.openxmlformats.org/officeDocument/2006/relationships" id="2147483652" r:id="Re59ddda97378471b"/>
-    <p:sldLayoutId xmlns:r="http://schemas.openxmlformats.org/officeDocument/2006/relationships" id="2147483653" r:id="R691d55b6876641e1"/>
-    <p:sldLayoutId xmlns:r="http://schemas.openxmlformats.org/officeDocument/2006/relationships" id="2147483654" r:id="Rec2000f7a5b84d88"/>
+    <p:sldLayoutId xmlns:r="http://schemas.openxmlformats.org/officeDocument/2006/relationships" id="2147483649" r:id="R2d18196eacc24fc7"/>
+    <p:sldLayoutId xmlns:r="http://schemas.openxmlformats.org/officeDocument/2006/relationships" id="2147483650" r:id="R3192137db7d24948"/>
+    <p:sldLayoutId xmlns:r="http://schemas.openxmlformats.org/officeDocument/2006/relationships" id="2147483651" r:id="R7c2f19bbc3114ff8"/>
+    <p:sldLayoutId xmlns:r="http://schemas.openxmlformats.org/officeDocument/2006/relationships" id="2147483652" r:id="R2aa87b282e7b47dc"/>
+    <p:sldLayoutId xmlns:r="http://schemas.openxmlformats.org/officeDocument/2006/relationships" id="2147483653" r:id="R770d6aa74b4349b8"/>
+    <p:sldLayoutId xmlns:r="http://schemas.openxmlformats.org/officeDocument/2006/relationships" id="2147483654" r:id="R96be2a6bad2942c3"/>
   </p:sldLayoutIdLst>
   <p:txStyles>
     <p:titleStyle>
@@ -3701,7 +3701,7 @@
           <p:cNvPr id="8" name="">
             <a:extLst xmlns:a="http://schemas.openxmlformats.org/drawingml/2006/main">
               <a:ext uri="{FF2B5EF4-FFF2-40B4-BE49-F238E27FC236}">
-                <a16:creationId xmlns:a16="http://schemas.microsoft.com/office/drawing/2014/main" id="{9A828000-11F2-44AF-B680-F83E5E14DF8F}"/>
+                <a16:creationId xmlns:a16="http://schemas.microsoft.com/office/drawing/2014/main" id="{C37BFC27-3935-4859-852D-D39BAA0EAF0A}"/>
               </a:ext>
             </a:extLst>
           </p:cNvPr>
@@ -3770,7 +3770,7 @@
           <p:cNvPr id="2" name="">
             <a:extLst xmlns:a="http://schemas.openxmlformats.org/drawingml/2006/main">
               <a:ext uri="{FF2B5EF4-FFF2-40B4-BE49-F238E27FC236}">
-                <a16:creationId xmlns:a16="http://schemas.microsoft.com/office/drawing/2014/main" id="{6DA418BE-4E34-48F5-BB2F-B107C69B409B}"/>
+                <a16:creationId xmlns:a16="http://schemas.microsoft.com/office/drawing/2014/main" id="{9A3A2A06-79C8-4669-AF6B-DD4CBC2EA466}"/>
               </a:ext>
             </a:extLst>
           </p:cNvPr>
@@ -3801,7 +3801,7 @@
           <p:cNvPr id="3" name="">
             <a:extLst xmlns:a="http://schemas.openxmlformats.org/drawingml/2006/main">
               <a:ext uri="{FF2B5EF4-FFF2-40B4-BE49-F238E27FC236}">
-                <a16:creationId xmlns:a16="http://schemas.microsoft.com/office/drawing/2014/main" id="{94A1870F-0C95-4EB5-AA12-1E27A42D4282}"/>
+                <a16:creationId xmlns:a16="http://schemas.microsoft.com/office/drawing/2014/main" id="{AF9A8AA9-849C-448A-8F14-FBAF15ADCC31}"/>
               </a:ext>
             </a:extLst>
           </p:cNvPr>
@@ -3870,7 +3870,7 @@
           <p:cNvPr id="4" name="">
             <a:extLst xmlns:a="http://schemas.openxmlformats.org/drawingml/2006/main">
               <a:ext uri="{FF2B5EF4-FFF2-40B4-BE49-F238E27FC236}">
-                <a16:creationId xmlns:a16="http://schemas.microsoft.com/office/drawing/2014/main" id="{308AB2FA-004E-401D-A43D-19376ABB9DEA}"/>
+                <a16:creationId xmlns:a16="http://schemas.microsoft.com/office/drawing/2014/main" id="{AB75F8D7-ED82-43BA-B82C-3F0ABB4198B7}"/>
               </a:ext>
             </a:extLst>
           </p:cNvPr>
@@ -3939,7 +3939,7 @@
           <p:cNvPr id="5" name="">
             <a:extLst xmlns:a="http://schemas.openxmlformats.org/drawingml/2006/main">
               <a:ext uri="{FF2B5EF4-FFF2-40B4-BE49-F238E27FC236}">
-                <a16:creationId xmlns:a16="http://schemas.microsoft.com/office/drawing/2014/main" id="{610A81AC-86D9-45AD-8A38-A8CA41C4659E}"/>
+                <a16:creationId xmlns:a16="http://schemas.microsoft.com/office/drawing/2014/main" id="{5BC3590A-31C4-4CF2-945B-D661D3DC029A}"/>
               </a:ext>
             </a:extLst>
           </p:cNvPr>
@@ -4008,7 +4008,7 @@
           <p:cNvPr id="6" name="">
             <a:extLst xmlns:a="http://schemas.openxmlformats.org/drawingml/2006/main">
               <a:ext uri="{FF2B5EF4-FFF2-40B4-BE49-F238E27FC236}">
-                <a16:creationId xmlns:a16="http://schemas.microsoft.com/office/drawing/2014/main" id="{ED6ADB34-41A3-4361-9930-AB68CABDF7DE}"/>
+                <a16:creationId xmlns:a16="http://schemas.microsoft.com/office/drawing/2014/main" id="{F7CC3160-0393-44BA-9445-E9B3CAB8A1F7}"/>
               </a:ext>
             </a:extLst>
           </p:cNvPr>
@@ -4039,7 +4039,7 @@
           <p:cNvPr id="7" name="">
             <a:extLst xmlns:a="http://schemas.openxmlformats.org/drawingml/2006/main">
               <a:ext uri="{FF2B5EF4-FFF2-40B4-BE49-F238E27FC236}">
-                <a16:creationId xmlns:a16="http://schemas.microsoft.com/office/drawing/2014/main" id="{317FB412-8E0B-40FD-BC19-7882E0BB6142}"/>
+                <a16:creationId xmlns:a16="http://schemas.microsoft.com/office/drawing/2014/main" id="{E6D5FA6E-C841-4624-BD5B-23D22B33A43C}"/>
               </a:ext>
             </a:extLst>
           </p:cNvPr>
@@ -4106,7 +4106,7 @@
     </p:spTree>
     <p:extLst>
       <p:ext uri="{BB962C8B-B14F-4D97-AF65-F5344CB8AC3E}">
-        <p14:creationId xmlns:p14="http://schemas.microsoft.com/office/powerpoint/2010/main" val="143147074"/>
+        <p14:creationId xmlns:p14="http://schemas.microsoft.com/office/powerpoint/2010/main" val="220179917"/>
       </p:ext>
     </p:extLst>
   </p:cSld>
@@ -4137,7 +4137,7 @@
           <p:cNvPr id="15" name="">
             <a:extLst xmlns:a="http://schemas.openxmlformats.org/drawingml/2006/main">
               <a:ext uri="{FF2B5EF4-FFF2-40B4-BE49-F238E27FC236}">
-                <a16:creationId xmlns:a16="http://schemas.microsoft.com/office/drawing/2014/main" id="{93060B0F-DA74-4D51-8E96-AF8EF25C06B1}"/>
+                <a16:creationId xmlns:a16="http://schemas.microsoft.com/office/drawing/2014/main" id="{D4806279-19E4-45A5-B28A-21E876C76B23}"/>
               </a:ext>
             </a:extLst>
           </p:cNvPr>
@@ -4206,7 +4206,7 @@
           <p:cNvPr id="2" name="">
             <a:extLst xmlns:a="http://schemas.openxmlformats.org/drawingml/2006/main">
               <a:ext uri="{FF2B5EF4-FFF2-40B4-BE49-F238E27FC236}">
-                <a16:creationId xmlns:a16="http://schemas.microsoft.com/office/drawing/2014/main" id="{62C90395-4D74-47AA-82DC-42EA1A8A38CD}"/>
+                <a16:creationId xmlns:a16="http://schemas.microsoft.com/office/drawing/2014/main" id="{06C63CAB-EF2C-4BD1-8DDE-4E6B6DDA0153}"/>
               </a:ext>
             </a:extLst>
           </p:cNvPr>
@@ -4237,7 +4237,7 @@
           <p:cNvPr id="3" name="">
             <a:extLst xmlns:a="http://schemas.openxmlformats.org/drawingml/2006/main">
               <a:ext uri="{FF2B5EF4-FFF2-40B4-BE49-F238E27FC236}">
-                <a16:creationId xmlns:a16="http://schemas.microsoft.com/office/drawing/2014/main" id="{F13F1B9F-4506-46BF-8830-613B07EC4E26}"/>
+                <a16:creationId xmlns:a16="http://schemas.microsoft.com/office/drawing/2014/main" id="{5A708AFF-5D6F-441A-BCDA-CAA552059280}"/>
               </a:ext>
             </a:extLst>
           </p:cNvPr>
@@ -4306,7 +4306,7 @@
           <p:cNvPr id="4" name="">
             <a:extLst xmlns:a="http://schemas.openxmlformats.org/drawingml/2006/main">
               <a:ext uri="{FF2B5EF4-FFF2-40B4-BE49-F238E27FC236}">
-                <a16:creationId xmlns:a16="http://schemas.microsoft.com/office/drawing/2014/main" id="{D4C8C888-7708-4EAD-8B09-E2AF9C7317B2}"/>
+                <a16:creationId xmlns:a16="http://schemas.microsoft.com/office/drawing/2014/main" id="{2AB42D60-A08C-496F-A3D9-DB373C0B929E}"/>
               </a:ext>
             </a:extLst>
           </p:cNvPr>
@@ -4375,7 +4375,7 @@
           <p:cNvPr id="5" name="">
             <a:extLst xmlns:a="http://schemas.openxmlformats.org/drawingml/2006/main">
               <a:ext uri="{FF2B5EF4-FFF2-40B4-BE49-F238E27FC236}">
-                <a16:creationId xmlns:a16="http://schemas.microsoft.com/office/drawing/2014/main" id="{D3661B15-5B5A-4013-982D-B0DB05E57CA0}"/>
+                <a16:creationId xmlns:a16="http://schemas.microsoft.com/office/drawing/2014/main" id="{C5829215-146F-4410-BB1F-D0BEE3F64030}"/>
               </a:ext>
             </a:extLst>
           </p:cNvPr>
@@ -4434,7 +4434,7 @@
                 <a:ea typeface="Arial"/>
                 <a:cs typeface="Arial"/>
               </a:rPr>
-              <a:t>Run v2 on a public article</a:t>
+              <a:t>Finish the live rubric</a:t>
             </a:r>
           </a:p>
         </p:txBody>
@@ -4444,7 +4444,7 @@
           <p:cNvPr id="6" name="">
             <a:extLst xmlns:a="http://schemas.openxmlformats.org/drawingml/2006/main">
               <a:ext uri="{FF2B5EF4-FFF2-40B4-BE49-F238E27FC236}">
-                <a16:creationId xmlns:a16="http://schemas.microsoft.com/office/drawing/2014/main" id="{206EEC04-97BA-44A5-818B-AFB3A650EC43}"/>
+                <a16:creationId xmlns:a16="http://schemas.microsoft.com/office/drawing/2014/main" id="{2298A181-BC76-4608-B82C-B3328D5C028E}"/>
               </a:ext>
             </a:extLst>
           </p:cNvPr>
@@ -4503,7 +4503,7 @@
                 <a:ea typeface="Arial"/>
                 <a:cs typeface="Arial"/>
               </a:rPr>
-              <a:t>Record status, analysis ID, and time.</a:t>
+              <a:t>Fix validation; rerun on a public article.</a:t>
             </a:r>
           </a:p>
         </p:txBody>
@@ -4513,7 +4513,7 @@
           <p:cNvPr id="7" name="">
             <a:extLst xmlns:a="http://schemas.openxmlformats.org/drawingml/2006/main">
               <a:ext uri="{FF2B5EF4-FFF2-40B4-BE49-F238E27FC236}">
-                <a16:creationId xmlns:a16="http://schemas.microsoft.com/office/drawing/2014/main" id="{4466E6A7-D65A-4798-8363-B2AD40F1FE4A}"/>
+                <a16:creationId xmlns:a16="http://schemas.microsoft.com/office/drawing/2014/main" id="{459FC6CC-4AD5-47AA-A902-62F6B05D89D0}"/>
               </a:ext>
             </a:extLst>
           </p:cNvPr>
@@ -4544,7 +4544,7 @@
           <p:cNvPr id="8" name="">
             <a:extLst xmlns:a="http://schemas.openxmlformats.org/drawingml/2006/main">
               <a:ext uri="{FF2B5EF4-FFF2-40B4-BE49-F238E27FC236}">
-                <a16:creationId xmlns:a16="http://schemas.microsoft.com/office/drawing/2014/main" id="{9D7FEB54-3D0D-48BB-9D5B-D1DE170746E0}"/>
+                <a16:creationId xmlns:a16="http://schemas.microsoft.com/office/drawing/2014/main" id="{1F3E9AFC-394D-4E91-BD31-2F79C5889B5B}"/>
               </a:ext>
             </a:extLst>
           </p:cNvPr>
@@ -4613,7 +4613,7 @@
           <p:cNvPr id="9" name="">
             <a:extLst xmlns:a="http://schemas.openxmlformats.org/drawingml/2006/main">
               <a:ext uri="{FF2B5EF4-FFF2-40B4-BE49-F238E27FC236}">
-                <a16:creationId xmlns:a16="http://schemas.microsoft.com/office/drawing/2014/main" id="{A335263F-02B5-433B-B5A0-5CD758CF91B0}"/>
+                <a16:creationId xmlns:a16="http://schemas.microsoft.com/office/drawing/2014/main" id="{33A7E74B-DDDA-42C2-B1C5-377A3107760A}"/>
               </a:ext>
             </a:extLst>
           </p:cNvPr>
@@ -4682,7 +4682,7 @@
           <p:cNvPr id="10" name="">
             <a:extLst xmlns:a="http://schemas.openxmlformats.org/drawingml/2006/main">
               <a:ext uri="{FF2B5EF4-FFF2-40B4-BE49-F238E27FC236}">
-                <a16:creationId xmlns:a16="http://schemas.microsoft.com/office/drawing/2014/main" id="{2425F00E-B335-45F1-9C04-E6FE23269194}"/>
+                <a16:creationId xmlns:a16="http://schemas.microsoft.com/office/drawing/2014/main" id="{8D0205B5-45C5-41A8-BDB1-78BAAA466D05}"/>
               </a:ext>
             </a:extLst>
           </p:cNvPr>
@@ -4751,7 +4751,7 @@
           <p:cNvPr id="11" name="">
             <a:extLst xmlns:a="http://schemas.openxmlformats.org/drawingml/2006/main">
               <a:ext uri="{FF2B5EF4-FFF2-40B4-BE49-F238E27FC236}">
-                <a16:creationId xmlns:a16="http://schemas.microsoft.com/office/drawing/2014/main" id="{3D424012-74FA-45BD-9169-69FD3A6D584F}"/>
+                <a16:creationId xmlns:a16="http://schemas.microsoft.com/office/drawing/2014/main" id="{7CDEAB85-DBA5-4C35-BC7E-DA5FD4199C40}"/>
               </a:ext>
             </a:extLst>
           </p:cNvPr>
@@ -4782,7 +4782,7 @@
           <p:cNvPr id="12" name="">
             <a:extLst xmlns:a="http://schemas.openxmlformats.org/drawingml/2006/main">
               <a:ext uri="{FF2B5EF4-FFF2-40B4-BE49-F238E27FC236}">
-                <a16:creationId xmlns:a16="http://schemas.microsoft.com/office/drawing/2014/main" id="{5ACF0AE0-D94D-491A-AC61-E3E339805D51}"/>
+                <a16:creationId xmlns:a16="http://schemas.microsoft.com/office/drawing/2014/main" id="{A5559962-5535-4673-84E4-FC9C5B8FE64C}"/>
               </a:ext>
             </a:extLst>
           </p:cNvPr>
@@ -4851,7 +4851,7 @@
           <p:cNvPr id="13" name="">
             <a:extLst xmlns:a="http://schemas.openxmlformats.org/drawingml/2006/main">
               <a:ext uri="{FF2B5EF4-FFF2-40B4-BE49-F238E27FC236}">
-                <a16:creationId xmlns:a16="http://schemas.microsoft.com/office/drawing/2014/main" id="{349641CD-77E7-4B52-882A-22ABB720F001}"/>
+                <a16:creationId xmlns:a16="http://schemas.microsoft.com/office/drawing/2014/main" id="{58FDEF94-8331-408E-9E0C-115AE12BF0FD}"/>
               </a:ext>
             </a:extLst>
           </p:cNvPr>
@@ -4920,7 +4920,7 @@
           <p:cNvPr id="14" name="">
             <a:extLst xmlns:a="http://schemas.openxmlformats.org/drawingml/2006/main">
               <a:ext uri="{FF2B5EF4-FFF2-40B4-BE49-F238E27FC236}">
-                <a16:creationId xmlns:a16="http://schemas.microsoft.com/office/drawing/2014/main" id="{3C7B8548-F033-4FC6-A35A-4344FF4BCF8C}"/>
+                <a16:creationId xmlns:a16="http://schemas.microsoft.com/office/drawing/2014/main" id="{E6577B50-2E06-4440-9455-93B7E109885C}"/>
               </a:ext>
             </a:extLst>
           </p:cNvPr>
@@ -4979,7 +4979,7 @@
                 <a:ea typeface="Arial"/>
                 <a:cs typeface="Arial"/>
               </a:rPr>
-              <a:t>Use that backend and APK; show the source page.</a:t>
+              <a:t>Retest on a device; show the source page.</a:t>
             </a:r>
           </a:p>
         </p:txBody>
@@ -4987,7 +4987,7 @@
     </p:spTree>
     <p:extLst>
       <p:ext uri="{BB962C8B-B14F-4D97-AF65-F5344CB8AC3E}">
-        <p14:creationId xmlns:p14="http://schemas.microsoft.com/office/powerpoint/2010/main" val="1302224683"/>
+        <p14:creationId xmlns:p14="http://schemas.microsoft.com/office/powerpoint/2010/main" val="760675873"/>
       </p:ext>
     </p:extLst>
   </p:cSld>
@@ -5018,7 +5018,7 @@
           <p:cNvPr id="10" name="">
             <a:extLst xmlns:a="http://schemas.openxmlformats.org/drawingml/2006/main">
               <a:ext uri="{FF2B5EF4-FFF2-40B4-BE49-F238E27FC236}">
-                <a16:creationId xmlns:a16="http://schemas.microsoft.com/office/drawing/2014/main" id="{42FCCC7C-7BC6-406C-8BCB-B382BC044883}"/>
+                <a16:creationId xmlns:a16="http://schemas.microsoft.com/office/drawing/2014/main" id="{3591C18E-95E1-4442-B792-4B506816661E}"/>
               </a:ext>
             </a:extLst>
           </p:cNvPr>
@@ -5087,7 +5087,7 @@
           <p:cNvPr id="2" name="">
             <a:extLst xmlns:a="http://schemas.openxmlformats.org/drawingml/2006/main">
               <a:ext uri="{FF2B5EF4-FFF2-40B4-BE49-F238E27FC236}">
-                <a16:creationId xmlns:a16="http://schemas.microsoft.com/office/drawing/2014/main" id="{8D756D50-B045-4D36-BEB2-345F5B1E8983}"/>
+                <a16:creationId xmlns:a16="http://schemas.microsoft.com/office/drawing/2014/main" id="{129A6E83-973B-4F94-B47A-E4304B84EA0C}"/>
               </a:ext>
             </a:extLst>
           </p:cNvPr>
@@ -5118,7 +5118,7 @@
           <p:cNvPr id="3" name="">
             <a:extLst xmlns:a="http://schemas.openxmlformats.org/drawingml/2006/main">
               <a:ext uri="{FF2B5EF4-FFF2-40B4-BE49-F238E27FC236}">
-                <a16:creationId xmlns:a16="http://schemas.microsoft.com/office/drawing/2014/main" id="{DFEC4383-A086-4850-B6EB-0DB9A276DBA2}"/>
+                <a16:creationId xmlns:a16="http://schemas.microsoft.com/office/drawing/2014/main" id="{368C5B1C-7458-4EF6-B56A-492F37054078}"/>
               </a:ext>
             </a:extLst>
           </p:cNvPr>
@@ -5187,7 +5187,7 @@
           <p:cNvPr id="4" name="">
             <a:extLst xmlns:a="http://schemas.openxmlformats.org/drawingml/2006/main">
               <a:ext uri="{FF2B5EF4-FFF2-40B4-BE49-F238E27FC236}">
-                <a16:creationId xmlns:a16="http://schemas.microsoft.com/office/drawing/2014/main" id="{313FE0A2-BD2F-42B6-864D-7D3B9E061F82}"/>
+                <a16:creationId xmlns:a16="http://schemas.microsoft.com/office/drawing/2014/main" id="{ACD907D4-BC9B-4A6A-A6F2-20007F56BA51}"/>
               </a:ext>
             </a:extLst>
           </p:cNvPr>
@@ -5279,7 +5279,7 @@
           <p:cNvPr id="5" name="">
             <a:extLst xmlns:a="http://schemas.openxmlformats.org/drawingml/2006/main">
               <a:ext uri="{FF2B5EF4-FFF2-40B4-BE49-F238E27FC236}">
-                <a16:creationId xmlns:a16="http://schemas.microsoft.com/office/drawing/2014/main" id="{90ACEDB9-0BF4-4660-9FC8-4D9D7ABDA815}"/>
+                <a16:creationId xmlns:a16="http://schemas.microsoft.com/office/drawing/2014/main" id="{8E0FF2B6-0FCB-4027-AF12-471226D5C6DF}"/>
               </a:ext>
             </a:extLst>
           </p:cNvPr>
@@ -5310,7 +5310,7 @@
           <p:cNvPr id="6" name="">
             <a:extLst xmlns:a="http://schemas.openxmlformats.org/drawingml/2006/main">
               <a:ext uri="{FF2B5EF4-FFF2-40B4-BE49-F238E27FC236}">
-                <a16:creationId xmlns:a16="http://schemas.microsoft.com/office/drawing/2014/main" id="{BB770AA4-52F7-45F4-89DA-D83C02B27349}"/>
+                <a16:creationId xmlns:a16="http://schemas.microsoft.com/office/drawing/2014/main" id="{295BC7D6-1570-4FD1-9442-E07B09DF1D72}"/>
               </a:ext>
             </a:extLst>
           </p:cNvPr>
@@ -5379,7 +5379,7 @@
           <p:cNvPr id="7" name="">
             <a:extLst xmlns:a="http://schemas.openxmlformats.org/drawingml/2006/main">
               <a:ext uri="{FF2B5EF4-FFF2-40B4-BE49-F238E27FC236}">
-                <a16:creationId xmlns:a16="http://schemas.microsoft.com/office/drawing/2014/main" id="{39D62575-6306-4B76-9E1D-A6D867418B18}"/>
+                <a16:creationId xmlns:a16="http://schemas.microsoft.com/office/drawing/2014/main" id="{8FE2CAB0-A4B8-4382-8A6E-353C0F2CCB86}"/>
               </a:ext>
             </a:extLst>
           </p:cNvPr>
@@ -5438,7 +5438,7 @@
                 <a:ea typeface="Arial"/>
                 <a:cs typeface="Arial"/>
               </a:rPr>
-              <a:t>IDs, quote spans, source links, failure states</a:t>
+              <a:t>IDs, quotes, links, failure states</a:t>
             </a:r>
           </a:p>
         </p:txBody>
@@ -5448,7 +5448,7 @@
           <p:cNvPr id="8" name="">
             <a:extLst xmlns:a="http://schemas.openxmlformats.org/drawingml/2006/main">
               <a:ext uri="{FF2B5EF4-FFF2-40B4-BE49-F238E27FC236}">
-                <a16:creationId xmlns:a16="http://schemas.microsoft.com/office/drawing/2014/main" id="{DF79302B-8D77-4B3D-91DE-3D1B1E58E601}"/>
+                <a16:creationId xmlns:a16="http://schemas.microsoft.com/office/drawing/2014/main" id="{061BB852-6585-4698-9FD9-41A3739F87A4}"/>
               </a:ext>
             </a:extLst>
           </p:cNvPr>
@@ -5517,7 +5517,7 @@
           <p:cNvPr id="9" name="">
             <a:extLst xmlns:a="http://schemas.openxmlformats.org/drawingml/2006/main">
               <a:ext uri="{FF2B5EF4-FFF2-40B4-BE49-F238E27FC236}">
-                <a16:creationId xmlns:a16="http://schemas.microsoft.com/office/drawing/2014/main" id="{B1FD0644-C7C4-4474-A26B-977F9FE6B0D7}"/>
+                <a16:creationId xmlns:a16="http://schemas.microsoft.com/office/drawing/2014/main" id="{9DF521AA-A8B8-4586-B800-52FB8D4391BE}"/>
               </a:ext>
             </a:extLst>
           </p:cNvPr>
@@ -5576,7 +5576,7 @@
                 <a:ea typeface="Arial"/>
                 <a:cs typeface="Arial"/>
               </a:rPr>
-              <a:t>Same-event selection and the meaning of each comparison</a:t>
+              <a:t>Event selection and what each comparison means</a:t>
             </a:r>
           </a:p>
         </p:txBody>
@@ -5584,7 +5584,7 @@
     </p:spTree>
     <p:extLst>
       <p:ext uri="{BB962C8B-B14F-4D97-AF65-F5344CB8AC3E}">
-        <p14:creationId xmlns:p14="http://schemas.microsoft.com/office/powerpoint/2010/main" val="190850223"/>
+        <p14:creationId xmlns:p14="http://schemas.microsoft.com/office/powerpoint/2010/main" val="1015216301"/>
       </p:ext>
     </p:extLst>
   </p:cSld>
@@ -5615,7 +5615,7 @@
           <p:cNvPr id="12" name="">
             <a:extLst xmlns:a="http://schemas.openxmlformats.org/drawingml/2006/main">
               <a:ext uri="{FF2B5EF4-FFF2-40B4-BE49-F238E27FC236}">
-                <a16:creationId xmlns:a16="http://schemas.microsoft.com/office/drawing/2014/main" id="{96400A45-3E58-4F98-861C-7098DFE91DEF}"/>
+                <a16:creationId xmlns:a16="http://schemas.microsoft.com/office/drawing/2014/main" id="{0CD1C99E-869E-4F0D-93E1-E0C8508BE0CE}"/>
               </a:ext>
             </a:extLst>
           </p:cNvPr>
@@ -5684,7 +5684,7 @@
           <p:cNvPr id="2" name="">
             <a:extLst xmlns:a="http://schemas.openxmlformats.org/drawingml/2006/main">
               <a:ext uri="{FF2B5EF4-FFF2-40B4-BE49-F238E27FC236}">
-                <a16:creationId xmlns:a16="http://schemas.microsoft.com/office/drawing/2014/main" id="{FC810F4A-DBB1-43DF-AC3B-440AB14B1FE4}"/>
+                <a16:creationId xmlns:a16="http://schemas.microsoft.com/office/drawing/2014/main" id="{BC14896E-3F7F-4DFE-858C-CF88AA8EE557}"/>
               </a:ext>
             </a:extLst>
           </p:cNvPr>
@@ -5715,7 +5715,7 @@
           <p:cNvPr id="3" name="">
             <a:extLst xmlns:a="http://schemas.openxmlformats.org/drawingml/2006/main">
               <a:ext uri="{FF2B5EF4-FFF2-40B4-BE49-F238E27FC236}">
-                <a16:creationId xmlns:a16="http://schemas.microsoft.com/office/drawing/2014/main" id="{0BFAC7EC-FCB5-4AD4-B4ED-5CF9CD64BB01}"/>
+                <a16:creationId xmlns:a16="http://schemas.microsoft.com/office/drawing/2014/main" id="{79885F86-C138-4CE9-B674-0BEAB74903B1}"/>
               </a:ext>
             </a:extLst>
           </p:cNvPr>
@@ -5784,7 +5784,7 @@
           <p:cNvPr id="4" name="">
             <a:extLst xmlns:a="http://schemas.openxmlformats.org/drawingml/2006/main">
               <a:ext uri="{FF2B5EF4-FFF2-40B4-BE49-F238E27FC236}">
-                <a16:creationId xmlns:a16="http://schemas.microsoft.com/office/drawing/2014/main" id="{C366F713-F977-4BE1-A932-763AB9C192A2}"/>
+                <a16:creationId xmlns:a16="http://schemas.microsoft.com/office/drawing/2014/main" id="{559D1A03-6EA1-45E4-9B0B-3873FCF10536}"/>
               </a:ext>
             </a:extLst>
           </p:cNvPr>
@@ -5876,7 +5876,7 @@
           <p:cNvPr id="5" name="">
             <a:extLst xmlns:a="http://schemas.openxmlformats.org/drawingml/2006/main">
               <a:ext uri="{FF2B5EF4-FFF2-40B4-BE49-F238E27FC236}">
-                <a16:creationId xmlns:a16="http://schemas.microsoft.com/office/drawing/2014/main" id="{A8AE2B65-2574-4296-B6F6-8A581C24E7BE}"/>
+                <a16:creationId xmlns:a16="http://schemas.microsoft.com/office/drawing/2014/main" id="{4EFACF4E-A338-44B4-AC37-F8299F8A3A42}"/>
               </a:ext>
             </a:extLst>
           </p:cNvPr>
@@ -5907,7 +5907,7 @@
           <p:cNvPr id="6" name="">
             <a:extLst xmlns:a="http://schemas.openxmlformats.org/drawingml/2006/main">
               <a:ext uri="{FF2B5EF4-FFF2-40B4-BE49-F238E27FC236}">
-                <a16:creationId xmlns:a16="http://schemas.microsoft.com/office/drawing/2014/main" id="{804C0613-B081-49A3-A661-FD595327423C}"/>
+                <a16:creationId xmlns:a16="http://schemas.microsoft.com/office/drawing/2014/main" id="{611CB095-B63A-4551-849F-A9B2DCD0C3DA}"/>
               </a:ext>
             </a:extLst>
           </p:cNvPr>
@@ -5976,7 +5976,7 @@
           <p:cNvPr id="7" name="">
             <a:extLst xmlns:a="http://schemas.openxmlformats.org/drawingml/2006/main">
               <a:ext uri="{FF2B5EF4-FFF2-40B4-BE49-F238E27FC236}">
-                <a16:creationId xmlns:a16="http://schemas.microsoft.com/office/drawing/2014/main" id="{06488C27-651F-4176-BB53-3261404EB9EF}"/>
+                <a16:creationId xmlns:a16="http://schemas.microsoft.com/office/drawing/2014/main" id="{55A8B8B8-47F3-4502-BF0D-0A75B7F7B93D}"/>
               </a:ext>
             </a:extLst>
           </p:cNvPr>
@@ -6045,7 +6045,7 @@
           <p:cNvPr id="8" name="">
             <a:extLst xmlns:a="http://schemas.openxmlformats.org/drawingml/2006/main">
               <a:ext uri="{FF2B5EF4-FFF2-40B4-BE49-F238E27FC236}">
-                <a16:creationId xmlns:a16="http://schemas.microsoft.com/office/drawing/2014/main" id="{FCB1A60B-D5EE-4A28-A3C9-BD229A249692}"/>
+                <a16:creationId xmlns:a16="http://schemas.microsoft.com/office/drawing/2014/main" id="{2D1C3503-0956-47F7-AED4-4D6F79770674}"/>
               </a:ext>
             </a:extLst>
           </p:cNvPr>
@@ -6114,7 +6114,7 @@
           <p:cNvPr id="9" name="">
             <a:extLst xmlns:a="http://schemas.openxmlformats.org/drawingml/2006/main">
               <a:ext uri="{FF2B5EF4-FFF2-40B4-BE49-F238E27FC236}">
-                <a16:creationId xmlns:a16="http://schemas.microsoft.com/office/drawing/2014/main" id="{94E80108-503B-4A7D-AE92-897B4F31092A}"/>
+                <a16:creationId xmlns:a16="http://schemas.microsoft.com/office/drawing/2014/main" id="{B0F1FBCD-7E60-4F2C-AD75-A635356E1C81}"/>
               </a:ext>
             </a:extLst>
           </p:cNvPr>
@@ -6183,7 +6183,7 @@
           <p:cNvPr id="10" name="">
             <a:extLst xmlns:a="http://schemas.openxmlformats.org/drawingml/2006/main">
               <a:ext uri="{FF2B5EF4-FFF2-40B4-BE49-F238E27FC236}">
-                <a16:creationId xmlns:a16="http://schemas.microsoft.com/office/drawing/2014/main" id="{B0D4BCD1-873A-47A8-89D3-97504EA945B9}"/>
+                <a16:creationId xmlns:a16="http://schemas.microsoft.com/office/drawing/2014/main" id="{EB513D0B-CF50-4BBA-988D-15EEC02F7C22}"/>
               </a:ext>
             </a:extLst>
           </p:cNvPr>
@@ -6252,7 +6252,7 @@
           <p:cNvPr id="11" name="">
             <a:extLst xmlns:a="http://schemas.openxmlformats.org/drawingml/2006/main">
               <a:ext uri="{FF2B5EF4-FFF2-40B4-BE49-F238E27FC236}">
-                <a16:creationId xmlns:a16="http://schemas.microsoft.com/office/drawing/2014/main" id="{BA5D6C51-4295-4DAF-9F13-F9B6091C53CA}"/>
+                <a16:creationId xmlns:a16="http://schemas.microsoft.com/office/drawing/2014/main" id="{A0FD1AD7-7007-4905-88BB-830CE51BB7F5}"/>
               </a:ext>
             </a:extLst>
           </p:cNvPr>
@@ -6319,7 +6319,7 @@
     </p:spTree>
     <p:extLst>
       <p:ext uri="{BB962C8B-B14F-4D97-AF65-F5344CB8AC3E}">
-        <p14:creationId xmlns:p14="http://schemas.microsoft.com/office/powerpoint/2010/main" val="1073557832"/>
+        <p14:creationId xmlns:p14="http://schemas.microsoft.com/office/powerpoint/2010/main" val="2143914795"/>
       </p:ext>
     </p:extLst>
   </p:cSld>
@@ -6350,7 +6350,7 @@
           <p:cNvPr id="19" name="">
             <a:extLst xmlns:a="http://schemas.openxmlformats.org/drawingml/2006/main">
               <a:ext uri="{FF2B5EF4-FFF2-40B4-BE49-F238E27FC236}">
-                <a16:creationId xmlns:a16="http://schemas.microsoft.com/office/drawing/2014/main" id="{5A70B6FA-10D9-4EE6-A4CB-9FDDD50B20E4}"/>
+                <a16:creationId xmlns:a16="http://schemas.microsoft.com/office/drawing/2014/main" id="{B6CFFF3D-6B63-4932-8791-1156CF74627D}"/>
               </a:ext>
             </a:extLst>
           </p:cNvPr>
@@ -6419,7 +6419,7 @@
           <p:cNvPr id="2" name="">
             <a:extLst xmlns:a="http://schemas.openxmlformats.org/drawingml/2006/main">
               <a:ext uri="{FF2B5EF4-FFF2-40B4-BE49-F238E27FC236}">
-                <a16:creationId xmlns:a16="http://schemas.microsoft.com/office/drawing/2014/main" id="{6840B659-846C-4621-8998-F65FE29E58AC}"/>
+                <a16:creationId xmlns:a16="http://schemas.microsoft.com/office/drawing/2014/main" id="{FBC16ED3-EE75-4CA2-96D2-D709A809DE4C}"/>
               </a:ext>
             </a:extLst>
           </p:cNvPr>
@@ -6450,7 +6450,7 @@
           <p:cNvPr id="3" name="">
             <a:extLst xmlns:a="http://schemas.openxmlformats.org/drawingml/2006/main">
               <a:ext uri="{FF2B5EF4-FFF2-40B4-BE49-F238E27FC236}">
-                <a16:creationId xmlns:a16="http://schemas.microsoft.com/office/drawing/2014/main" id="{929B7A99-5B2E-4452-8C44-470DEED7AC11}"/>
+                <a16:creationId xmlns:a16="http://schemas.microsoft.com/office/drawing/2014/main" id="{59D3E984-AF98-4E49-A8A4-B57961B63F5F}"/>
               </a:ext>
             </a:extLst>
           </p:cNvPr>
@@ -6519,7 +6519,7 @@
           <p:cNvPr id="4" name="">
             <a:extLst xmlns:a="http://schemas.openxmlformats.org/drawingml/2006/main">
               <a:ext uri="{FF2B5EF4-FFF2-40B4-BE49-F238E27FC236}">
-                <a16:creationId xmlns:a16="http://schemas.microsoft.com/office/drawing/2014/main" id="{CF85703D-C98C-489B-9577-EE897B99B6E2}"/>
+                <a16:creationId xmlns:a16="http://schemas.microsoft.com/office/drawing/2014/main" id="{A49786DC-937A-40E0-9F00-CC86E0F8C256}"/>
               </a:ext>
             </a:extLst>
           </p:cNvPr>
@@ -6588,7 +6588,7 @@
           <p:cNvPr id="5" name="">
             <a:extLst xmlns:a="http://schemas.openxmlformats.org/drawingml/2006/main">
               <a:ext uri="{FF2B5EF4-FFF2-40B4-BE49-F238E27FC236}">
-                <a16:creationId xmlns:a16="http://schemas.microsoft.com/office/drawing/2014/main" id="{DE136DA4-5792-4529-8413-745398F1D04C}"/>
+                <a16:creationId xmlns:a16="http://schemas.microsoft.com/office/drawing/2014/main" id="{7B753E87-E3D4-4E03-A6B9-F7B3FFC16209}"/>
               </a:ext>
             </a:extLst>
           </p:cNvPr>
@@ -6657,7 +6657,7 @@
           <p:cNvPr id="6" name="">
             <a:extLst xmlns:a="http://schemas.openxmlformats.org/drawingml/2006/main">
               <a:ext uri="{FF2B5EF4-FFF2-40B4-BE49-F238E27FC236}">
-                <a16:creationId xmlns:a16="http://schemas.microsoft.com/office/drawing/2014/main" id="{1306CDFD-B66D-45EB-9FF3-80FF2B3B8763}"/>
+                <a16:creationId xmlns:a16="http://schemas.microsoft.com/office/drawing/2014/main" id="{B429C2F5-B85C-4422-AC5F-53AA7A00609F}"/>
               </a:ext>
             </a:extLst>
           </p:cNvPr>
@@ -6726,7 +6726,7 @@
           <p:cNvPr id="7" name="">
             <a:extLst xmlns:a="http://schemas.openxmlformats.org/drawingml/2006/main">
               <a:ext uri="{FF2B5EF4-FFF2-40B4-BE49-F238E27FC236}">
-                <a16:creationId xmlns:a16="http://schemas.microsoft.com/office/drawing/2014/main" id="{CB69336D-E651-43AD-9B9D-A5273514BCFF}"/>
+                <a16:creationId xmlns:a16="http://schemas.microsoft.com/office/drawing/2014/main" id="{2AF2CC1E-F69A-4000-A889-9C47496F5E95}"/>
               </a:ext>
             </a:extLst>
           </p:cNvPr>
@@ -6757,7 +6757,7 @@
           <p:cNvPr id="8" name="">
             <a:extLst xmlns:a="http://schemas.openxmlformats.org/drawingml/2006/main">
               <a:ext uri="{FF2B5EF4-FFF2-40B4-BE49-F238E27FC236}">
-                <a16:creationId xmlns:a16="http://schemas.microsoft.com/office/drawing/2014/main" id="{1CBCC2E7-9388-4244-A8C1-FE219E6BC1BC}"/>
+                <a16:creationId xmlns:a16="http://schemas.microsoft.com/office/drawing/2014/main" id="{93980D85-CA22-4514-88D0-A50212888CC8}"/>
               </a:ext>
             </a:extLst>
           </p:cNvPr>
@@ -6826,7 +6826,7 @@
           <p:cNvPr id="9" name="">
             <a:extLst xmlns:a="http://schemas.openxmlformats.org/drawingml/2006/main">
               <a:ext uri="{FF2B5EF4-FFF2-40B4-BE49-F238E27FC236}">
-                <a16:creationId xmlns:a16="http://schemas.microsoft.com/office/drawing/2014/main" id="{F9CA9326-689A-4182-87A9-49CC7C3E8757}"/>
+                <a16:creationId xmlns:a16="http://schemas.microsoft.com/office/drawing/2014/main" id="{26E3F224-F209-41D3-933C-97C2569DF4F5}"/>
               </a:ext>
             </a:extLst>
           </p:cNvPr>
@@ -6895,7 +6895,7 @@
           <p:cNvPr id="10" name="">
             <a:extLst xmlns:a="http://schemas.openxmlformats.org/drawingml/2006/main">
               <a:ext uri="{FF2B5EF4-FFF2-40B4-BE49-F238E27FC236}">
-                <a16:creationId xmlns:a16="http://schemas.microsoft.com/office/drawing/2014/main" id="{271ABCF5-8221-4653-8C01-A953179DE429}"/>
+                <a16:creationId xmlns:a16="http://schemas.microsoft.com/office/drawing/2014/main" id="{CB66D033-D401-414D-9466-C5609E1B7E1A}"/>
               </a:ext>
             </a:extLst>
           </p:cNvPr>
@@ -6964,7 +6964,7 @@
           <p:cNvPr id="11" name="">
             <a:extLst xmlns:a="http://schemas.openxmlformats.org/drawingml/2006/main">
               <a:ext uri="{FF2B5EF4-FFF2-40B4-BE49-F238E27FC236}">
-                <a16:creationId xmlns:a16="http://schemas.microsoft.com/office/drawing/2014/main" id="{B4B6C307-84D8-4EC2-80C2-EE80BE178C3F}"/>
+                <a16:creationId xmlns:a16="http://schemas.microsoft.com/office/drawing/2014/main" id="{A7DE95E5-52C0-449C-AA77-7AABE7B6B872}"/>
               </a:ext>
             </a:extLst>
           </p:cNvPr>
@@ -6995,7 +6995,7 @@
           <p:cNvPr id="12" name="">
             <a:extLst xmlns:a="http://schemas.openxmlformats.org/drawingml/2006/main">
               <a:ext uri="{FF2B5EF4-FFF2-40B4-BE49-F238E27FC236}">
-                <a16:creationId xmlns:a16="http://schemas.microsoft.com/office/drawing/2014/main" id="{B3E8F5A6-8D5C-4A3F-A7E4-CE4DDE42F145}"/>
+                <a16:creationId xmlns:a16="http://schemas.microsoft.com/office/drawing/2014/main" id="{1A8CCAA6-38FA-4358-AB78-ADB360323005}"/>
               </a:ext>
             </a:extLst>
           </p:cNvPr>
@@ -7064,7 +7064,7 @@
           <p:cNvPr id="13" name="">
             <a:extLst xmlns:a="http://schemas.openxmlformats.org/drawingml/2006/main">
               <a:ext uri="{FF2B5EF4-FFF2-40B4-BE49-F238E27FC236}">
-                <a16:creationId xmlns:a16="http://schemas.microsoft.com/office/drawing/2014/main" id="{637485D2-7C38-4F05-85C9-9A611902994E}"/>
+                <a16:creationId xmlns:a16="http://schemas.microsoft.com/office/drawing/2014/main" id="{F22E5244-5F0F-422D-95D9-292E761D4758}"/>
               </a:ext>
             </a:extLst>
           </p:cNvPr>
@@ -7133,7 +7133,7 @@
           <p:cNvPr id="14" name="">
             <a:extLst xmlns:a="http://schemas.openxmlformats.org/drawingml/2006/main">
               <a:ext uri="{FF2B5EF4-FFF2-40B4-BE49-F238E27FC236}">
-                <a16:creationId xmlns:a16="http://schemas.microsoft.com/office/drawing/2014/main" id="{32F25CD5-3C36-4115-8530-025D397240FD}"/>
+                <a16:creationId xmlns:a16="http://schemas.microsoft.com/office/drawing/2014/main" id="{A5FCA59F-F2C4-4D67-BD61-870064941D40}"/>
               </a:ext>
             </a:extLst>
           </p:cNvPr>
@@ -7202,7 +7202,7 @@
           <p:cNvPr id="15" name="">
             <a:extLst xmlns:a="http://schemas.openxmlformats.org/drawingml/2006/main">
               <a:ext uri="{FF2B5EF4-FFF2-40B4-BE49-F238E27FC236}">
-                <a16:creationId xmlns:a16="http://schemas.microsoft.com/office/drawing/2014/main" id="{3B2FC34F-4657-4C15-8623-78CD0AB93B82}"/>
+                <a16:creationId xmlns:a16="http://schemas.microsoft.com/office/drawing/2014/main" id="{E615625E-4AF5-43CF-9619-E80A126DDD6A}"/>
               </a:ext>
             </a:extLst>
           </p:cNvPr>
@@ -7233,7 +7233,7 @@
           <p:cNvPr id="16" name="">
             <a:extLst xmlns:a="http://schemas.openxmlformats.org/drawingml/2006/main">
               <a:ext uri="{FF2B5EF4-FFF2-40B4-BE49-F238E27FC236}">
-                <a16:creationId xmlns:a16="http://schemas.microsoft.com/office/drawing/2014/main" id="{80B18990-F7C7-49F8-AFF9-463A08FCAB49}"/>
+                <a16:creationId xmlns:a16="http://schemas.microsoft.com/office/drawing/2014/main" id="{1189DA3F-2A4F-40D7-B8F5-48ED4E7389B9}"/>
               </a:ext>
             </a:extLst>
           </p:cNvPr>
@@ -7302,7 +7302,7 @@
           <p:cNvPr id="17" name="">
             <a:extLst xmlns:a="http://schemas.openxmlformats.org/drawingml/2006/main">
               <a:ext uri="{FF2B5EF4-FFF2-40B4-BE49-F238E27FC236}">
-                <a16:creationId xmlns:a16="http://schemas.microsoft.com/office/drawing/2014/main" id="{F66598CB-8044-4521-B512-C9910908BB29}"/>
+                <a16:creationId xmlns:a16="http://schemas.microsoft.com/office/drawing/2014/main" id="{FDC56946-F9B6-4C21-83CC-CB30AC7F6805}"/>
               </a:ext>
             </a:extLst>
           </p:cNvPr>
@@ -7371,7 +7371,7 @@
           <p:cNvPr id="18" name="">
             <a:extLst xmlns:a="http://schemas.openxmlformats.org/drawingml/2006/main">
               <a:ext uri="{FF2B5EF4-FFF2-40B4-BE49-F238E27FC236}">
-                <a16:creationId xmlns:a16="http://schemas.microsoft.com/office/drawing/2014/main" id="{2E50E5AA-C281-43B5-BD6E-4CD21B7E30EB}"/>
+                <a16:creationId xmlns:a16="http://schemas.microsoft.com/office/drawing/2014/main" id="{343EDB1C-006C-444E-8012-B16923B5A705}"/>
               </a:ext>
             </a:extLst>
           </p:cNvPr>
@@ -7438,7 +7438,7 @@
     </p:spTree>
     <p:extLst>
       <p:ext uri="{BB962C8B-B14F-4D97-AF65-F5344CB8AC3E}">
-        <p14:creationId xmlns:p14="http://schemas.microsoft.com/office/powerpoint/2010/main" val="1366648011"/>
+        <p14:creationId xmlns:p14="http://schemas.microsoft.com/office/powerpoint/2010/main" val="672922549"/>
       </p:ext>
     </p:extLst>
   </p:cSld>
@@ -7469,7 +7469,7 @@
           <p:cNvPr id="10" name="">
             <a:extLst xmlns:a="http://schemas.openxmlformats.org/drawingml/2006/main">
               <a:ext uri="{FF2B5EF4-FFF2-40B4-BE49-F238E27FC236}">
-                <a16:creationId xmlns:a16="http://schemas.microsoft.com/office/drawing/2014/main" id="{3FEFA2F0-206D-419D-85E0-12258D4BED31}"/>
+                <a16:creationId xmlns:a16="http://schemas.microsoft.com/office/drawing/2014/main" id="{1673AD7F-C5F2-4F78-B4E4-C6E1DAEB83D9}"/>
               </a:ext>
             </a:extLst>
           </p:cNvPr>
@@ -7538,7 +7538,7 @@
           <p:cNvPr id="2" name="">
             <a:extLst xmlns:a="http://schemas.openxmlformats.org/drawingml/2006/main">
               <a:ext uri="{FF2B5EF4-FFF2-40B4-BE49-F238E27FC236}">
-                <a16:creationId xmlns:a16="http://schemas.microsoft.com/office/drawing/2014/main" id="{964AA127-1FDF-4A8B-A326-CBDA832E2B15}"/>
+                <a16:creationId xmlns:a16="http://schemas.microsoft.com/office/drawing/2014/main" id="{AEA8543F-D82E-4606-A9B1-45C06A716149}"/>
               </a:ext>
             </a:extLst>
           </p:cNvPr>
@@ -7569,7 +7569,7 @@
           <p:cNvPr id="3" name="">
             <a:extLst xmlns:a="http://schemas.openxmlformats.org/drawingml/2006/main">
               <a:ext uri="{FF2B5EF4-FFF2-40B4-BE49-F238E27FC236}">
-                <a16:creationId xmlns:a16="http://schemas.microsoft.com/office/drawing/2014/main" id="{5E5C9A25-8D1E-4181-A4DF-8491AD6E3F12}"/>
+                <a16:creationId xmlns:a16="http://schemas.microsoft.com/office/drawing/2014/main" id="{6420B4D9-F591-4579-ABC0-85A4942933A8}"/>
               </a:ext>
             </a:extLst>
           </p:cNvPr>
@@ -7638,7 +7638,7 @@
           <p:cNvPr id="4" name="">
             <a:extLst xmlns:a="http://schemas.openxmlformats.org/drawingml/2006/main">
               <a:ext uri="{FF2B5EF4-FFF2-40B4-BE49-F238E27FC236}">
-                <a16:creationId xmlns:a16="http://schemas.microsoft.com/office/drawing/2014/main" id="{4AE929D6-CCFC-435C-8A85-804DAAFCAF7F}"/>
+                <a16:creationId xmlns:a16="http://schemas.microsoft.com/office/drawing/2014/main" id="{BAF8FFDA-F550-4C66-9ADF-7867860434E9}"/>
               </a:ext>
             </a:extLst>
           </p:cNvPr>
@@ -7707,7 +7707,7 @@
           <p:cNvPr id="5" name="">
             <a:extLst xmlns:a="http://schemas.openxmlformats.org/drawingml/2006/main">
               <a:ext uri="{FF2B5EF4-FFF2-40B4-BE49-F238E27FC236}">
-                <a16:creationId xmlns:a16="http://schemas.microsoft.com/office/drawing/2014/main" id="{638231AD-3E8C-4E37-877B-DDD0A47744E7}"/>
+                <a16:creationId xmlns:a16="http://schemas.microsoft.com/office/drawing/2014/main" id="{B07BEE80-5884-4640-B31E-8CEF9EF781EF}"/>
               </a:ext>
             </a:extLst>
           </p:cNvPr>
@@ -7845,7 +7845,7 @@
           <p:cNvPr id="6" name="">
             <a:extLst xmlns:a="http://schemas.openxmlformats.org/drawingml/2006/main">
               <a:ext uri="{FF2B5EF4-FFF2-40B4-BE49-F238E27FC236}">
-                <a16:creationId xmlns:a16="http://schemas.microsoft.com/office/drawing/2014/main" id="{0CA5F178-5C75-4754-A83B-685505E9B06C}"/>
+                <a16:creationId xmlns:a16="http://schemas.microsoft.com/office/drawing/2014/main" id="{28551AB9-6A13-4FC2-A778-CC6BBFAD3164}"/>
               </a:ext>
             </a:extLst>
           </p:cNvPr>
@@ -7876,7 +7876,7 @@
           <p:cNvPr id="7" name="">
             <a:extLst xmlns:a="http://schemas.openxmlformats.org/drawingml/2006/main">
               <a:ext uri="{FF2B5EF4-FFF2-40B4-BE49-F238E27FC236}">
-                <a16:creationId xmlns:a16="http://schemas.microsoft.com/office/drawing/2014/main" id="{56E39CD3-08B3-4AA3-9C23-93302E9915BD}"/>
+                <a16:creationId xmlns:a16="http://schemas.microsoft.com/office/drawing/2014/main" id="{A5715471-7E37-4646-B4E0-937A21239392}"/>
               </a:ext>
             </a:extLst>
           </p:cNvPr>
@@ -7945,7 +7945,7 @@
           <p:cNvPr id="8" name="">
             <a:extLst xmlns:a="http://schemas.openxmlformats.org/drawingml/2006/main">
               <a:ext uri="{FF2B5EF4-FFF2-40B4-BE49-F238E27FC236}">
-                <a16:creationId xmlns:a16="http://schemas.microsoft.com/office/drawing/2014/main" id="{D8EE7607-3E97-419F-BD30-8C7FF1B4EB90}"/>
+                <a16:creationId xmlns:a16="http://schemas.microsoft.com/office/drawing/2014/main" id="{3F1AC3EF-F164-4F27-A89A-439F85EEC3F8}"/>
               </a:ext>
             </a:extLst>
           </p:cNvPr>
@@ -8060,7 +8060,7 @@
           <p:cNvPr id="9" name="">
             <a:extLst xmlns:a="http://schemas.openxmlformats.org/drawingml/2006/main">
               <a:ext uri="{FF2B5EF4-FFF2-40B4-BE49-F238E27FC236}">
-                <a16:creationId xmlns:a16="http://schemas.microsoft.com/office/drawing/2014/main" id="{7626A133-A975-4339-A7D0-D07FCAB9FA11}"/>
+                <a16:creationId xmlns:a16="http://schemas.microsoft.com/office/drawing/2014/main" id="{AEB698A4-7365-4C36-9E77-AFD61AF514D1}"/>
               </a:ext>
             </a:extLst>
           </p:cNvPr>
@@ -8127,7 +8127,7 @@
     </p:spTree>
     <p:extLst>
       <p:ext uri="{BB962C8B-B14F-4D97-AF65-F5344CB8AC3E}">
-        <p14:creationId xmlns:p14="http://schemas.microsoft.com/office/powerpoint/2010/main" val="987148200"/>
+        <p14:creationId xmlns:p14="http://schemas.microsoft.com/office/powerpoint/2010/main" val="1993308737"/>
       </p:ext>
     </p:extLst>
   </p:cSld>
@@ -8158,7 +8158,7 @@
           <p:cNvPr id="13" name="">
             <a:extLst xmlns:a="http://schemas.openxmlformats.org/drawingml/2006/main">
               <a:ext uri="{FF2B5EF4-FFF2-40B4-BE49-F238E27FC236}">
-                <a16:creationId xmlns:a16="http://schemas.microsoft.com/office/drawing/2014/main" id="{7754B748-BE29-472D-B040-E6AE8A498F85}"/>
+                <a16:creationId xmlns:a16="http://schemas.microsoft.com/office/drawing/2014/main" id="{E92A2E06-A01C-4F16-AE80-E78697F2E00B}"/>
               </a:ext>
             </a:extLst>
           </p:cNvPr>
@@ -8227,7 +8227,7 @@
           <p:cNvPr id="2" name="">
             <a:extLst xmlns:a="http://schemas.openxmlformats.org/drawingml/2006/main">
               <a:ext uri="{FF2B5EF4-FFF2-40B4-BE49-F238E27FC236}">
-                <a16:creationId xmlns:a16="http://schemas.microsoft.com/office/drawing/2014/main" id="{79FC0DD3-A3B8-4706-9374-D1174E82D553}"/>
+                <a16:creationId xmlns:a16="http://schemas.microsoft.com/office/drawing/2014/main" id="{253F892C-ABE0-4B9C-9610-CA3A4ECADC61}"/>
               </a:ext>
             </a:extLst>
           </p:cNvPr>
@@ -8258,7 +8258,7 @@
           <p:cNvPr id="3" name="">
             <a:extLst xmlns:a="http://schemas.openxmlformats.org/drawingml/2006/main">
               <a:ext uri="{FF2B5EF4-FFF2-40B4-BE49-F238E27FC236}">
-                <a16:creationId xmlns:a16="http://schemas.microsoft.com/office/drawing/2014/main" id="{117ACC05-4ACD-4389-B38E-85E57246DB36}"/>
+                <a16:creationId xmlns:a16="http://schemas.microsoft.com/office/drawing/2014/main" id="{78CC8D51-DD7F-4079-9CCF-554069169881}"/>
               </a:ext>
             </a:extLst>
           </p:cNvPr>
@@ -8327,7 +8327,7 @@
           <p:cNvPr id="4" name="">
             <a:extLst xmlns:a="http://schemas.openxmlformats.org/drawingml/2006/main">
               <a:ext uri="{FF2B5EF4-FFF2-40B4-BE49-F238E27FC236}">
-                <a16:creationId xmlns:a16="http://schemas.microsoft.com/office/drawing/2014/main" id="{BE55C568-87FA-4B1D-939F-5581FFE0EE01}"/>
+                <a16:creationId xmlns:a16="http://schemas.microsoft.com/office/drawing/2014/main" id="{AE20B8B3-C084-45C7-B985-42A0CEFBBCDB}"/>
               </a:ext>
             </a:extLst>
           </p:cNvPr>
@@ -8396,7 +8396,7 @@
           <p:cNvPr id="5" name="">
             <a:extLst xmlns:a="http://schemas.openxmlformats.org/drawingml/2006/main">
               <a:ext uri="{FF2B5EF4-FFF2-40B4-BE49-F238E27FC236}">
-                <a16:creationId xmlns:a16="http://schemas.microsoft.com/office/drawing/2014/main" id="{D5E2E1A5-D918-4CF5-A46E-816D8A1370CD}"/>
+                <a16:creationId xmlns:a16="http://schemas.microsoft.com/office/drawing/2014/main" id="{4298A5C3-8F6D-4113-A9DB-5D5D89F7EF29}"/>
               </a:ext>
             </a:extLst>
           </p:cNvPr>
@@ -8465,7 +8465,7 @@
           <p:cNvPr id="6" name="">
             <a:extLst xmlns:a="http://schemas.openxmlformats.org/drawingml/2006/main">
               <a:ext uri="{FF2B5EF4-FFF2-40B4-BE49-F238E27FC236}">
-                <a16:creationId xmlns:a16="http://schemas.microsoft.com/office/drawing/2014/main" id="{F96A53F4-F344-48E8-AF6B-12930615E5CC}"/>
+                <a16:creationId xmlns:a16="http://schemas.microsoft.com/office/drawing/2014/main" id="{8460B669-9871-499B-86E3-A296C6146194}"/>
               </a:ext>
             </a:extLst>
           </p:cNvPr>
@@ -8534,7 +8534,7 @@
           <p:cNvPr id="7" name="">
             <a:extLst xmlns:a="http://schemas.openxmlformats.org/drawingml/2006/main">
               <a:ext uri="{FF2B5EF4-FFF2-40B4-BE49-F238E27FC236}">
-                <a16:creationId xmlns:a16="http://schemas.microsoft.com/office/drawing/2014/main" id="{10A79FC2-7CCC-45EF-AD6E-9C9C46174D99}"/>
+                <a16:creationId xmlns:a16="http://schemas.microsoft.com/office/drawing/2014/main" id="{82C655DD-3AF8-4F84-80DD-DD2055E10BB1}"/>
               </a:ext>
             </a:extLst>
           </p:cNvPr>
@@ -8565,7 +8565,7 @@
           <p:cNvPr id="8" name="">
             <a:extLst xmlns:a="http://schemas.openxmlformats.org/drawingml/2006/main">
               <a:ext uri="{FF2B5EF4-FFF2-40B4-BE49-F238E27FC236}">
-                <a16:creationId xmlns:a16="http://schemas.microsoft.com/office/drawing/2014/main" id="{C96903B6-E38D-4756-9401-9A331B6AD28C}"/>
+                <a16:creationId xmlns:a16="http://schemas.microsoft.com/office/drawing/2014/main" id="{9CF30DE0-8AFB-4F0F-A021-A01974DE32B0}"/>
               </a:ext>
             </a:extLst>
           </p:cNvPr>
@@ -8634,7 +8634,7 @@
           <p:cNvPr id="9" name="">
             <a:extLst xmlns:a="http://schemas.openxmlformats.org/drawingml/2006/main">
               <a:ext uri="{FF2B5EF4-FFF2-40B4-BE49-F238E27FC236}">
-                <a16:creationId xmlns:a16="http://schemas.microsoft.com/office/drawing/2014/main" id="{6D893B35-88D8-4818-9D8F-067089B8EDB5}"/>
+                <a16:creationId xmlns:a16="http://schemas.microsoft.com/office/drawing/2014/main" id="{FE554D91-A4B9-4DDC-8C28-E94B909594F5}"/>
               </a:ext>
             </a:extLst>
           </p:cNvPr>
@@ -8703,7 +8703,7 @@
           <p:cNvPr id="10" name="">
             <a:extLst xmlns:a="http://schemas.openxmlformats.org/drawingml/2006/main">
               <a:ext uri="{FF2B5EF4-FFF2-40B4-BE49-F238E27FC236}">
-                <a16:creationId xmlns:a16="http://schemas.microsoft.com/office/drawing/2014/main" id="{8EF564F2-63F5-45E6-9288-C40C5FB45EF9}"/>
+                <a16:creationId xmlns:a16="http://schemas.microsoft.com/office/drawing/2014/main" id="{3C6FB0E0-88C0-4EC0-A130-277D88C70FA1}"/>
               </a:ext>
             </a:extLst>
           </p:cNvPr>
@@ -8772,7 +8772,7 @@
           <p:cNvPr id="11" name="">
             <a:extLst xmlns:a="http://schemas.openxmlformats.org/drawingml/2006/main">
               <a:ext uri="{FF2B5EF4-FFF2-40B4-BE49-F238E27FC236}">
-                <a16:creationId xmlns:a16="http://schemas.microsoft.com/office/drawing/2014/main" id="{0B4E55FF-33A7-4A26-87C4-2F520172054F}"/>
+                <a16:creationId xmlns:a16="http://schemas.microsoft.com/office/drawing/2014/main" id="{71E5EB85-F2C1-4294-BFB3-1F1FA2FE2D77}"/>
               </a:ext>
             </a:extLst>
           </p:cNvPr>
@@ -8803,7 +8803,7 @@
           <p:cNvPr id="12" name="">
             <a:extLst xmlns:a="http://schemas.openxmlformats.org/drawingml/2006/main">
               <a:ext uri="{FF2B5EF4-FFF2-40B4-BE49-F238E27FC236}">
-                <a16:creationId xmlns:a16="http://schemas.microsoft.com/office/drawing/2014/main" id="{68DC8ADE-9924-4D30-8A0C-00AB905651DB}"/>
+                <a16:creationId xmlns:a16="http://schemas.microsoft.com/office/drawing/2014/main" id="{E24E1CCE-06D5-4F82-9BBC-615DA33D2611}"/>
               </a:ext>
             </a:extLst>
           </p:cNvPr>
@@ -8870,7 +8870,7 @@
     </p:spTree>
     <p:extLst>
       <p:ext uri="{BB962C8B-B14F-4D97-AF65-F5344CB8AC3E}">
-        <p14:creationId xmlns:p14="http://schemas.microsoft.com/office/powerpoint/2010/main" val="902039228"/>
+        <p14:creationId xmlns:p14="http://schemas.microsoft.com/office/powerpoint/2010/main" val="1041859777"/>
       </p:ext>
     </p:extLst>
   </p:cSld>
@@ -8901,7 +8901,7 @@
           <p:cNvPr id="21" name="">
             <a:extLst xmlns:a="http://schemas.openxmlformats.org/drawingml/2006/main">
               <a:ext uri="{FF2B5EF4-FFF2-40B4-BE49-F238E27FC236}">
-                <a16:creationId xmlns:a16="http://schemas.microsoft.com/office/drawing/2014/main" id="{E63A53B3-5EA7-4553-8615-8107E2765C28}"/>
+                <a16:creationId xmlns:a16="http://schemas.microsoft.com/office/drawing/2014/main" id="{8B3D23E2-EB8E-41CA-A0FA-260782B08936}"/>
               </a:ext>
             </a:extLst>
           </p:cNvPr>
@@ -8970,7 +8970,7 @@
           <p:cNvPr id="2" name="">
             <a:extLst xmlns:a="http://schemas.openxmlformats.org/drawingml/2006/main">
               <a:ext uri="{FF2B5EF4-FFF2-40B4-BE49-F238E27FC236}">
-                <a16:creationId xmlns:a16="http://schemas.microsoft.com/office/drawing/2014/main" id="{94AAB6B4-F97D-4E22-B83C-74A25ECE0A0A}"/>
+                <a16:creationId xmlns:a16="http://schemas.microsoft.com/office/drawing/2014/main" id="{8717684F-69E1-4D40-8F84-77C162CC9591}"/>
               </a:ext>
             </a:extLst>
           </p:cNvPr>
@@ -9001,7 +9001,7 @@
           <p:cNvPr id="3" name="">
             <a:extLst xmlns:a="http://schemas.openxmlformats.org/drawingml/2006/main">
               <a:ext uri="{FF2B5EF4-FFF2-40B4-BE49-F238E27FC236}">
-                <a16:creationId xmlns:a16="http://schemas.microsoft.com/office/drawing/2014/main" id="{F4463F14-27F5-4740-9987-585743684AA5}"/>
+                <a16:creationId xmlns:a16="http://schemas.microsoft.com/office/drawing/2014/main" id="{75B219DE-8D14-47F9-99FD-FB5A4BC77193}"/>
               </a:ext>
             </a:extLst>
           </p:cNvPr>
@@ -9070,7 +9070,7 @@
           <p:cNvPr id="4" name="">
             <a:extLst xmlns:a="http://schemas.openxmlformats.org/drawingml/2006/main">
               <a:ext uri="{FF2B5EF4-FFF2-40B4-BE49-F238E27FC236}">
-                <a16:creationId xmlns:a16="http://schemas.microsoft.com/office/drawing/2014/main" id="{C561485E-D2C5-44CA-99BB-21CCB86387DA}"/>
+                <a16:creationId xmlns:a16="http://schemas.microsoft.com/office/drawing/2014/main" id="{C8C558CF-140F-4702-8583-4C07B7489522}"/>
               </a:ext>
             </a:extLst>
           </p:cNvPr>
@@ -9139,7 +9139,7 @@
           <p:cNvPr id="5" name="">
             <a:extLst xmlns:a="http://schemas.openxmlformats.org/drawingml/2006/main">
               <a:ext uri="{FF2B5EF4-FFF2-40B4-BE49-F238E27FC236}">
-                <a16:creationId xmlns:a16="http://schemas.microsoft.com/office/drawing/2014/main" id="{09688C1F-0F2C-4762-A86E-6B2752CEF360}"/>
+                <a16:creationId xmlns:a16="http://schemas.microsoft.com/office/drawing/2014/main" id="{0A9CCFBC-1DE5-447A-9295-2999AF413315}"/>
               </a:ext>
             </a:extLst>
           </p:cNvPr>
@@ -9208,7 +9208,7 @@
           <p:cNvPr id="6" name="">
             <a:extLst xmlns:a="http://schemas.openxmlformats.org/drawingml/2006/main">
               <a:ext uri="{FF2B5EF4-FFF2-40B4-BE49-F238E27FC236}">
-                <a16:creationId xmlns:a16="http://schemas.microsoft.com/office/drawing/2014/main" id="{36617875-E343-4552-85B3-3AA3F09243E9}"/>
+                <a16:creationId xmlns:a16="http://schemas.microsoft.com/office/drawing/2014/main" id="{7AC1F77D-F339-46C3-8572-C1CC80C8B1E8}"/>
               </a:ext>
             </a:extLst>
           </p:cNvPr>
@@ -9277,7 +9277,7 @@
           <p:cNvPr id="7" name="">
             <a:extLst xmlns:a="http://schemas.openxmlformats.org/drawingml/2006/main">
               <a:ext uri="{FF2B5EF4-FFF2-40B4-BE49-F238E27FC236}">
-                <a16:creationId xmlns:a16="http://schemas.microsoft.com/office/drawing/2014/main" id="{906D4F16-E6E0-4E4C-9EF2-903E395BA1A2}"/>
+                <a16:creationId xmlns:a16="http://schemas.microsoft.com/office/drawing/2014/main" id="{B5F81571-64E8-45E5-89EB-B45AC6E3202C}"/>
               </a:ext>
             </a:extLst>
           </p:cNvPr>
@@ -9308,7 +9308,7 @@
           <p:cNvPr id="8" name="">
             <a:extLst xmlns:a="http://schemas.openxmlformats.org/drawingml/2006/main">
               <a:ext uri="{FF2B5EF4-FFF2-40B4-BE49-F238E27FC236}">
-                <a16:creationId xmlns:a16="http://schemas.microsoft.com/office/drawing/2014/main" id="{026788F8-7502-4F1E-A618-4D1F06E0C622}"/>
+                <a16:creationId xmlns:a16="http://schemas.microsoft.com/office/drawing/2014/main" id="{4B465A0F-C8A6-4354-80A9-7426C8619A28}"/>
               </a:ext>
             </a:extLst>
           </p:cNvPr>
@@ -9377,7 +9377,7 @@
           <p:cNvPr id="9" name="">
             <a:extLst xmlns:a="http://schemas.openxmlformats.org/drawingml/2006/main">
               <a:ext uri="{FF2B5EF4-FFF2-40B4-BE49-F238E27FC236}">
-                <a16:creationId xmlns:a16="http://schemas.microsoft.com/office/drawing/2014/main" id="{B933C0A5-6FCA-470F-A211-53DD17A52FD6}"/>
+                <a16:creationId xmlns:a16="http://schemas.microsoft.com/office/drawing/2014/main" id="{01F819BF-A3C9-4D5E-A4FB-D58DFC134543}"/>
               </a:ext>
             </a:extLst>
           </p:cNvPr>
@@ -9446,7 +9446,7 @@
           <p:cNvPr id="10" name="">
             <a:extLst xmlns:a="http://schemas.openxmlformats.org/drawingml/2006/main">
               <a:ext uri="{FF2B5EF4-FFF2-40B4-BE49-F238E27FC236}">
-                <a16:creationId xmlns:a16="http://schemas.microsoft.com/office/drawing/2014/main" id="{B469045B-5568-4F72-9C4B-2916F0DE4A73}"/>
+                <a16:creationId xmlns:a16="http://schemas.microsoft.com/office/drawing/2014/main" id="{BB03346F-B8D0-4E56-AF5F-3ABADB59D1A0}"/>
               </a:ext>
             </a:extLst>
           </p:cNvPr>
@@ -9515,7 +9515,7 @@
           <p:cNvPr id="11" name="">
             <a:extLst xmlns:a="http://schemas.openxmlformats.org/drawingml/2006/main">
               <a:ext uri="{FF2B5EF4-FFF2-40B4-BE49-F238E27FC236}">
-                <a16:creationId xmlns:a16="http://schemas.microsoft.com/office/drawing/2014/main" id="{3FCE0553-1846-4DAE-B2B9-CC52489CBC20}"/>
+                <a16:creationId xmlns:a16="http://schemas.microsoft.com/office/drawing/2014/main" id="{8EBEC26D-FFC7-4F46-A278-BC0C65FCD2E9}"/>
               </a:ext>
             </a:extLst>
           </p:cNvPr>
@@ -9546,7 +9546,7 @@
           <p:cNvPr id="12" name="">
             <a:extLst xmlns:a="http://schemas.openxmlformats.org/drawingml/2006/main">
               <a:ext uri="{FF2B5EF4-FFF2-40B4-BE49-F238E27FC236}">
-                <a16:creationId xmlns:a16="http://schemas.microsoft.com/office/drawing/2014/main" id="{60889100-EB10-45B6-91F4-E41FE22EEA8C}"/>
+                <a16:creationId xmlns:a16="http://schemas.microsoft.com/office/drawing/2014/main" id="{01DC1555-CA6D-4513-BC48-367EC2633DB4}"/>
               </a:ext>
             </a:extLst>
           </p:cNvPr>
@@ -9615,7 +9615,7 @@
           <p:cNvPr id="13" name="">
             <a:extLst xmlns:a="http://schemas.openxmlformats.org/drawingml/2006/main">
               <a:ext uri="{FF2B5EF4-FFF2-40B4-BE49-F238E27FC236}">
-                <a16:creationId xmlns:a16="http://schemas.microsoft.com/office/drawing/2014/main" id="{84A29974-445F-4CA3-9F3B-85869CBA81D0}"/>
+                <a16:creationId xmlns:a16="http://schemas.microsoft.com/office/drawing/2014/main" id="{AEE3AEDD-19DE-49BA-AE3A-E3AE763375B4}"/>
               </a:ext>
             </a:extLst>
           </p:cNvPr>
@@ -9684,7 +9684,7 @@
           <p:cNvPr id="14" name="">
             <a:extLst xmlns:a="http://schemas.openxmlformats.org/drawingml/2006/main">
               <a:ext uri="{FF2B5EF4-FFF2-40B4-BE49-F238E27FC236}">
-                <a16:creationId xmlns:a16="http://schemas.microsoft.com/office/drawing/2014/main" id="{A235753F-A6C0-479E-B53F-026E1947A547}"/>
+                <a16:creationId xmlns:a16="http://schemas.microsoft.com/office/drawing/2014/main" id="{B1B7D3AD-CB75-4B13-8D11-0B2B087DEBBD}"/>
               </a:ext>
             </a:extLst>
           </p:cNvPr>
@@ -9753,7 +9753,7 @@
           <p:cNvPr id="15" name="">
             <a:extLst xmlns:a="http://schemas.openxmlformats.org/drawingml/2006/main">
               <a:ext uri="{FF2B5EF4-FFF2-40B4-BE49-F238E27FC236}">
-                <a16:creationId xmlns:a16="http://schemas.microsoft.com/office/drawing/2014/main" id="{5F2A19F6-7184-43AA-9CFA-BBAE1A690007}"/>
+                <a16:creationId xmlns:a16="http://schemas.microsoft.com/office/drawing/2014/main" id="{98A5B073-49BF-4EA5-A88D-0CC848E64C6B}"/>
               </a:ext>
             </a:extLst>
           </p:cNvPr>
@@ -9784,7 +9784,7 @@
           <p:cNvPr id="16" name="">
             <a:extLst xmlns:a="http://schemas.openxmlformats.org/drawingml/2006/main">
               <a:ext uri="{FF2B5EF4-FFF2-40B4-BE49-F238E27FC236}">
-                <a16:creationId xmlns:a16="http://schemas.microsoft.com/office/drawing/2014/main" id="{E3DAE044-7457-4637-9962-BB3A063CF529}"/>
+                <a16:creationId xmlns:a16="http://schemas.microsoft.com/office/drawing/2014/main" id="{9021BE89-4E11-485E-8C72-7D6231C51C3E}"/>
               </a:ext>
             </a:extLst>
           </p:cNvPr>
@@ -9853,7 +9853,7 @@
           <p:cNvPr id="17" name="">
             <a:extLst xmlns:a="http://schemas.openxmlformats.org/drawingml/2006/main">
               <a:ext uri="{FF2B5EF4-FFF2-40B4-BE49-F238E27FC236}">
-                <a16:creationId xmlns:a16="http://schemas.microsoft.com/office/drawing/2014/main" id="{38DAACBE-3867-4148-A290-BE7F4F0B8B31}"/>
+                <a16:creationId xmlns:a16="http://schemas.microsoft.com/office/drawing/2014/main" id="{9CD725B0-DB19-44F1-96DC-879029FCB6E9}"/>
               </a:ext>
             </a:extLst>
           </p:cNvPr>
@@ -9922,7 +9922,7 @@
           <p:cNvPr id="18" name="">
             <a:extLst xmlns:a="http://schemas.openxmlformats.org/drawingml/2006/main">
               <a:ext uri="{FF2B5EF4-FFF2-40B4-BE49-F238E27FC236}">
-                <a16:creationId xmlns:a16="http://schemas.microsoft.com/office/drawing/2014/main" id="{4286AB90-5FFF-4AF2-8C01-2899BD5FA76F}"/>
+                <a16:creationId xmlns:a16="http://schemas.microsoft.com/office/drawing/2014/main" id="{F5D1482C-49F4-408F-8B48-F7B7DA15E156}"/>
               </a:ext>
             </a:extLst>
           </p:cNvPr>
@@ -9991,7 +9991,7 @@
           <p:cNvPr id="19" name="">
             <a:extLst xmlns:a="http://schemas.openxmlformats.org/drawingml/2006/main">
               <a:ext uri="{FF2B5EF4-FFF2-40B4-BE49-F238E27FC236}">
-                <a16:creationId xmlns:a16="http://schemas.microsoft.com/office/drawing/2014/main" id="{7F0886E4-6776-451C-A353-BD3B8DD86ABC}"/>
+                <a16:creationId xmlns:a16="http://schemas.microsoft.com/office/drawing/2014/main" id="{62C836FB-C7EF-4C61-B040-F864E127F808}"/>
               </a:ext>
             </a:extLst>
           </p:cNvPr>
@@ -10022,7 +10022,7 @@
           <p:cNvPr id="20" name="">
             <a:extLst xmlns:a="http://schemas.openxmlformats.org/drawingml/2006/main">
               <a:ext uri="{FF2B5EF4-FFF2-40B4-BE49-F238E27FC236}">
-                <a16:creationId xmlns:a16="http://schemas.microsoft.com/office/drawing/2014/main" id="{D53FEDF3-4263-43F7-AC41-B9B2F823CC2D}"/>
+                <a16:creationId xmlns:a16="http://schemas.microsoft.com/office/drawing/2014/main" id="{00CFB30B-7585-4C2C-8091-AAD53B9C81D8}"/>
               </a:ext>
             </a:extLst>
           </p:cNvPr>
@@ -10081,7 +10081,7 @@
                 <a:ea typeface="Arial"/>
                 <a:cs typeface="Arial"/>
               </a:rPr>
-              <a:t>API keys stay on the server. The current production deployment is still Iteration 1 code.</a:t>
+              <a:t>Deployed v2 reached live comparison. Rubric and Android checks remain open.</a:t>
             </a:r>
           </a:p>
         </p:txBody>
@@ -10089,7 +10089,7 @@
     </p:spTree>
     <p:extLst>
       <p:ext uri="{BB962C8B-B14F-4D97-AF65-F5344CB8AC3E}">
-        <p14:creationId xmlns:p14="http://schemas.microsoft.com/office/powerpoint/2010/main" val="468582185"/>
+        <p14:creationId xmlns:p14="http://schemas.microsoft.com/office/powerpoint/2010/main" val="586135764"/>
       </p:ext>
     </p:extLst>
   </p:cSld>
@@ -10120,7 +10120,7 @@
           <p:cNvPr id="13" name="">
             <a:extLst xmlns:a="http://schemas.openxmlformats.org/drawingml/2006/main">
               <a:ext uri="{FF2B5EF4-FFF2-40B4-BE49-F238E27FC236}">
-                <a16:creationId xmlns:a16="http://schemas.microsoft.com/office/drawing/2014/main" id="{7C68277A-550C-45E9-92A1-0029477D67E0}"/>
+                <a16:creationId xmlns:a16="http://schemas.microsoft.com/office/drawing/2014/main" id="{FD71E4BB-D51B-420C-8C88-451EEA5A26D5}"/>
               </a:ext>
             </a:extLst>
           </p:cNvPr>
@@ -10189,7 +10189,7 @@
           <p:cNvPr id="2" name="">
             <a:extLst xmlns:a="http://schemas.openxmlformats.org/drawingml/2006/main">
               <a:ext uri="{FF2B5EF4-FFF2-40B4-BE49-F238E27FC236}">
-                <a16:creationId xmlns:a16="http://schemas.microsoft.com/office/drawing/2014/main" id="{B23859C7-A976-45B4-BE05-D605A0D0ECBC}"/>
+                <a16:creationId xmlns:a16="http://schemas.microsoft.com/office/drawing/2014/main" id="{5E5514F1-9D5F-4E74-BDD8-5A36144DBC01}"/>
               </a:ext>
             </a:extLst>
           </p:cNvPr>
@@ -10220,7 +10220,7 @@
           <p:cNvPr id="3" name="">
             <a:extLst xmlns:a="http://schemas.openxmlformats.org/drawingml/2006/main">
               <a:ext uri="{FF2B5EF4-FFF2-40B4-BE49-F238E27FC236}">
-                <a16:creationId xmlns:a16="http://schemas.microsoft.com/office/drawing/2014/main" id="{6B87DA26-218A-4396-8595-3AA971FC42E2}"/>
+                <a16:creationId xmlns:a16="http://schemas.microsoft.com/office/drawing/2014/main" id="{88A680A3-AA18-4DCC-B1A0-9EFA8AC4D0FE}"/>
               </a:ext>
             </a:extLst>
           </p:cNvPr>
@@ -10289,7 +10289,7 @@
           <p:cNvPr id="4" name="">
             <a:extLst xmlns:a="http://schemas.openxmlformats.org/drawingml/2006/main">
               <a:ext uri="{FF2B5EF4-FFF2-40B4-BE49-F238E27FC236}">
-                <a16:creationId xmlns:a16="http://schemas.microsoft.com/office/drawing/2014/main" id="{F66193A1-7521-4DAC-A70E-61D7C8F78B21}"/>
+                <a16:creationId xmlns:a16="http://schemas.microsoft.com/office/drawing/2014/main" id="{6E4E590A-7EE2-4F05-99D1-4C33D64BCF18}"/>
               </a:ext>
             </a:extLst>
           </p:cNvPr>
@@ -10358,7 +10358,7 @@
           <p:cNvPr id="5" name="">
             <a:extLst xmlns:a="http://schemas.openxmlformats.org/drawingml/2006/main">
               <a:ext uri="{FF2B5EF4-FFF2-40B4-BE49-F238E27FC236}">
-                <a16:creationId xmlns:a16="http://schemas.microsoft.com/office/drawing/2014/main" id="{BA85CD8F-1B93-4D80-BC60-DAEE0CD50E0A}"/>
+                <a16:creationId xmlns:a16="http://schemas.microsoft.com/office/drawing/2014/main" id="{93189806-6FB5-468B-86B6-B99AA718F2BB}"/>
               </a:ext>
             </a:extLst>
           </p:cNvPr>
@@ -10427,7 +10427,7 @@
           <p:cNvPr id="6" name="">
             <a:extLst xmlns:a="http://schemas.openxmlformats.org/drawingml/2006/main">
               <a:ext uri="{FF2B5EF4-FFF2-40B4-BE49-F238E27FC236}">
-                <a16:creationId xmlns:a16="http://schemas.microsoft.com/office/drawing/2014/main" id="{55877A65-E144-4C35-9E20-6FCC035F82CD}"/>
+                <a16:creationId xmlns:a16="http://schemas.microsoft.com/office/drawing/2014/main" id="{6083F3FD-EC5A-4D79-8205-72C110608360}"/>
               </a:ext>
             </a:extLst>
           </p:cNvPr>
@@ -10458,7 +10458,7 @@
           <p:cNvPr id="7" name="">
             <a:extLst xmlns:a="http://schemas.openxmlformats.org/drawingml/2006/main">
               <a:ext uri="{FF2B5EF4-FFF2-40B4-BE49-F238E27FC236}">
-                <a16:creationId xmlns:a16="http://schemas.microsoft.com/office/drawing/2014/main" id="{60C65489-5319-4E83-A267-B6F2EF14F07F}"/>
+                <a16:creationId xmlns:a16="http://schemas.microsoft.com/office/drawing/2014/main" id="{C985F332-D68D-40AF-AC06-FA35984CD57B}"/>
               </a:ext>
             </a:extLst>
           </p:cNvPr>
@@ -10527,7 +10527,7 @@
           <p:cNvPr id="8" name="">
             <a:extLst xmlns:a="http://schemas.openxmlformats.org/drawingml/2006/main">
               <a:ext uri="{FF2B5EF4-FFF2-40B4-BE49-F238E27FC236}">
-                <a16:creationId xmlns:a16="http://schemas.microsoft.com/office/drawing/2014/main" id="{68DC36C0-A762-4E17-8DA0-3694B4793097}"/>
+                <a16:creationId xmlns:a16="http://schemas.microsoft.com/office/drawing/2014/main" id="{5369316F-4BF1-4090-87B9-E8C9CFC4C8E1}"/>
               </a:ext>
             </a:extLst>
           </p:cNvPr>
@@ -10596,7 +10596,7 @@
           <p:cNvPr id="9" name="">
             <a:extLst xmlns:a="http://schemas.openxmlformats.org/drawingml/2006/main">
               <a:ext uri="{FF2B5EF4-FFF2-40B4-BE49-F238E27FC236}">
-                <a16:creationId xmlns:a16="http://schemas.microsoft.com/office/drawing/2014/main" id="{48FC9A1E-ABAD-4A76-A324-80C558CE0F0D}"/>
+                <a16:creationId xmlns:a16="http://schemas.microsoft.com/office/drawing/2014/main" id="{97BA403C-F89C-4F97-B6DE-3B924F84EBC1}"/>
               </a:ext>
             </a:extLst>
           </p:cNvPr>
@@ -10665,7 +10665,7 @@
           <p:cNvPr id="10" name="">
             <a:extLst xmlns:a="http://schemas.openxmlformats.org/drawingml/2006/main">
               <a:ext uri="{FF2B5EF4-FFF2-40B4-BE49-F238E27FC236}">
-                <a16:creationId xmlns:a16="http://schemas.microsoft.com/office/drawing/2014/main" id="{592E4E1B-29F8-4E92-8D1A-482529B38A7F}"/>
+                <a16:creationId xmlns:a16="http://schemas.microsoft.com/office/drawing/2014/main" id="{9BC574C7-1640-4357-B84D-1FC109E31640}"/>
               </a:ext>
             </a:extLst>
           </p:cNvPr>
@@ -10734,7 +10734,7 @@
           <p:cNvPr id="11" name="">
             <a:extLst xmlns:a="http://schemas.openxmlformats.org/drawingml/2006/main">
               <a:ext uri="{FF2B5EF4-FFF2-40B4-BE49-F238E27FC236}">
-                <a16:creationId xmlns:a16="http://schemas.microsoft.com/office/drawing/2014/main" id="{6A660C15-99DE-4EAA-A9FB-2A0BF1C7EF5A}"/>
+                <a16:creationId xmlns:a16="http://schemas.microsoft.com/office/drawing/2014/main" id="{E8975296-93E3-4AB8-A563-324689EBA0FD}"/>
               </a:ext>
             </a:extLst>
           </p:cNvPr>
@@ -10803,7 +10803,7 @@
           <p:cNvPr id="12" name="">
             <a:extLst xmlns:a="http://schemas.openxmlformats.org/drawingml/2006/main">
               <a:ext uri="{FF2B5EF4-FFF2-40B4-BE49-F238E27FC236}">
-                <a16:creationId xmlns:a16="http://schemas.microsoft.com/office/drawing/2014/main" id="{06DFB763-D584-4F2E-83F3-15A736F93854}"/>
+                <a16:creationId xmlns:a16="http://schemas.microsoft.com/office/drawing/2014/main" id="{C2C291A0-C6BF-4D01-B177-EBBA9DBAC84A}"/>
               </a:ext>
             </a:extLst>
           </p:cNvPr>
@@ -10870,7 +10870,7 @@
     </p:spTree>
     <p:extLst>
       <p:ext uri="{BB962C8B-B14F-4D97-AF65-F5344CB8AC3E}">
-        <p14:creationId xmlns:p14="http://schemas.microsoft.com/office/powerpoint/2010/main" val="667703571"/>
+        <p14:creationId xmlns:p14="http://schemas.microsoft.com/office/powerpoint/2010/main" val="1387189404"/>
       </p:ext>
     </p:extLst>
   </p:cSld>
@@ -10901,7 +10901,7 @@
           <p:cNvPr id="9" name="">
             <a:extLst xmlns:a="http://schemas.openxmlformats.org/drawingml/2006/main">
               <a:ext uri="{FF2B5EF4-FFF2-40B4-BE49-F238E27FC236}">
-                <a16:creationId xmlns:a16="http://schemas.microsoft.com/office/drawing/2014/main" id="{DE6E6F9F-B898-4A6B-B6AD-EE910A6DC118}"/>
+                <a16:creationId xmlns:a16="http://schemas.microsoft.com/office/drawing/2014/main" id="{21F292C6-FBF0-4F73-97D4-89684DE9E14F}"/>
               </a:ext>
             </a:extLst>
           </p:cNvPr>
@@ -10970,7 +10970,7 @@
           <p:cNvPr id="2" name="">
             <a:extLst xmlns:a="http://schemas.openxmlformats.org/drawingml/2006/main">
               <a:ext uri="{FF2B5EF4-FFF2-40B4-BE49-F238E27FC236}">
-                <a16:creationId xmlns:a16="http://schemas.microsoft.com/office/drawing/2014/main" id="{D76AD93D-6804-407F-92FA-41EB954C464B}"/>
+                <a16:creationId xmlns:a16="http://schemas.microsoft.com/office/drawing/2014/main" id="{465D6974-F804-4834-897F-2E2DF3544F78}"/>
               </a:ext>
             </a:extLst>
           </p:cNvPr>
@@ -11001,7 +11001,7 @@
           <p:cNvPr id="3" name="">
             <a:extLst xmlns:a="http://schemas.openxmlformats.org/drawingml/2006/main">
               <a:ext uri="{FF2B5EF4-FFF2-40B4-BE49-F238E27FC236}">
-                <a16:creationId xmlns:a16="http://schemas.microsoft.com/office/drawing/2014/main" id="{BC28FCBF-EF74-45DC-B1F4-B51D85EB251D}"/>
+                <a16:creationId xmlns:a16="http://schemas.microsoft.com/office/drawing/2014/main" id="{2AF0A048-2954-4C1E-879E-6C7163F2B754}"/>
               </a:ext>
             </a:extLst>
           </p:cNvPr>
@@ -11070,7 +11070,7 @@
           <p:cNvPr id="4" name="">
             <a:extLst xmlns:a="http://schemas.openxmlformats.org/drawingml/2006/main">
               <a:ext uri="{FF2B5EF4-FFF2-40B4-BE49-F238E27FC236}">
-                <a16:creationId xmlns:a16="http://schemas.microsoft.com/office/drawing/2014/main" id="{E331E034-7E88-4989-A998-A5FE7B18C0D4}"/>
+                <a16:creationId xmlns:a16="http://schemas.microsoft.com/office/drawing/2014/main" id="{E4BCF559-1E28-4996-8C89-AB826EF9BBFA}"/>
               </a:ext>
             </a:extLst>
           </p:cNvPr>
@@ -11080,7 +11080,7 @@
           <p:nvPr/>
         </p:nvPicPr>
         <p:blipFill>
-          <a:blip xmlns:r="http://schemas.openxmlformats.org/officeDocument/2006/relationships" xmlns:a="http://schemas.openxmlformats.org/drawingml/2006/main" r:embed="Ra8dd7dd67d1e4b8e"/>
+          <a:blip xmlns:r="http://schemas.openxmlformats.org/officeDocument/2006/relationships" xmlns:a="http://schemas.openxmlformats.org/drawingml/2006/main" r:embed="Rf6cad14ef4cb4cd1"/>
           <a:srcRect xmlns:a="http://schemas.openxmlformats.org/drawingml/2006/main" l="3000" t="27000" r="3000" b="32000"/>
           <a:stretch xmlns:a="http://schemas.openxmlformats.org/drawingml/2006/main"/>
         </p:blipFill>
@@ -11099,7 +11099,7 @@
           <p:cNvPr id="5" name="">
             <a:extLst xmlns:a="http://schemas.openxmlformats.org/drawingml/2006/main">
               <a:ext uri="{FF2B5EF4-FFF2-40B4-BE49-F238E27FC236}">
-                <a16:creationId xmlns:a16="http://schemas.microsoft.com/office/drawing/2014/main" id="{7692FFC9-3DFE-481F-96C9-870BDD9933B3}"/>
+                <a16:creationId xmlns:a16="http://schemas.microsoft.com/office/drawing/2014/main" id="{11D54DE7-0417-444F-87BD-8D56BAD4F781}"/>
               </a:ext>
             </a:extLst>
           </p:cNvPr>
@@ -11168,7 +11168,7 @@
           <p:cNvPr id="6" name="">
             <a:extLst xmlns:a="http://schemas.openxmlformats.org/drawingml/2006/main">
               <a:ext uri="{FF2B5EF4-FFF2-40B4-BE49-F238E27FC236}">
-                <a16:creationId xmlns:a16="http://schemas.microsoft.com/office/drawing/2014/main" id="{F45B7274-05AD-4BE8-98E7-716913C93AA2}"/>
+                <a16:creationId xmlns:a16="http://schemas.microsoft.com/office/drawing/2014/main" id="{9495DEE6-CF4C-4A15-BA80-0AB16FEE2748}"/>
               </a:ext>
             </a:extLst>
           </p:cNvPr>
@@ -11237,7 +11237,7 @@
           <p:cNvPr id="7" name="">
             <a:extLst xmlns:a="http://schemas.openxmlformats.org/drawingml/2006/main">
               <a:ext uri="{FF2B5EF4-FFF2-40B4-BE49-F238E27FC236}">
-                <a16:creationId xmlns:a16="http://schemas.microsoft.com/office/drawing/2014/main" id="{7AD79EF5-44F2-4041-BEFA-B2BD4B02DA64}"/>
+                <a16:creationId xmlns:a16="http://schemas.microsoft.com/office/drawing/2014/main" id="{5D4CC9FB-8A8A-456B-BCF6-CFF694CAA000}"/>
               </a:ext>
             </a:extLst>
           </p:cNvPr>
@@ -11268,7 +11268,7 @@
           <p:cNvPr id="8" name="">
             <a:extLst xmlns:a="http://schemas.openxmlformats.org/drawingml/2006/main">
               <a:ext uri="{FF2B5EF4-FFF2-40B4-BE49-F238E27FC236}">
-                <a16:creationId xmlns:a16="http://schemas.microsoft.com/office/drawing/2014/main" id="{C6E18DE9-F389-4615-8A65-DE4C836DDC6A}"/>
+                <a16:creationId xmlns:a16="http://schemas.microsoft.com/office/drawing/2014/main" id="{BBE9319A-1198-45DB-8E56-59745C1654E7}"/>
               </a:ext>
             </a:extLst>
           </p:cNvPr>
@@ -11327,7 +11327,7 @@
                 <a:ea typeface="Arial"/>
                 <a:cs typeface="Arial"/>
               </a:rPr>
-              <a:t>Live NAVER/Gemini walkthrough and source review are still pending.</a:t>
+              <a:t>API comparison available. Rubric validation failed. Android test remains open.</a:t>
             </a:r>
           </a:p>
         </p:txBody>
@@ -11335,7 +11335,7 @@
     </p:spTree>
     <p:extLst>
       <p:ext uri="{BB962C8B-B14F-4D97-AF65-F5344CB8AC3E}">
-        <p14:creationId xmlns:p14="http://schemas.microsoft.com/office/powerpoint/2010/main" val="1231511017"/>
+        <p14:creationId xmlns:p14="http://schemas.microsoft.com/office/powerpoint/2010/main" val="2069525781"/>
       </p:ext>
     </p:extLst>
   </p:cSld>
@@ -11366,7 +11366,7 @@
           <p:cNvPr id="17" name="">
             <a:extLst xmlns:a="http://schemas.openxmlformats.org/drawingml/2006/main">
               <a:ext uri="{FF2B5EF4-FFF2-40B4-BE49-F238E27FC236}">
-                <a16:creationId xmlns:a16="http://schemas.microsoft.com/office/drawing/2014/main" id="{CCB5A756-453F-4BE2-88E9-D51D82229235}"/>
+                <a16:creationId xmlns:a16="http://schemas.microsoft.com/office/drawing/2014/main" id="{D063962E-251F-4EFD-849A-EEC56A7B2ED8}"/>
               </a:ext>
             </a:extLst>
           </p:cNvPr>
@@ -11435,7 +11435,7 @@
           <p:cNvPr id="2" name="">
             <a:extLst xmlns:a="http://schemas.openxmlformats.org/drawingml/2006/main">
               <a:ext uri="{FF2B5EF4-FFF2-40B4-BE49-F238E27FC236}">
-                <a16:creationId xmlns:a16="http://schemas.microsoft.com/office/drawing/2014/main" id="{4A36A003-3B47-4E1C-AF27-B32FF8C72615}"/>
+                <a16:creationId xmlns:a16="http://schemas.microsoft.com/office/drawing/2014/main" id="{7F208063-A8AC-4CFB-AA35-8D5328B6C975}"/>
               </a:ext>
             </a:extLst>
           </p:cNvPr>
@@ -11466,7 +11466,7 @@
           <p:cNvPr id="3" name="">
             <a:extLst xmlns:a="http://schemas.openxmlformats.org/drawingml/2006/main">
               <a:ext uri="{FF2B5EF4-FFF2-40B4-BE49-F238E27FC236}">
-                <a16:creationId xmlns:a16="http://schemas.microsoft.com/office/drawing/2014/main" id="{411C3D24-D614-4B13-A96A-80C10A7944F4}"/>
+                <a16:creationId xmlns:a16="http://schemas.microsoft.com/office/drawing/2014/main" id="{68F15E9E-A57F-4E18-B296-6E12F929C5CD}"/>
               </a:ext>
             </a:extLst>
           </p:cNvPr>
@@ -11535,7 +11535,7 @@
           <p:cNvPr id="4" name="">
             <a:extLst xmlns:a="http://schemas.openxmlformats.org/drawingml/2006/main">
               <a:ext uri="{FF2B5EF4-FFF2-40B4-BE49-F238E27FC236}">
-                <a16:creationId xmlns:a16="http://schemas.microsoft.com/office/drawing/2014/main" id="{8145BB15-A2E6-4218-B3B5-D9F888E1591F}"/>
+                <a16:creationId xmlns:a16="http://schemas.microsoft.com/office/drawing/2014/main" id="{5609ADD2-887B-422F-8B0A-C3967FD68B0C}"/>
               </a:ext>
             </a:extLst>
           </p:cNvPr>
@@ -11604,7 +11604,7 @@
           <p:cNvPr id="5" name="">
             <a:extLst xmlns:a="http://schemas.openxmlformats.org/drawingml/2006/main">
               <a:ext uri="{FF2B5EF4-FFF2-40B4-BE49-F238E27FC236}">
-                <a16:creationId xmlns:a16="http://schemas.microsoft.com/office/drawing/2014/main" id="{82BB9C79-E34F-4F83-942B-297F0F475EE7}"/>
+                <a16:creationId xmlns:a16="http://schemas.microsoft.com/office/drawing/2014/main" id="{85226BC0-ADBA-4D1F-A8A3-0E520F40DD71}"/>
               </a:ext>
             </a:extLst>
           </p:cNvPr>
@@ -11673,7 +11673,7 @@
           <p:cNvPr id="6" name="">
             <a:extLst xmlns:a="http://schemas.openxmlformats.org/drawingml/2006/main">
               <a:ext uri="{FF2B5EF4-FFF2-40B4-BE49-F238E27FC236}">
-                <a16:creationId xmlns:a16="http://schemas.microsoft.com/office/drawing/2014/main" id="{E6F5662C-ADDD-4BCF-A9C0-F5F85F86ED10}"/>
+                <a16:creationId xmlns:a16="http://schemas.microsoft.com/office/drawing/2014/main" id="{F2494026-B31A-404A-B825-254E16AB2CCF}"/>
               </a:ext>
             </a:extLst>
           </p:cNvPr>
@@ -11704,7 +11704,7 @@
           <p:cNvPr id="7" name="">
             <a:extLst xmlns:a="http://schemas.openxmlformats.org/drawingml/2006/main">
               <a:ext uri="{FF2B5EF4-FFF2-40B4-BE49-F238E27FC236}">
-                <a16:creationId xmlns:a16="http://schemas.microsoft.com/office/drawing/2014/main" id="{544C6D19-A55D-4DBD-BC22-6A1264DA38EC}"/>
+                <a16:creationId xmlns:a16="http://schemas.microsoft.com/office/drawing/2014/main" id="{BC84E136-F4B4-4380-99BC-740FAB758346}"/>
               </a:ext>
             </a:extLst>
           </p:cNvPr>
@@ -11773,7 +11773,7 @@
           <p:cNvPr id="8" name="">
             <a:extLst xmlns:a="http://schemas.openxmlformats.org/drawingml/2006/main">
               <a:ext uri="{FF2B5EF4-FFF2-40B4-BE49-F238E27FC236}">
-                <a16:creationId xmlns:a16="http://schemas.microsoft.com/office/drawing/2014/main" id="{C1927047-5817-4FEB-843B-042E66F9AB71}"/>
+                <a16:creationId xmlns:a16="http://schemas.microsoft.com/office/drawing/2014/main" id="{45C60099-404F-467A-90CC-CB1A84F42F09}"/>
               </a:ext>
             </a:extLst>
           </p:cNvPr>
@@ -11842,7 +11842,7 @@
           <p:cNvPr id="9" name="">
             <a:extLst xmlns:a="http://schemas.openxmlformats.org/drawingml/2006/main">
               <a:ext uri="{FF2B5EF4-FFF2-40B4-BE49-F238E27FC236}">
-                <a16:creationId xmlns:a16="http://schemas.microsoft.com/office/drawing/2014/main" id="{4EAFCB14-DBA9-400F-9CE1-5E4E6FF693A1}"/>
+                <a16:creationId xmlns:a16="http://schemas.microsoft.com/office/drawing/2014/main" id="{D34C9C92-C4E7-44E4-8713-85D8A89E7635}"/>
               </a:ext>
             </a:extLst>
           </p:cNvPr>
@@ -11873,7 +11873,7 @@
           <p:cNvPr id="10" name="">
             <a:extLst xmlns:a="http://schemas.openxmlformats.org/drawingml/2006/main">
               <a:ext uri="{FF2B5EF4-FFF2-40B4-BE49-F238E27FC236}">
-                <a16:creationId xmlns:a16="http://schemas.microsoft.com/office/drawing/2014/main" id="{DBB8F2F9-B895-44EB-A119-B25474AD2342}"/>
+                <a16:creationId xmlns:a16="http://schemas.microsoft.com/office/drawing/2014/main" id="{3DB145E3-703F-4713-B086-F9F5C92763B1}"/>
               </a:ext>
             </a:extLst>
           </p:cNvPr>
@@ -11942,7 +11942,7 @@
           <p:cNvPr id="11" name="">
             <a:extLst xmlns:a="http://schemas.openxmlformats.org/drawingml/2006/main">
               <a:ext uri="{FF2B5EF4-FFF2-40B4-BE49-F238E27FC236}">
-                <a16:creationId xmlns:a16="http://schemas.microsoft.com/office/drawing/2014/main" id="{6E82F6C3-793C-40DA-B7B7-F83D0ECDBF32}"/>
+                <a16:creationId xmlns:a16="http://schemas.microsoft.com/office/drawing/2014/main" id="{EEA70C2E-9A6E-4541-B337-36B998F02F6F}"/>
               </a:ext>
             </a:extLst>
           </p:cNvPr>
@@ -12011,7 +12011,7 @@
           <p:cNvPr id="12" name="">
             <a:extLst xmlns:a="http://schemas.openxmlformats.org/drawingml/2006/main">
               <a:ext uri="{FF2B5EF4-FFF2-40B4-BE49-F238E27FC236}">
-                <a16:creationId xmlns:a16="http://schemas.microsoft.com/office/drawing/2014/main" id="{5A67D72C-2E58-45EB-A7AE-BE4B5724772D}"/>
+                <a16:creationId xmlns:a16="http://schemas.microsoft.com/office/drawing/2014/main" id="{AD2733A2-913B-4E53-8B7D-70A7E716086A}"/>
               </a:ext>
             </a:extLst>
           </p:cNvPr>
@@ -12042,7 +12042,7 @@
           <p:cNvPr id="13" name="">
             <a:extLst xmlns:a="http://schemas.openxmlformats.org/drawingml/2006/main">
               <a:ext uri="{FF2B5EF4-FFF2-40B4-BE49-F238E27FC236}">
-                <a16:creationId xmlns:a16="http://schemas.microsoft.com/office/drawing/2014/main" id="{97D9D1F2-8E54-40FE-BAFC-E4C2A1103F71}"/>
+                <a16:creationId xmlns:a16="http://schemas.microsoft.com/office/drawing/2014/main" id="{0013EEE3-7A33-4B1F-A94C-ECE2F6C07BD4}"/>
               </a:ext>
             </a:extLst>
           </p:cNvPr>
@@ -12111,7 +12111,7 @@
           <p:cNvPr id="14" name="">
             <a:extLst xmlns:a="http://schemas.openxmlformats.org/drawingml/2006/main">
               <a:ext uri="{FF2B5EF4-FFF2-40B4-BE49-F238E27FC236}">
-                <a16:creationId xmlns:a16="http://schemas.microsoft.com/office/drawing/2014/main" id="{BB23699A-75B5-4FA6-8E90-18A488A0CC82}"/>
+                <a16:creationId xmlns:a16="http://schemas.microsoft.com/office/drawing/2014/main" id="{9CA4AE1E-44F5-4471-A66E-848E03AF7C0F}"/>
               </a:ext>
             </a:extLst>
           </p:cNvPr>
@@ -12180,7 +12180,7 @@
           <p:cNvPr id="15" name="">
             <a:extLst xmlns:a="http://schemas.openxmlformats.org/drawingml/2006/main">
               <a:ext uri="{FF2B5EF4-FFF2-40B4-BE49-F238E27FC236}">
-                <a16:creationId xmlns:a16="http://schemas.microsoft.com/office/drawing/2014/main" id="{A22C0C8A-EF89-4684-9459-59671FE96E24}"/>
+                <a16:creationId xmlns:a16="http://schemas.microsoft.com/office/drawing/2014/main" id="{62ABC768-AC3A-4B96-A54C-560E3375776D}"/>
               </a:ext>
             </a:extLst>
           </p:cNvPr>
@@ -12211,7 +12211,7 @@
           <p:cNvPr id="16" name="">
             <a:extLst xmlns:a="http://schemas.openxmlformats.org/drawingml/2006/main">
               <a:ext uri="{FF2B5EF4-FFF2-40B4-BE49-F238E27FC236}">
-                <a16:creationId xmlns:a16="http://schemas.microsoft.com/office/drawing/2014/main" id="{670175A6-70D0-458F-900D-A67F16E118F6}"/>
+                <a16:creationId xmlns:a16="http://schemas.microsoft.com/office/drawing/2014/main" id="{99703304-5C9A-48AE-A5FB-0ED839788DB5}"/>
               </a:ext>
             </a:extLst>
           </p:cNvPr>
@@ -12270,7 +12270,7 @@
                 <a:ea typeface="Arial"/>
                 <a:cs typeface="Arial"/>
               </a:rPr>
-              <a:t>Draft PR #10 connects the parts. Offline tests pass; live v2 remains to be checked.</a:t>
+              <a:t>PR #10 merged. Live comparison returned; rubric and Android remain open.</a:t>
             </a:r>
           </a:p>
         </p:txBody>
@@ -12278,7 +12278,7 @@
     </p:spTree>
     <p:extLst>
       <p:ext uri="{BB962C8B-B14F-4D97-AF65-F5344CB8AC3E}">
-        <p14:creationId xmlns:p14="http://schemas.microsoft.com/office/powerpoint/2010/main" val="287679998"/>
+        <p14:creationId xmlns:p14="http://schemas.microsoft.com/office/powerpoint/2010/main" val="1189152733"/>
       </p:ext>
     </p:extLst>
   </p:cSld>

</xml_diff>